<commit_message>
docs(product): refresh cross-surface guide materials
</commit_message>
<xml_diff>
--- a/docs/product-guide/self-study-studio-product-deck.pptx
+++ b/docs/product-guide/self-study-studio-product-deck.pptx
@@ -2,130 +2,35 @@
 <file path=ppt/presentation.xml><?xml version="1.0" encoding="utf-8"?>
 <p:presentation xmlns:p="http://schemas.openxmlformats.org/presentationml/2006/main">
   <p:sldMasterIdLst>
-    <p:sldMasterId xmlns:r="http://schemas.openxmlformats.org/officeDocument/2006/relationships" id="2147483648" r:id="R6ad930e73d17418b"/>
+    <p:sldMasterId xmlns:r="http://schemas.openxmlformats.org/officeDocument/2006/relationships" id="2147483648" r:id="R560e9cd28ba54c30"/>
   </p:sldMasterIdLst>
   <p:notesMasterIdLst>
-    <p:notesMasterId xmlns:r="http://schemas.openxmlformats.org/officeDocument/2006/relationships" r:id="R208278a41e9547c4"/>
+    <p:notesMasterId xmlns:r="http://schemas.openxmlformats.org/officeDocument/2006/relationships" r:id="Rb76a25932ca94e2d"/>
   </p:notesMasterIdLst>
   <p:sldIdLst>
-    <p:sldId xmlns:r="http://schemas.openxmlformats.org/officeDocument/2006/relationships" id="256" r:id="Rebbd0ede36014749"/>
-    <p:sldId xmlns:r="http://schemas.openxmlformats.org/officeDocument/2006/relationships" id="257" r:id="R2e0600cf1ef3406c"/>
-    <p:sldId xmlns:r="http://schemas.openxmlformats.org/officeDocument/2006/relationships" id="258" r:id="R237ea43178bb4ec1"/>
-    <p:sldId xmlns:r="http://schemas.openxmlformats.org/officeDocument/2006/relationships" id="259" r:id="R03fd30c0d64a4fd2"/>
-    <p:sldId xmlns:r="http://schemas.openxmlformats.org/officeDocument/2006/relationships" id="260" r:id="R498f82db1a1e42d7"/>
-    <p:sldId xmlns:r="http://schemas.openxmlformats.org/officeDocument/2006/relationships" id="261" r:id="R0d017f4d26f140ee"/>
-    <p:sldId xmlns:r="http://schemas.openxmlformats.org/officeDocument/2006/relationships" id="262" r:id="R2be8bd6161914a77"/>
-    <p:sldId xmlns:r="http://schemas.openxmlformats.org/officeDocument/2006/relationships" id="263" r:id="R5944f61268b144be"/>
-    <p:sldId xmlns:r="http://schemas.openxmlformats.org/officeDocument/2006/relationships" id="264" r:id="R78c3c4f4d3834dbb"/>
-    <p:sldId xmlns:r="http://schemas.openxmlformats.org/officeDocument/2006/relationships" id="265" r:id="Rd5deac234a1a4171"/>
-    <p:sldId xmlns:r="http://schemas.openxmlformats.org/officeDocument/2006/relationships" id="266" r:id="Rb23836555b094467"/>
-    <p:sldId xmlns:r="http://schemas.openxmlformats.org/officeDocument/2006/relationships" id="267" r:id="R8f0b54e538234a22"/>
-    <p:sldId xmlns:r="http://schemas.openxmlformats.org/officeDocument/2006/relationships" id="268" r:id="R975a87f2fe184860"/>
-    <p:sldId xmlns:r="http://schemas.openxmlformats.org/officeDocument/2006/relationships" id="269" r:id="Rf5a7da7df33048aa"/>
-    <p:sldId xmlns:r="http://schemas.openxmlformats.org/officeDocument/2006/relationships" id="270" r:id="R18068438f92c4d65"/>
-    <p:sldId xmlns:r="http://schemas.openxmlformats.org/officeDocument/2006/relationships" id="271" r:id="R8b97187cb0204d73"/>
-    <p:sldId xmlns:r="http://schemas.openxmlformats.org/officeDocument/2006/relationships" id="272" r:id="R4d65fa46c1f74543"/>
-    <p:sldId xmlns:r="http://schemas.openxmlformats.org/officeDocument/2006/relationships" id="273" r:id="R40a38dd3d452402f"/>
-    <p:sldId xmlns:r="http://schemas.openxmlformats.org/officeDocument/2006/relationships" id="274" r:id="R89fa502f1bfa4bc7"/>
-    <p:sldId xmlns:r="http://schemas.openxmlformats.org/officeDocument/2006/relationships" id="275" r:id="R8e64a97d872b4679"/>
+    <p:sldId xmlns:r="http://schemas.openxmlformats.org/officeDocument/2006/relationships" id="256" r:id="R794f1e388c024a4d"/>
+    <p:sldId xmlns:r="http://schemas.openxmlformats.org/officeDocument/2006/relationships" id="257" r:id="Re3bb024c69224738"/>
+    <p:sldId xmlns:r="http://schemas.openxmlformats.org/officeDocument/2006/relationships" id="258" r:id="R22a7f48eff484851"/>
+    <p:sldId xmlns:r="http://schemas.openxmlformats.org/officeDocument/2006/relationships" id="259" r:id="Rf4c2422b0fc74140"/>
+    <p:sldId xmlns:r="http://schemas.openxmlformats.org/officeDocument/2006/relationships" id="260" r:id="R1184c468f84b41fc"/>
+    <p:sldId xmlns:r="http://schemas.openxmlformats.org/officeDocument/2006/relationships" id="261" r:id="Rc378304f98af46d9"/>
+    <p:sldId xmlns:r="http://schemas.openxmlformats.org/officeDocument/2006/relationships" id="262" r:id="R1122379f93724ccf"/>
+    <p:sldId xmlns:r="http://schemas.openxmlformats.org/officeDocument/2006/relationships" id="263" r:id="Re843ed740b384b5a"/>
+    <p:sldId xmlns:r="http://schemas.openxmlformats.org/officeDocument/2006/relationships" id="264" r:id="Rfa3aa543bdd34fef"/>
+    <p:sldId xmlns:r="http://schemas.openxmlformats.org/officeDocument/2006/relationships" id="265" r:id="R34594b61b13a40d9"/>
+    <p:sldId xmlns:r="http://schemas.openxmlformats.org/officeDocument/2006/relationships" id="266" r:id="R513e7c1ce688493c"/>
+    <p:sldId xmlns:r="http://schemas.openxmlformats.org/officeDocument/2006/relationships" id="267" r:id="Rb8a5729778aa48d1"/>
+    <p:sldId xmlns:r="http://schemas.openxmlformats.org/officeDocument/2006/relationships" id="268" r:id="Rb623b1a4fbb94124"/>
+    <p:sldId xmlns:r="http://schemas.openxmlformats.org/officeDocument/2006/relationships" id="269" r:id="R2b9fcf0d102b4c34"/>
+    <p:sldId xmlns:r="http://schemas.openxmlformats.org/officeDocument/2006/relationships" id="270" r:id="Rfcbbd08fa6974c2f"/>
+    <p:sldId xmlns:r="http://schemas.openxmlformats.org/officeDocument/2006/relationships" id="271" r:id="Rd72031bd4e544b8f"/>
+    <p:sldId xmlns:r="http://schemas.openxmlformats.org/officeDocument/2006/relationships" id="272" r:id="Rf7d5366dae904662"/>
+    <p:sldId xmlns:r="http://schemas.openxmlformats.org/officeDocument/2006/relationships" id="273" r:id="R39c41ce19617409d"/>
+    <p:sldId xmlns:r="http://schemas.openxmlformats.org/officeDocument/2006/relationships" id="274" r:id="R69ae19456e6c40bf"/>
+    <p:sldId xmlns:r="http://schemas.openxmlformats.org/officeDocument/2006/relationships" id="275" r:id="Rfa4ace82443e44d5"/>
   </p:sldIdLst>
   <p:sldSz cx="12192000" cy="6858000"/>
   <p:notesSz cx="6858000" cy="9144000"/>
-  <p:defaultTextStyle>
-    <a:defPPr xmlns:a="http://schemas.openxmlformats.org/drawingml/2006/main">
-      <a:defRPr lang="en-US"/>
-    </a:defPPr>
-    <a:lvl1pPr xmlns:a="http://schemas.openxmlformats.org/drawingml/2006/main" marL="0" indent="0" algn="l" defTabSz="914400">
-      <a:defRPr sz="1800" kern="1200">
-        <a:solidFill>
-          <a:schemeClr val="tx1"/>
-        </a:solidFill>
-        <a:latin typeface="+mn-lt"/>
-        <a:ea typeface="+mn-ea"/>
-        <a:cs typeface="+mn-cs"/>
-      </a:defRPr>
-    </a:lvl1pPr>
-    <a:lvl2pPr xmlns:a="http://schemas.openxmlformats.org/drawingml/2006/main" marL="457200" indent="0" algn="l" defTabSz="914400">
-      <a:defRPr sz="1800" kern="1200">
-        <a:solidFill>
-          <a:schemeClr val="tx1"/>
-        </a:solidFill>
-        <a:latin typeface="+mn-lt"/>
-        <a:ea typeface="+mn-ea"/>
-        <a:cs typeface="+mn-cs"/>
-      </a:defRPr>
-    </a:lvl2pPr>
-    <a:lvl3pPr xmlns:a="http://schemas.openxmlformats.org/drawingml/2006/main" marL="914400" indent="0" algn="l" defTabSz="914400">
-      <a:defRPr sz="1800" kern="1200">
-        <a:solidFill>
-          <a:schemeClr val="tx1"/>
-        </a:solidFill>
-        <a:latin typeface="+mn-lt"/>
-        <a:ea typeface="+mn-ea"/>
-        <a:cs typeface="+mn-cs"/>
-      </a:defRPr>
-    </a:lvl3pPr>
-    <a:lvl4pPr xmlns:a="http://schemas.openxmlformats.org/drawingml/2006/main" marL="1371600" indent="0" algn="l" defTabSz="914400">
-      <a:defRPr sz="1800" kern="1200">
-        <a:solidFill>
-          <a:schemeClr val="tx1"/>
-        </a:solidFill>
-        <a:latin typeface="+mn-lt"/>
-        <a:ea typeface="+mn-ea"/>
-        <a:cs typeface="+mn-cs"/>
-      </a:defRPr>
-    </a:lvl4pPr>
-    <a:lvl5pPr xmlns:a="http://schemas.openxmlformats.org/drawingml/2006/main" marL="1828800" indent="0" algn="l" defTabSz="914400">
-      <a:defRPr sz="1800" kern="1200">
-        <a:solidFill>
-          <a:schemeClr val="tx1"/>
-        </a:solidFill>
-        <a:latin typeface="+mn-lt"/>
-        <a:ea typeface="+mn-ea"/>
-        <a:cs typeface="+mn-cs"/>
-      </a:defRPr>
-    </a:lvl5pPr>
-    <a:lvl6pPr xmlns:a="http://schemas.openxmlformats.org/drawingml/2006/main" marL="2286000" indent="0" algn="l" defTabSz="914400">
-      <a:defRPr sz="1800" kern="1200">
-        <a:solidFill>
-          <a:schemeClr val="tx1"/>
-        </a:solidFill>
-        <a:latin typeface="+mn-lt"/>
-        <a:ea typeface="+mn-ea"/>
-        <a:cs typeface="+mn-cs"/>
-      </a:defRPr>
-    </a:lvl6pPr>
-    <a:lvl7pPr xmlns:a="http://schemas.openxmlformats.org/drawingml/2006/main" marL="2743200" indent="0" algn="l" defTabSz="914400">
-      <a:defRPr sz="1800" kern="1200">
-        <a:solidFill>
-          <a:schemeClr val="tx1"/>
-        </a:solidFill>
-        <a:latin typeface="+mn-lt"/>
-        <a:ea typeface="+mn-ea"/>
-        <a:cs typeface="+mn-cs"/>
-      </a:defRPr>
-    </a:lvl7pPr>
-    <a:lvl8pPr xmlns:a="http://schemas.openxmlformats.org/drawingml/2006/main" marL="3200400" indent="0" algn="l" defTabSz="914400">
-      <a:defRPr sz="1800" kern="1200">
-        <a:solidFill>
-          <a:schemeClr val="tx1"/>
-        </a:solidFill>
-        <a:latin typeface="+mn-lt"/>
-        <a:ea typeface="+mn-ea"/>
-        <a:cs typeface="+mn-cs"/>
-      </a:defRPr>
-    </a:lvl8pPr>
-    <a:lvl9pPr xmlns:a="http://schemas.openxmlformats.org/drawingml/2006/main" marL="3657600" indent="0" algn="l" defTabSz="914400">
-      <a:defRPr sz="1800" kern="1200">
-        <a:solidFill>
-          <a:schemeClr val="tx1"/>
-        </a:solidFill>
-        <a:latin typeface="+mn-lt"/>
-        <a:ea typeface="+mn-ea"/>
-        <a:cs typeface="+mn-cs"/>
-      </a:defRPr>
-    </a:lvl9pPr>
-  </p:defaultTextStyle>
 </p:presentation>
 </file>
 
@@ -1874,7 +1779,7 @@
   </p:cSld>
   <p:clrMap bg1="lt1" tx1="dk1" bg2="lt2" tx2="dk2" accent1="accent1" accent2="accent2" accent3="accent3" accent4="accent4" accent5="accent5" accent6="accent6" hlink="hlink" folHlink="folHlink"/>
   <p:sldLayoutIdLst>
-    <p:sldLayoutId xmlns:r="http://schemas.openxmlformats.org/officeDocument/2006/relationships" id="2147483649" r:id="Rb5e8444d3f8245a8"/>
+    <p:sldLayoutId xmlns:r="http://schemas.openxmlformats.org/officeDocument/2006/relationships" id="2147483649" r:id="R17922994febc47bc"/>
   </p:sldLayoutIdLst>
   <p:txStyles>
     <p:titleStyle>
@@ -2422,10 +2327,10 @@
       </p:grpSpPr>
       <p:sp>
         <p:nvSpPr>
-          <p:cNvPr id="1" name="">
-            <a:extLst xmlns:a="http://schemas.openxmlformats.org/drawingml/2006/main">
-              <a:ext uri="{FF2B5EF4-FFF2-40B4-BE49-F238E27FC236}">
-                <a16:creationId xmlns:a16="http://schemas.microsoft.com/office/drawing/2014/main" id="{DCD1B1BE-F608-4655-A75C-DA5956DB8AFC}"/>
+          <p:cNvPr id="7" name="">
+            <a:extLst xmlns:a="http://schemas.openxmlformats.org/drawingml/2006/main">
+              <a:ext uri="{FF2B5EF4-FFF2-40B4-BE49-F238E27FC236}">
+                <a16:creationId xmlns:a16="http://schemas.microsoft.com/office/drawing/2014/main" id="{1F0086A4-1DDA-45D4-A691-ACD9CD457BEF}"/>
               </a:ext>
             </a:extLst>
           </p:cNvPr>
@@ -2475,7 +2380,7 @@
           <p:cNvPr id="2" name="cover-title">
             <a:extLst xmlns:a="http://schemas.openxmlformats.org/drawingml/2006/main">
               <a:ext uri="{FF2B5EF4-FFF2-40B4-BE49-F238E27FC236}">
-                <a16:creationId xmlns:a16="http://schemas.microsoft.com/office/drawing/2014/main" id="{EDA6468B-C7FE-4CDA-94F1-336B67806752}"/>
+                <a16:creationId xmlns:a16="http://schemas.microsoft.com/office/drawing/2014/main" id="{E5621CEE-2BD7-48FA-B2D4-DDEBB6969A30}"/>
               </a:ext>
             </a:extLst>
           </p:cNvPr>
@@ -2542,7 +2447,7 @@
           <p:cNvPr id="3" name="">
             <a:extLst xmlns:a="http://schemas.openxmlformats.org/drawingml/2006/main">
               <a:ext uri="{FF2B5EF4-FFF2-40B4-BE49-F238E27FC236}">
-                <a16:creationId xmlns:a16="http://schemas.microsoft.com/office/drawing/2014/main" id="{B0F93ED9-F419-4ACB-8798-44E364CC5DF7}"/>
+                <a16:creationId xmlns:a16="http://schemas.microsoft.com/office/drawing/2014/main" id="{9FFBC0BC-5C0B-42AF-A0E3-F9F902D589F9}"/>
               </a:ext>
             </a:extLst>
           </p:cNvPr>
@@ -2582,7 +2487,7 @@
                   <a:srgbClr val="6F6C76"/>
                 </a:solidFill>
               </a:rPr>
-              <a:t>一个帮助个人学习者把行动、证据和复盘串成下一步决定的本地优先学习日志。</a:t>
+              <a:t>一个帮助个人学习者把行动、证据和复盘串成下一步决定的学习日志，并把同一份 Journal 连接到 iPhone 与 Web Workspace。</a:t>
             </a:r>
           </a:p>
         </p:txBody>
@@ -2592,7 +2497,7 @@
           <p:cNvPr id="4" name="">
             <a:extLst xmlns:a="http://schemas.openxmlformats.org/drawingml/2006/main">
               <a:ext uri="{FF2B5EF4-FFF2-40B4-BE49-F238E27FC236}">
-                <a16:creationId xmlns:a16="http://schemas.microsoft.com/office/drawing/2014/main" id="{D5A27617-6CC4-4E72-84CA-8325453D736B}"/>
+                <a16:creationId xmlns:a16="http://schemas.microsoft.com/office/drawing/2014/main" id="{718E2340-F222-4BEC-9B85-F24FA0BDDDF8}"/>
               </a:ext>
             </a:extLst>
           </p:cNvPr>
@@ -2625,7 +2530,7 @@
           <p:cNvPr id="5" name="">
             <a:extLst xmlns:a="http://schemas.openxmlformats.org/drawingml/2006/main">
               <a:ext uri="{FF2B5EF4-FFF2-40B4-BE49-F238E27FC236}">
-                <a16:creationId xmlns:a16="http://schemas.microsoft.com/office/drawing/2014/main" id="{39F63063-5A24-424E-AE11-8BFD67F11FB2}"/>
+                <a16:creationId xmlns:a16="http://schemas.microsoft.com/office/drawing/2014/main" id="{B49E350F-83EA-4FCC-8977-7A30241589B4}"/>
               </a:ext>
             </a:extLst>
           </p:cNvPr>
@@ -2777,7 +2682,7 @@
           <p:cNvPr id="6" name="">
             <a:extLst xmlns:a="http://schemas.openxmlformats.org/drawingml/2006/main">
               <a:ext uri="{FF2B5EF4-FFF2-40B4-BE49-F238E27FC236}">
-                <a16:creationId xmlns:a16="http://schemas.microsoft.com/office/drawing/2014/main" id="{E49731AC-7252-4650-98D9-61888A954AE9}"/>
+                <a16:creationId xmlns:a16="http://schemas.microsoft.com/office/drawing/2014/main" id="{BBDD182F-CD43-4507-AA0A-801769C7F9BE}"/>
               </a:ext>
             </a:extLst>
           </p:cNvPr>
@@ -2817,7 +2722,7 @@
                   <a:srgbClr val="6F6C76"/>
                 </a:solidFill>
               </a:rPr>
-              <a:t>产品功能说明 · v1.0 · 2026-07-13</a:t>
+              <a:t>产品功能说明 · v1.3 · 2026-08-09</a:t>
             </a:r>
           </a:p>
         </p:txBody>
@@ -2825,7 +2730,7 @@
     </p:spTree>
     <p:extLst>
       <p:ext uri="{BB962C8B-B14F-4D97-AF65-F5344CB8AC3E}">
-        <p14:creationId xmlns:p14="http://schemas.microsoft.com/office/powerpoint/2010/main" val="1063126641"/>
+        <p14:creationId xmlns:p14="http://schemas.microsoft.com/office/powerpoint/2010/main" val="635023537"/>
       </p:ext>
     </p:extLst>
   </p:cSld>
@@ -2853,10 +2758,10 @@
       </p:grpSpPr>
       <p:sp>
         <p:nvSpPr>
-          <p:cNvPr id="1" name="">
-            <a:extLst xmlns:a="http://schemas.openxmlformats.org/drawingml/2006/main">
-              <a:ext uri="{FF2B5EF4-FFF2-40B4-BE49-F238E27FC236}">
-                <a16:creationId xmlns:a16="http://schemas.microsoft.com/office/drawing/2014/main" id="{BB5660E3-11D6-4A43-A504-94FF7E458486}"/>
+          <p:cNvPr id="10" name="">
+            <a:extLst xmlns:a="http://schemas.openxmlformats.org/drawingml/2006/main">
+              <a:ext uri="{FF2B5EF4-FFF2-40B4-BE49-F238E27FC236}">
+                <a16:creationId xmlns:a16="http://schemas.microsoft.com/office/drawing/2014/main" id="{DF2968C2-5D59-48A6-A0AE-F113BFAE40E3}"/>
               </a:ext>
             </a:extLst>
           </p:cNvPr>
@@ -2906,7 +2811,7 @@
           <p:cNvPr id="2" name="wide-title-10">
             <a:extLst xmlns:a="http://schemas.openxmlformats.org/drawingml/2006/main">
               <a:ext uri="{FF2B5EF4-FFF2-40B4-BE49-F238E27FC236}">
-                <a16:creationId xmlns:a16="http://schemas.microsoft.com/office/drawing/2014/main" id="{1AC64B58-6406-4440-817E-87AEFAC1D32D}"/>
+                <a16:creationId xmlns:a16="http://schemas.microsoft.com/office/drawing/2014/main" id="{C40D1557-5A5A-4F7A-BC09-9A2DC5EA0E0A}"/>
               </a:ext>
             </a:extLst>
           </p:cNvPr>
@@ -2956,7 +2861,7 @@
           <p:cNvPr id="3" name="">
             <a:extLst xmlns:a="http://schemas.openxmlformats.org/drawingml/2006/main">
               <a:ext uri="{FF2B5EF4-FFF2-40B4-BE49-F238E27FC236}">
-                <a16:creationId xmlns:a16="http://schemas.microsoft.com/office/drawing/2014/main" id="{190DFFAA-E118-40C3-9872-854C16A1DEB8}"/>
+                <a16:creationId xmlns:a16="http://schemas.microsoft.com/office/drawing/2014/main" id="{106AE194-09D3-4AD4-9306-38F3D5431E15}"/>
               </a:ext>
             </a:extLst>
           </p:cNvPr>
@@ -3006,7 +2911,7 @@
           <p:cNvPr id="4" name="">
             <a:extLst xmlns:a="http://schemas.openxmlformats.org/drawingml/2006/main">
               <a:ext uri="{FF2B5EF4-FFF2-40B4-BE49-F238E27FC236}">
-                <a16:creationId xmlns:a16="http://schemas.microsoft.com/office/drawing/2014/main" id="{9BB5C089-690D-4B7F-B09F-1AA0CB794B4A}"/>
+                <a16:creationId xmlns:a16="http://schemas.microsoft.com/office/drawing/2014/main" id="{88B55A6B-F2D7-4F38-9AA4-4DB12FDB52D4}"/>
               </a:ext>
             </a:extLst>
           </p:cNvPr>
@@ -3045,7 +2950,7 @@
           <p:nvPr/>
         </p:nvPicPr>
         <p:blipFill>
-          <a:blip xmlns:r="http://schemas.openxmlformats.org/officeDocument/2006/relationships" xmlns:a="http://schemas.openxmlformats.org/drawingml/2006/main" r:embed="R17697fbd2cc145e8"/>
+          <a:blip xmlns:r="http://schemas.openxmlformats.org/officeDocument/2006/relationships" xmlns:a="http://schemas.openxmlformats.org/drawingml/2006/main" r:embed="R41da4a00e55e40c0"/>
           <a:stretch xmlns:a="http://schemas.openxmlformats.org/drawingml/2006/main"/>
         </p:blipFill>
         <p:spPr>
@@ -3069,7 +2974,7 @@
           <p:nvPr/>
         </p:nvPicPr>
         <p:blipFill>
-          <a:blip xmlns:r="http://schemas.openxmlformats.org/officeDocument/2006/relationships" xmlns:a="http://schemas.openxmlformats.org/drawingml/2006/main" r:embed="Reccbbaae0f294d23"/>
+          <a:blip xmlns:r="http://schemas.openxmlformats.org/officeDocument/2006/relationships" xmlns:a="http://schemas.openxmlformats.org/drawingml/2006/main" r:embed="R7a904129b32c4215"/>
           <a:stretch xmlns:a="http://schemas.openxmlformats.org/drawingml/2006/main"/>
         </p:blipFill>
         <p:spPr>
@@ -3089,7 +2994,7 @@
           <p:cNvPr id="7" name="">
             <a:extLst xmlns:a="http://schemas.openxmlformats.org/drawingml/2006/main">
               <a:ext uri="{FF2B5EF4-FFF2-40B4-BE49-F238E27FC236}">
-                <a16:creationId xmlns:a16="http://schemas.microsoft.com/office/drawing/2014/main" id="{052281AD-C6A0-4FE4-8844-06796B0FD7C2}"/>
+                <a16:creationId xmlns:a16="http://schemas.microsoft.com/office/drawing/2014/main" id="{216D4B15-72C8-4815-8815-B66D94727744}"/>
               </a:ext>
             </a:extLst>
           </p:cNvPr>
@@ -3128,13 +3033,13 @@
           <p:nvPr/>
         </p:nvPicPr>
         <p:blipFill>
-          <a:blip xmlns:r="http://schemas.openxmlformats.org/officeDocument/2006/relationships" xmlns:a="http://schemas.openxmlformats.org/drawingml/2006/main" r:embed="R1fe7918653f540bf"/>
+          <a:blip xmlns:r="http://schemas.openxmlformats.org/officeDocument/2006/relationships" xmlns:a="http://schemas.openxmlformats.org/drawingml/2006/main" r:embed="R63c592b6eab746bd"/>
           <a:stretch xmlns:a="http://schemas.openxmlformats.org/drawingml/2006/main"/>
         </p:blipFill>
         <p:spPr>
           <a:xfrm xmlns:a="http://schemas.openxmlformats.org/drawingml/2006/main">
-            <a:off x="7554060" y="1809750"/>
-            <a:ext cx="2227380" cy="3390900"/>
+            <a:off x="7517047" y="1809750"/>
+            <a:ext cx="2301405" cy="3390900"/>
           </a:xfrm>
           <a:prstGeom xmlns:a="http://schemas.openxmlformats.org/drawingml/2006/main" prst="rect">
             <a:avLst/>
@@ -3146,7 +3051,7 @@
           <p:cNvPr id="9" name="">
             <a:extLst xmlns:a="http://schemas.openxmlformats.org/drawingml/2006/main">
               <a:ext uri="{FF2B5EF4-FFF2-40B4-BE49-F238E27FC236}">
-                <a16:creationId xmlns:a16="http://schemas.microsoft.com/office/drawing/2014/main" id="{55201A46-684C-45DE-BC10-FFEC3DDDD3CF}"/>
+                <a16:creationId xmlns:a16="http://schemas.microsoft.com/office/drawing/2014/main" id="{915C358F-9EC6-4A81-9D04-D1A9EC7E136E}"/>
               </a:ext>
             </a:extLst>
           </p:cNvPr>
@@ -3194,7 +3099,7 @@
     </p:spTree>
     <p:extLst>
       <p:ext uri="{BB962C8B-B14F-4D97-AF65-F5344CB8AC3E}">
-        <p14:creationId xmlns:p14="http://schemas.microsoft.com/office/powerpoint/2010/main" val="216334059"/>
+        <p14:creationId xmlns:p14="http://schemas.microsoft.com/office/powerpoint/2010/main" val="1186020428"/>
       </p:ext>
     </p:extLst>
   </p:cSld>
@@ -3222,10 +3127,10 @@
       </p:grpSpPr>
       <p:sp>
         <p:nvSpPr>
-          <p:cNvPr id="1" name="">
-            <a:extLst xmlns:a="http://schemas.openxmlformats.org/drawingml/2006/main">
-              <a:ext uri="{FF2B5EF4-FFF2-40B4-BE49-F238E27FC236}">
-                <a16:creationId xmlns:a16="http://schemas.microsoft.com/office/drawing/2014/main" id="{4154D664-94C5-4653-9647-F0BE4F37855E}"/>
+          <p:cNvPr id="14" name="">
+            <a:extLst xmlns:a="http://schemas.openxmlformats.org/drawingml/2006/main">
+              <a:ext uri="{FF2B5EF4-FFF2-40B4-BE49-F238E27FC236}">
+                <a16:creationId xmlns:a16="http://schemas.microsoft.com/office/drawing/2014/main" id="{AD580673-CA0C-42B3-BE33-7926A2CD521B}"/>
               </a:ext>
             </a:extLst>
           </p:cNvPr>
@@ -3275,7 +3180,7 @@
           <p:cNvPr id="2" name="wide-title-11">
             <a:extLst xmlns:a="http://schemas.openxmlformats.org/drawingml/2006/main">
               <a:ext uri="{FF2B5EF4-FFF2-40B4-BE49-F238E27FC236}">
-                <a16:creationId xmlns:a16="http://schemas.microsoft.com/office/drawing/2014/main" id="{16B5800E-D78F-48F7-8A92-527E90651288}"/>
+                <a16:creationId xmlns:a16="http://schemas.microsoft.com/office/drawing/2014/main" id="{03265B17-7259-46A5-A5BF-43FD76B49372}"/>
               </a:ext>
             </a:extLst>
           </p:cNvPr>
@@ -3325,7 +3230,7 @@
           <p:cNvPr id="3" name="">
             <a:extLst xmlns:a="http://schemas.openxmlformats.org/drawingml/2006/main">
               <a:ext uri="{FF2B5EF4-FFF2-40B4-BE49-F238E27FC236}">
-                <a16:creationId xmlns:a16="http://schemas.microsoft.com/office/drawing/2014/main" id="{AE56AB65-0240-4F7F-A9FE-0113CCC4D969}"/>
+                <a16:creationId xmlns:a16="http://schemas.microsoft.com/office/drawing/2014/main" id="{F6D8AA65-1461-4186-B152-A1429302E2C6}"/>
               </a:ext>
             </a:extLst>
           </p:cNvPr>
@@ -3375,7 +3280,7 @@
           <p:cNvPr id="4" name="">
             <a:extLst xmlns:a="http://schemas.openxmlformats.org/drawingml/2006/main">
               <a:ext uri="{FF2B5EF4-FFF2-40B4-BE49-F238E27FC236}">
-                <a16:creationId xmlns:a16="http://schemas.microsoft.com/office/drawing/2014/main" id="{E3536B8E-F47E-4678-945D-83F5C987497B}"/>
+                <a16:creationId xmlns:a16="http://schemas.microsoft.com/office/drawing/2014/main" id="{7E8F9C89-137E-4C09-9E2E-E258E95DEEBE}"/>
               </a:ext>
             </a:extLst>
           </p:cNvPr>
@@ -3414,7 +3319,7 @@
           <p:nvPr/>
         </p:nvPicPr>
         <p:blipFill>
-          <a:blip xmlns:r="http://schemas.openxmlformats.org/officeDocument/2006/relationships" xmlns:a="http://schemas.openxmlformats.org/drawingml/2006/main" r:embed="R9861e69d728947df"/>
+          <a:blip xmlns:r="http://schemas.openxmlformats.org/officeDocument/2006/relationships" xmlns:a="http://schemas.openxmlformats.org/drawingml/2006/main" r:embed="R00fdcebca5ea4dba"/>
           <a:stretch xmlns:a="http://schemas.openxmlformats.org/drawingml/2006/main"/>
         </p:blipFill>
         <p:spPr>
@@ -3434,7 +3339,7 @@
           <p:cNvPr id="6" name="">
             <a:extLst xmlns:a="http://schemas.openxmlformats.org/drawingml/2006/main">
               <a:ext uri="{FF2B5EF4-FFF2-40B4-BE49-F238E27FC236}">
-                <a16:creationId xmlns:a16="http://schemas.microsoft.com/office/drawing/2014/main" id="{F730AA4A-FE27-481A-9433-055F505C2C6A}"/>
+                <a16:creationId xmlns:a16="http://schemas.microsoft.com/office/drawing/2014/main" id="{FF7BE604-0949-4315-ADFF-9A81E1852C2E}"/>
               </a:ext>
             </a:extLst>
           </p:cNvPr>
@@ -3465,7 +3370,7 @@
           <p:cNvPr id="7" name="">
             <a:extLst xmlns:a="http://schemas.openxmlformats.org/drawingml/2006/main">
               <a:ext uri="{FF2B5EF4-FFF2-40B4-BE49-F238E27FC236}">
-                <a16:creationId xmlns:a16="http://schemas.microsoft.com/office/drawing/2014/main" id="{EF83AE54-3AC8-405C-8052-95A2E26D66B8}"/>
+                <a16:creationId xmlns:a16="http://schemas.microsoft.com/office/drawing/2014/main" id="{8B39C6FD-FD64-4784-B364-3E6D8B39C0B6}"/>
               </a:ext>
             </a:extLst>
           </p:cNvPr>
@@ -3515,7 +3420,7 @@
           <p:cNvPr id="8" name="">
             <a:extLst xmlns:a="http://schemas.openxmlformats.org/drawingml/2006/main">
               <a:ext uri="{FF2B5EF4-FFF2-40B4-BE49-F238E27FC236}">
-                <a16:creationId xmlns:a16="http://schemas.microsoft.com/office/drawing/2014/main" id="{0C263D2C-2731-4F8F-AF11-94D822C30D85}"/>
+                <a16:creationId xmlns:a16="http://schemas.microsoft.com/office/drawing/2014/main" id="{52EE44AD-F438-46C6-B3CE-CEAB6F46191D}"/>
               </a:ext>
             </a:extLst>
           </p:cNvPr>
@@ -3548,7 +3453,7 @@
           <p:cNvPr id="9" name="">
             <a:extLst xmlns:a="http://schemas.openxmlformats.org/drawingml/2006/main">
               <a:ext uri="{FF2B5EF4-FFF2-40B4-BE49-F238E27FC236}">
-                <a16:creationId xmlns:a16="http://schemas.microsoft.com/office/drawing/2014/main" id="{ED40A933-7DA4-426E-9E52-12DB303B25CF}"/>
+                <a16:creationId xmlns:a16="http://schemas.microsoft.com/office/drawing/2014/main" id="{16561193-AF99-4D2F-9BCD-1BE38296CEB1}"/>
               </a:ext>
             </a:extLst>
           </p:cNvPr>
@@ -3598,7 +3503,7 @@
           <p:cNvPr id="10" name="">
             <a:extLst xmlns:a="http://schemas.openxmlformats.org/drawingml/2006/main">
               <a:ext uri="{FF2B5EF4-FFF2-40B4-BE49-F238E27FC236}">
-                <a16:creationId xmlns:a16="http://schemas.microsoft.com/office/drawing/2014/main" id="{051FEB0E-7CAB-46FE-A640-48342DFDB846}"/>
+                <a16:creationId xmlns:a16="http://schemas.microsoft.com/office/drawing/2014/main" id="{66728A2E-9089-4567-A0F0-A810E2FF3982}"/>
               </a:ext>
             </a:extLst>
           </p:cNvPr>
@@ -3631,7 +3536,7 @@
           <p:cNvPr id="11" name="">
             <a:extLst xmlns:a="http://schemas.openxmlformats.org/drawingml/2006/main">
               <a:ext uri="{FF2B5EF4-FFF2-40B4-BE49-F238E27FC236}">
-                <a16:creationId xmlns:a16="http://schemas.microsoft.com/office/drawing/2014/main" id="{77C20996-8404-448B-9436-A8FCC80DC28D}"/>
+                <a16:creationId xmlns:a16="http://schemas.microsoft.com/office/drawing/2014/main" id="{3ABCAEA0-3200-469A-8A72-FE880504CDDC}"/>
               </a:ext>
             </a:extLst>
           </p:cNvPr>
@@ -3681,7 +3586,7 @@
           <p:cNvPr id="12" name="">
             <a:extLst xmlns:a="http://schemas.openxmlformats.org/drawingml/2006/main">
               <a:ext uri="{FF2B5EF4-FFF2-40B4-BE49-F238E27FC236}">
-                <a16:creationId xmlns:a16="http://schemas.microsoft.com/office/drawing/2014/main" id="{E48BBD8C-0872-4C76-B731-613924678969}"/>
+                <a16:creationId xmlns:a16="http://schemas.microsoft.com/office/drawing/2014/main" id="{2B1AD3AF-5C5E-405C-8AC2-DF96041673DC}"/>
               </a:ext>
             </a:extLst>
           </p:cNvPr>
@@ -3714,7 +3619,7 @@
           <p:cNvPr id="13" name="">
             <a:extLst xmlns:a="http://schemas.openxmlformats.org/drawingml/2006/main">
               <a:ext uri="{FF2B5EF4-FFF2-40B4-BE49-F238E27FC236}">
-                <a16:creationId xmlns:a16="http://schemas.microsoft.com/office/drawing/2014/main" id="{E3F68EC4-355D-400D-BF0C-47EA7FF9CDBF}"/>
+                <a16:creationId xmlns:a16="http://schemas.microsoft.com/office/drawing/2014/main" id="{775C3675-4DB9-4766-AA69-1FC6165889EF}"/>
               </a:ext>
             </a:extLst>
           </p:cNvPr>
@@ -3762,7 +3667,7 @@
     </p:spTree>
     <p:extLst>
       <p:ext uri="{BB962C8B-B14F-4D97-AF65-F5344CB8AC3E}">
-        <p14:creationId xmlns:p14="http://schemas.microsoft.com/office/powerpoint/2010/main" val="2133081056"/>
+        <p14:creationId xmlns:p14="http://schemas.microsoft.com/office/powerpoint/2010/main" val="1998235125"/>
       </p:ext>
     </p:extLst>
   </p:cSld>
@@ -3790,10 +3695,10 @@
       </p:grpSpPr>
       <p:sp>
         <p:nvSpPr>
-          <p:cNvPr id="1" name="">
-            <a:extLst xmlns:a="http://schemas.openxmlformats.org/drawingml/2006/main">
-              <a:ext uri="{FF2B5EF4-FFF2-40B4-BE49-F238E27FC236}">
-                <a16:creationId xmlns:a16="http://schemas.microsoft.com/office/drawing/2014/main" id="{A3FF6971-D065-48CC-950A-738CB4DE9AC7}"/>
+          <p:cNvPr id="7" name="">
+            <a:extLst xmlns:a="http://schemas.openxmlformats.org/drawingml/2006/main">
+              <a:ext uri="{FF2B5EF4-FFF2-40B4-BE49-F238E27FC236}">
+                <a16:creationId xmlns:a16="http://schemas.microsoft.com/office/drawing/2014/main" id="{B6D2C713-82B2-4622-A29B-0B4865E16B85}"/>
               </a:ext>
             </a:extLst>
           </p:cNvPr>
@@ -3843,7 +3748,7 @@
           <p:cNvPr id="2" name="wide-title-12">
             <a:extLst xmlns:a="http://schemas.openxmlformats.org/drawingml/2006/main">
               <a:ext uri="{FF2B5EF4-FFF2-40B4-BE49-F238E27FC236}">
-                <a16:creationId xmlns:a16="http://schemas.microsoft.com/office/drawing/2014/main" id="{5D67D783-46E6-43F2-93A2-4385BC5D2A0A}"/>
+                <a16:creationId xmlns:a16="http://schemas.microsoft.com/office/drawing/2014/main" id="{4466B72D-3783-4733-B8F9-1571FCB9DCA5}"/>
               </a:ext>
             </a:extLst>
           </p:cNvPr>
@@ -3893,7 +3798,7 @@
           <p:cNvPr id="3" name="">
             <a:extLst xmlns:a="http://schemas.openxmlformats.org/drawingml/2006/main">
               <a:ext uri="{FF2B5EF4-FFF2-40B4-BE49-F238E27FC236}">
-                <a16:creationId xmlns:a16="http://schemas.microsoft.com/office/drawing/2014/main" id="{2EE36399-E75C-476E-A500-A36F4F695E8C}"/>
+                <a16:creationId xmlns:a16="http://schemas.microsoft.com/office/drawing/2014/main" id="{1C9BF402-02A3-403D-8064-91AC7F3E31FE}"/>
               </a:ext>
             </a:extLst>
           </p:cNvPr>
@@ -3943,7 +3848,7 @@
           <p:cNvPr id="4" name="">
             <a:extLst xmlns:a="http://schemas.openxmlformats.org/drawingml/2006/main">
               <a:ext uri="{FF2B5EF4-FFF2-40B4-BE49-F238E27FC236}">
-                <a16:creationId xmlns:a16="http://schemas.microsoft.com/office/drawing/2014/main" id="{AD1D3F0A-2686-4875-AC05-26D234EF6765}"/>
+                <a16:creationId xmlns:a16="http://schemas.microsoft.com/office/drawing/2014/main" id="{9D3257B8-E68A-47C3-AB08-87F79894E15E}"/>
               </a:ext>
             </a:extLst>
           </p:cNvPr>
@@ -3982,13 +3887,13 @@
           <p:nvPr/>
         </p:nvPicPr>
         <p:blipFill>
-          <a:blip xmlns:r="http://schemas.openxmlformats.org/officeDocument/2006/relationships" xmlns:a="http://schemas.openxmlformats.org/drawingml/2006/main" r:embed="R4b24d78d9153459f"/>
+          <a:blip xmlns:r="http://schemas.openxmlformats.org/officeDocument/2006/relationships" xmlns:a="http://schemas.openxmlformats.org/drawingml/2006/main" r:embed="R2cbdaa02fb90472b"/>
           <a:stretch xmlns:a="http://schemas.openxmlformats.org/drawingml/2006/main"/>
         </p:blipFill>
         <p:spPr>
           <a:xfrm xmlns:a="http://schemas.openxmlformats.org/drawingml/2006/main">
-            <a:off x="4947479" y="1695450"/>
-            <a:ext cx="2297041" cy="4000500"/>
+            <a:off x="5355130" y="1695450"/>
+            <a:ext cx="1481741" cy="4000500"/>
           </a:xfrm>
           <a:prstGeom xmlns:a="http://schemas.openxmlformats.org/drawingml/2006/main" prst="rect">
             <a:avLst/>
@@ -4000,7 +3905,7 @@
           <p:cNvPr id="6" name="">
             <a:extLst xmlns:a="http://schemas.openxmlformats.org/drawingml/2006/main">
               <a:ext uri="{FF2B5EF4-FFF2-40B4-BE49-F238E27FC236}">
-                <a16:creationId xmlns:a16="http://schemas.microsoft.com/office/drawing/2014/main" id="{4420C906-6AFF-4EDB-A794-5F98007952BD}"/>
+                <a16:creationId xmlns:a16="http://schemas.microsoft.com/office/drawing/2014/main" id="{92C4DCE0-6B95-4F7C-A44F-B656EB60F904}"/>
               </a:ext>
             </a:extLst>
           </p:cNvPr>
@@ -4048,7 +3953,7 @@
     </p:spTree>
     <p:extLst>
       <p:ext uri="{BB962C8B-B14F-4D97-AF65-F5344CB8AC3E}">
-        <p14:creationId xmlns:p14="http://schemas.microsoft.com/office/powerpoint/2010/main" val="1211040631"/>
+        <p14:creationId xmlns:p14="http://schemas.microsoft.com/office/powerpoint/2010/main" val="1449137614"/>
       </p:ext>
     </p:extLst>
   </p:cSld>
@@ -4076,10 +3981,10 @@
       </p:grpSpPr>
       <p:sp>
         <p:nvSpPr>
-          <p:cNvPr id="1" name="">
-            <a:extLst xmlns:a="http://schemas.openxmlformats.org/drawingml/2006/main">
-              <a:ext uri="{FF2B5EF4-FFF2-40B4-BE49-F238E27FC236}">
-                <a16:creationId xmlns:a16="http://schemas.microsoft.com/office/drawing/2014/main" id="{5B1001F4-11F8-4CA5-AD4D-60E8C5FC2570}"/>
+          <p:cNvPr id="15" name="">
+            <a:extLst xmlns:a="http://schemas.openxmlformats.org/drawingml/2006/main">
+              <a:ext uri="{FF2B5EF4-FFF2-40B4-BE49-F238E27FC236}">
+                <a16:creationId xmlns:a16="http://schemas.microsoft.com/office/drawing/2014/main" id="{D19FADC9-7555-43E7-BF56-5B2A0334323C}"/>
               </a:ext>
             </a:extLst>
           </p:cNvPr>
@@ -4129,7 +4034,7 @@
           <p:cNvPr id="2" name="wide-title-13">
             <a:extLst xmlns:a="http://schemas.openxmlformats.org/drawingml/2006/main">
               <a:ext uri="{FF2B5EF4-FFF2-40B4-BE49-F238E27FC236}">
-                <a16:creationId xmlns:a16="http://schemas.microsoft.com/office/drawing/2014/main" id="{677D2C80-5570-403D-9E07-E2E3F578EE8E}"/>
+                <a16:creationId xmlns:a16="http://schemas.microsoft.com/office/drawing/2014/main" id="{E5D6BFAC-100E-4661-A47D-F77C8360D20A}"/>
               </a:ext>
             </a:extLst>
           </p:cNvPr>
@@ -4179,7 +4084,7 @@
           <p:cNvPr id="3" name="">
             <a:extLst xmlns:a="http://schemas.openxmlformats.org/drawingml/2006/main">
               <a:ext uri="{FF2B5EF4-FFF2-40B4-BE49-F238E27FC236}">
-                <a16:creationId xmlns:a16="http://schemas.microsoft.com/office/drawing/2014/main" id="{0B8092BA-B473-40A9-9EA5-E29E816174E7}"/>
+                <a16:creationId xmlns:a16="http://schemas.microsoft.com/office/drawing/2014/main" id="{979A7B18-1852-4519-8011-DEBA7BF63D54}"/>
               </a:ext>
             </a:extLst>
           </p:cNvPr>
@@ -4229,7 +4134,7 @@
           <p:cNvPr id="4" name="">
             <a:extLst xmlns:a="http://schemas.openxmlformats.org/drawingml/2006/main">
               <a:ext uri="{FF2B5EF4-FFF2-40B4-BE49-F238E27FC236}">
-                <a16:creationId xmlns:a16="http://schemas.microsoft.com/office/drawing/2014/main" id="{92D1EDB5-C81E-4BB4-8872-23BF27EEFC96}"/>
+                <a16:creationId xmlns:a16="http://schemas.microsoft.com/office/drawing/2014/main" id="{2E347050-19CE-47B2-AA9F-394FEEEC9656}"/>
               </a:ext>
             </a:extLst>
           </p:cNvPr>
@@ -4268,7 +4173,7 @@
           <p:nvPr/>
         </p:nvPicPr>
         <p:blipFill>
-          <a:blip xmlns:r="http://schemas.openxmlformats.org/officeDocument/2006/relationships" xmlns:a="http://schemas.openxmlformats.org/drawingml/2006/main" r:embed="Rde34f46d51874727"/>
+          <a:blip xmlns:r="http://schemas.openxmlformats.org/officeDocument/2006/relationships" xmlns:a="http://schemas.openxmlformats.org/drawingml/2006/main" r:embed="R9c856f641f58443f"/>
           <a:stretch xmlns:a="http://schemas.openxmlformats.org/drawingml/2006/main"/>
         </p:blipFill>
         <p:spPr>
@@ -4292,7 +4197,7 @@
           <p:nvPr/>
         </p:nvPicPr>
         <p:blipFill>
-          <a:blip xmlns:r="http://schemas.openxmlformats.org/officeDocument/2006/relationships" xmlns:a="http://schemas.openxmlformats.org/drawingml/2006/main" r:embed="R9002ad39e2844eba"/>
+          <a:blip xmlns:r="http://schemas.openxmlformats.org/officeDocument/2006/relationships" xmlns:a="http://schemas.openxmlformats.org/drawingml/2006/main" r:embed="Rb582121720b84cc4"/>
           <a:stretch xmlns:a="http://schemas.openxmlformats.org/drawingml/2006/main"/>
         </p:blipFill>
         <p:spPr>
@@ -4312,7 +4217,7 @@
           <p:cNvPr id="7" name="">
             <a:extLst xmlns:a="http://schemas.openxmlformats.org/drawingml/2006/main">
               <a:ext uri="{FF2B5EF4-FFF2-40B4-BE49-F238E27FC236}">
-                <a16:creationId xmlns:a16="http://schemas.microsoft.com/office/drawing/2014/main" id="{9C52B588-31DB-4EF8-8FD5-DFF3747F1981}"/>
+                <a16:creationId xmlns:a16="http://schemas.microsoft.com/office/drawing/2014/main" id="{D693C88F-4A28-4EA6-BE81-446D587E47C7}"/>
               </a:ext>
             </a:extLst>
           </p:cNvPr>
@@ -4343,7 +4248,7 @@
           <p:cNvPr id="8" name="">
             <a:extLst xmlns:a="http://schemas.openxmlformats.org/drawingml/2006/main">
               <a:ext uri="{FF2B5EF4-FFF2-40B4-BE49-F238E27FC236}">
-                <a16:creationId xmlns:a16="http://schemas.microsoft.com/office/drawing/2014/main" id="{49811837-E4CE-480C-A449-A1E3D0B9D138}"/>
+                <a16:creationId xmlns:a16="http://schemas.microsoft.com/office/drawing/2014/main" id="{E08685E1-7AE8-470F-AFAB-BC6DE2E1F620}"/>
               </a:ext>
             </a:extLst>
           </p:cNvPr>
@@ -4393,7 +4298,7 @@
           <p:cNvPr id="9" name="">
             <a:extLst xmlns:a="http://schemas.openxmlformats.org/drawingml/2006/main">
               <a:ext uri="{FF2B5EF4-FFF2-40B4-BE49-F238E27FC236}">
-                <a16:creationId xmlns:a16="http://schemas.microsoft.com/office/drawing/2014/main" id="{9DBCA8F0-A8B3-4B54-89F9-76FDA7DD1DAF}"/>
+                <a16:creationId xmlns:a16="http://schemas.microsoft.com/office/drawing/2014/main" id="{810E692F-1DCB-48BF-BC73-634C8527A1E8}"/>
               </a:ext>
             </a:extLst>
           </p:cNvPr>
@@ -4426,7 +4331,7 @@
           <p:cNvPr id="10" name="">
             <a:extLst xmlns:a="http://schemas.openxmlformats.org/drawingml/2006/main">
               <a:ext uri="{FF2B5EF4-FFF2-40B4-BE49-F238E27FC236}">
-                <a16:creationId xmlns:a16="http://schemas.microsoft.com/office/drawing/2014/main" id="{7E07BC66-0C43-4D0C-A7A6-CBB5513A3D42}"/>
+                <a16:creationId xmlns:a16="http://schemas.microsoft.com/office/drawing/2014/main" id="{AD8CB0FC-6377-4055-BCBA-9ED654B0DE51}"/>
               </a:ext>
             </a:extLst>
           </p:cNvPr>
@@ -4476,7 +4381,7 @@
           <p:cNvPr id="11" name="">
             <a:extLst xmlns:a="http://schemas.openxmlformats.org/drawingml/2006/main">
               <a:ext uri="{FF2B5EF4-FFF2-40B4-BE49-F238E27FC236}">
-                <a16:creationId xmlns:a16="http://schemas.microsoft.com/office/drawing/2014/main" id="{D86F706F-EC4C-47A7-8896-F4E5110775D5}"/>
+                <a16:creationId xmlns:a16="http://schemas.microsoft.com/office/drawing/2014/main" id="{B5CAA66F-6273-4C60-BE2D-238FE033F47C}"/>
               </a:ext>
             </a:extLst>
           </p:cNvPr>
@@ -4509,7 +4414,7 @@
           <p:cNvPr id="12" name="">
             <a:extLst xmlns:a="http://schemas.openxmlformats.org/drawingml/2006/main">
               <a:ext uri="{FF2B5EF4-FFF2-40B4-BE49-F238E27FC236}">
-                <a16:creationId xmlns:a16="http://schemas.microsoft.com/office/drawing/2014/main" id="{F18B8A23-7E3F-498B-A5D0-A11B1093CC9A}"/>
+                <a16:creationId xmlns:a16="http://schemas.microsoft.com/office/drawing/2014/main" id="{AC959EBC-9028-418B-BD6E-3FBB8E4329BF}"/>
               </a:ext>
             </a:extLst>
           </p:cNvPr>
@@ -4559,7 +4464,7 @@
           <p:cNvPr id="13" name="">
             <a:extLst xmlns:a="http://schemas.openxmlformats.org/drawingml/2006/main">
               <a:ext uri="{FF2B5EF4-FFF2-40B4-BE49-F238E27FC236}">
-                <a16:creationId xmlns:a16="http://schemas.microsoft.com/office/drawing/2014/main" id="{87688B74-8204-49D0-8C1F-99367EFA6A5F}"/>
+                <a16:creationId xmlns:a16="http://schemas.microsoft.com/office/drawing/2014/main" id="{C08FBF61-F8E6-4C32-B0FC-453981F005B0}"/>
               </a:ext>
             </a:extLst>
           </p:cNvPr>
@@ -4592,7 +4497,7 @@
           <p:cNvPr id="14" name="">
             <a:extLst xmlns:a="http://schemas.openxmlformats.org/drawingml/2006/main">
               <a:ext uri="{FF2B5EF4-FFF2-40B4-BE49-F238E27FC236}">
-                <a16:creationId xmlns:a16="http://schemas.microsoft.com/office/drawing/2014/main" id="{7BBE4B42-3662-47AF-9B3B-771C6B5F1D2D}"/>
+                <a16:creationId xmlns:a16="http://schemas.microsoft.com/office/drawing/2014/main" id="{9450A0DC-7912-4CFB-8B27-E122DE9AEC85}"/>
               </a:ext>
             </a:extLst>
           </p:cNvPr>
@@ -4640,7 +4545,7 @@
     </p:spTree>
     <p:extLst>
       <p:ext uri="{BB962C8B-B14F-4D97-AF65-F5344CB8AC3E}">
-        <p14:creationId xmlns:p14="http://schemas.microsoft.com/office/powerpoint/2010/main" val="1814481333"/>
+        <p14:creationId xmlns:p14="http://schemas.microsoft.com/office/powerpoint/2010/main" val="1086944194"/>
       </p:ext>
     </p:extLst>
   </p:cSld>
@@ -4668,10 +4573,10 @@
       </p:grpSpPr>
       <p:sp>
         <p:nvSpPr>
-          <p:cNvPr id="1" name="">
-            <a:extLst xmlns:a="http://schemas.openxmlformats.org/drawingml/2006/main">
-              <a:ext uri="{FF2B5EF4-FFF2-40B4-BE49-F238E27FC236}">
-                <a16:creationId xmlns:a16="http://schemas.microsoft.com/office/drawing/2014/main" id="{3B7B1489-ABF4-42AD-8DC2-E38FE9AC5FB3}"/>
+          <p:cNvPr id="14" name="">
+            <a:extLst xmlns:a="http://schemas.openxmlformats.org/drawingml/2006/main">
+              <a:ext uri="{FF2B5EF4-FFF2-40B4-BE49-F238E27FC236}">
+                <a16:creationId xmlns:a16="http://schemas.microsoft.com/office/drawing/2014/main" id="{A6A1134E-1326-4292-B903-B3B9B29B6F31}"/>
               </a:ext>
             </a:extLst>
           </p:cNvPr>
@@ -4721,7 +4626,7 @@
           <p:cNvPr id="2" name="wide-title-14">
             <a:extLst xmlns:a="http://schemas.openxmlformats.org/drawingml/2006/main">
               <a:ext uri="{FF2B5EF4-FFF2-40B4-BE49-F238E27FC236}">
-                <a16:creationId xmlns:a16="http://schemas.microsoft.com/office/drawing/2014/main" id="{1E435EA7-69B0-4CD3-8DA8-A3E366340EB4}"/>
+                <a16:creationId xmlns:a16="http://schemas.microsoft.com/office/drawing/2014/main" id="{AA29B3E7-4C4C-407C-B6D7-5BDC660990DB}"/>
               </a:ext>
             </a:extLst>
           </p:cNvPr>
@@ -4771,7 +4676,7 @@
           <p:cNvPr id="3" name="">
             <a:extLst xmlns:a="http://schemas.openxmlformats.org/drawingml/2006/main">
               <a:ext uri="{FF2B5EF4-FFF2-40B4-BE49-F238E27FC236}">
-                <a16:creationId xmlns:a16="http://schemas.microsoft.com/office/drawing/2014/main" id="{7AEA5F67-C6EB-4539-B2E6-0C9E16ECDAD7}"/>
+                <a16:creationId xmlns:a16="http://schemas.microsoft.com/office/drawing/2014/main" id="{1748B9DA-709C-4EA9-B44D-D71E0127BB8C}"/>
               </a:ext>
             </a:extLst>
           </p:cNvPr>
@@ -4821,7 +4726,7 @@
           <p:cNvPr id="4" name="">
             <a:extLst xmlns:a="http://schemas.openxmlformats.org/drawingml/2006/main">
               <a:ext uri="{FF2B5EF4-FFF2-40B4-BE49-F238E27FC236}">
-                <a16:creationId xmlns:a16="http://schemas.microsoft.com/office/drawing/2014/main" id="{BD0216A0-A205-42F9-8268-1D69B6E8CB38}"/>
+                <a16:creationId xmlns:a16="http://schemas.microsoft.com/office/drawing/2014/main" id="{2DAA6772-BD5B-4227-862E-32F37C831700}"/>
               </a:ext>
             </a:extLst>
           </p:cNvPr>
@@ -4860,7 +4765,7 @@
           <p:nvPr/>
         </p:nvPicPr>
         <p:blipFill>
-          <a:blip xmlns:r="http://schemas.openxmlformats.org/officeDocument/2006/relationships" xmlns:a="http://schemas.openxmlformats.org/drawingml/2006/main" r:embed="R26aa636123994bc4"/>
+          <a:blip xmlns:r="http://schemas.openxmlformats.org/officeDocument/2006/relationships" xmlns:a="http://schemas.openxmlformats.org/drawingml/2006/main" r:embed="R2934e8d9e8bd48e9"/>
           <a:stretch xmlns:a="http://schemas.openxmlformats.org/drawingml/2006/main"/>
         </p:blipFill>
         <p:spPr>
@@ -4880,7 +4785,7 @@
           <p:cNvPr id="6" name="">
             <a:extLst xmlns:a="http://schemas.openxmlformats.org/drawingml/2006/main">
               <a:ext uri="{FF2B5EF4-FFF2-40B4-BE49-F238E27FC236}">
-                <a16:creationId xmlns:a16="http://schemas.microsoft.com/office/drawing/2014/main" id="{907C154B-E0F6-40A1-8377-E6489046F625}"/>
+                <a16:creationId xmlns:a16="http://schemas.microsoft.com/office/drawing/2014/main" id="{E23953CC-9F64-4664-A6A5-6D0979A6BCCC}"/>
               </a:ext>
             </a:extLst>
           </p:cNvPr>
@@ -4911,7 +4816,7 @@
           <p:cNvPr id="7" name="">
             <a:extLst xmlns:a="http://schemas.openxmlformats.org/drawingml/2006/main">
               <a:ext uri="{FF2B5EF4-FFF2-40B4-BE49-F238E27FC236}">
-                <a16:creationId xmlns:a16="http://schemas.microsoft.com/office/drawing/2014/main" id="{CA10FD0C-946B-4861-93E3-1625C1A3CA5B}"/>
+                <a16:creationId xmlns:a16="http://schemas.microsoft.com/office/drawing/2014/main" id="{A4D6AD59-5D60-49EF-A921-273614C4AF2C}"/>
               </a:ext>
             </a:extLst>
           </p:cNvPr>
@@ -4961,7 +4866,7 @@
           <p:cNvPr id="8" name="">
             <a:extLst xmlns:a="http://schemas.openxmlformats.org/drawingml/2006/main">
               <a:ext uri="{FF2B5EF4-FFF2-40B4-BE49-F238E27FC236}">
-                <a16:creationId xmlns:a16="http://schemas.microsoft.com/office/drawing/2014/main" id="{4B23AB37-4F89-481F-A3EA-BC9D67F01179}"/>
+                <a16:creationId xmlns:a16="http://schemas.microsoft.com/office/drawing/2014/main" id="{94796247-417A-492D-A1B6-6B66E4B0A294}"/>
               </a:ext>
             </a:extLst>
           </p:cNvPr>
@@ -4994,7 +4899,7 @@
           <p:cNvPr id="9" name="">
             <a:extLst xmlns:a="http://schemas.openxmlformats.org/drawingml/2006/main">
               <a:ext uri="{FF2B5EF4-FFF2-40B4-BE49-F238E27FC236}">
-                <a16:creationId xmlns:a16="http://schemas.microsoft.com/office/drawing/2014/main" id="{540D5385-667C-455F-8B3C-D902A5E06119}"/>
+                <a16:creationId xmlns:a16="http://schemas.microsoft.com/office/drawing/2014/main" id="{03DEED1C-C363-46EB-B7FD-3FC8068A8DDF}"/>
               </a:ext>
             </a:extLst>
           </p:cNvPr>
@@ -5044,7 +4949,7 @@
           <p:cNvPr id="10" name="">
             <a:extLst xmlns:a="http://schemas.openxmlformats.org/drawingml/2006/main">
               <a:ext uri="{FF2B5EF4-FFF2-40B4-BE49-F238E27FC236}">
-                <a16:creationId xmlns:a16="http://schemas.microsoft.com/office/drawing/2014/main" id="{1F8B22D5-14AC-48F6-8816-EF8FF85D5C11}"/>
+                <a16:creationId xmlns:a16="http://schemas.microsoft.com/office/drawing/2014/main" id="{7A93AB5A-4705-4F1E-9AD4-5E650DBF31D2}"/>
               </a:ext>
             </a:extLst>
           </p:cNvPr>
@@ -5077,7 +4982,7 @@
           <p:cNvPr id="11" name="">
             <a:extLst xmlns:a="http://schemas.openxmlformats.org/drawingml/2006/main">
               <a:ext uri="{FF2B5EF4-FFF2-40B4-BE49-F238E27FC236}">
-                <a16:creationId xmlns:a16="http://schemas.microsoft.com/office/drawing/2014/main" id="{73B7B091-F356-435C-92F9-F0041AD2B1C7}"/>
+                <a16:creationId xmlns:a16="http://schemas.microsoft.com/office/drawing/2014/main" id="{FFB0D214-4A04-4B29-9BE3-2390ABD78896}"/>
               </a:ext>
             </a:extLst>
           </p:cNvPr>
@@ -5127,7 +5032,7 @@
           <p:cNvPr id="12" name="">
             <a:extLst xmlns:a="http://schemas.openxmlformats.org/drawingml/2006/main">
               <a:ext uri="{FF2B5EF4-FFF2-40B4-BE49-F238E27FC236}">
-                <a16:creationId xmlns:a16="http://schemas.microsoft.com/office/drawing/2014/main" id="{7A5CAEF1-57A2-46EA-89BC-BAE3E710146E}"/>
+                <a16:creationId xmlns:a16="http://schemas.microsoft.com/office/drawing/2014/main" id="{CF87912E-0751-4F77-B794-201D0722C85A}"/>
               </a:ext>
             </a:extLst>
           </p:cNvPr>
@@ -5160,7 +5065,7 @@
           <p:cNvPr id="13" name="">
             <a:extLst xmlns:a="http://schemas.openxmlformats.org/drawingml/2006/main">
               <a:ext uri="{FF2B5EF4-FFF2-40B4-BE49-F238E27FC236}">
-                <a16:creationId xmlns:a16="http://schemas.microsoft.com/office/drawing/2014/main" id="{38FDC38B-2878-4042-83E6-C7E9A91E9168}"/>
+                <a16:creationId xmlns:a16="http://schemas.microsoft.com/office/drawing/2014/main" id="{7EDCD311-D481-46F4-B1DA-ABAA5F7140E5}"/>
               </a:ext>
             </a:extLst>
           </p:cNvPr>
@@ -5208,7 +5113,7 @@
     </p:spTree>
     <p:extLst>
       <p:ext uri="{BB962C8B-B14F-4D97-AF65-F5344CB8AC3E}">
-        <p14:creationId xmlns:p14="http://schemas.microsoft.com/office/powerpoint/2010/main" val="109962052"/>
+        <p14:creationId xmlns:p14="http://schemas.microsoft.com/office/powerpoint/2010/main" val="2004440770"/>
       </p:ext>
     </p:extLst>
   </p:cSld>
@@ -5236,10 +5141,10 @@
       </p:grpSpPr>
       <p:sp>
         <p:nvSpPr>
-          <p:cNvPr id="1" name="">
-            <a:extLst xmlns:a="http://schemas.openxmlformats.org/drawingml/2006/main">
-              <a:ext uri="{FF2B5EF4-FFF2-40B4-BE49-F238E27FC236}">
-                <a16:creationId xmlns:a16="http://schemas.microsoft.com/office/drawing/2014/main" id="{DCEAAF54-1CFC-4A98-BF65-6729F6D1A51E}"/>
+          <p:cNvPr id="8" name="">
+            <a:extLst xmlns:a="http://schemas.openxmlformats.org/drawingml/2006/main">
+              <a:ext uri="{FF2B5EF4-FFF2-40B4-BE49-F238E27FC236}">
+                <a16:creationId xmlns:a16="http://schemas.microsoft.com/office/drawing/2014/main" id="{66A4E94B-BD8D-4FE5-BC4F-382122725E1C}"/>
               </a:ext>
             </a:extLst>
           </p:cNvPr>
@@ -5289,7 +5194,7 @@
           <p:cNvPr id="2" name="wide-title-15">
             <a:extLst xmlns:a="http://schemas.openxmlformats.org/drawingml/2006/main">
               <a:ext uri="{FF2B5EF4-FFF2-40B4-BE49-F238E27FC236}">
-                <a16:creationId xmlns:a16="http://schemas.microsoft.com/office/drawing/2014/main" id="{650508AF-6301-4C28-961C-50EC8124B78C}"/>
+                <a16:creationId xmlns:a16="http://schemas.microsoft.com/office/drawing/2014/main" id="{1799BFFA-BD37-4A95-9055-719AF17BC3AE}"/>
               </a:ext>
             </a:extLst>
           </p:cNvPr>
@@ -5339,7 +5244,7 @@
           <p:cNvPr id="3" name="">
             <a:extLst xmlns:a="http://schemas.openxmlformats.org/drawingml/2006/main">
               <a:ext uri="{FF2B5EF4-FFF2-40B4-BE49-F238E27FC236}">
-                <a16:creationId xmlns:a16="http://schemas.microsoft.com/office/drawing/2014/main" id="{C6AF26EB-2074-4542-8C10-3A30B5AD7639}"/>
+                <a16:creationId xmlns:a16="http://schemas.microsoft.com/office/drawing/2014/main" id="{0457CFDF-30C5-49B5-9B06-48B62352EE25}"/>
               </a:ext>
             </a:extLst>
           </p:cNvPr>
@@ -5389,7 +5294,7 @@
           <p:cNvPr id="4" name="">
             <a:extLst xmlns:a="http://schemas.openxmlformats.org/drawingml/2006/main">
               <a:ext uri="{FF2B5EF4-FFF2-40B4-BE49-F238E27FC236}">
-                <a16:creationId xmlns:a16="http://schemas.microsoft.com/office/drawing/2014/main" id="{A9AF96E1-BF43-44A9-BB0F-090E86B64524}"/>
+                <a16:creationId xmlns:a16="http://schemas.microsoft.com/office/drawing/2014/main" id="{1AA84887-D82E-4A63-B991-DADA3A3912EC}"/>
               </a:ext>
             </a:extLst>
           </p:cNvPr>
@@ -5428,13 +5333,13 @@
           <p:nvPr/>
         </p:nvPicPr>
         <p:blipFill>
-          <a:blip xmlns:r="http://schemas.openxmlformats.org/officeDocument/2006/relationships" xmlns:a="http://schemas.openxmlformats.org/drawingml/2006/main" r:embed="R4b3cf5f8d1ab4175"/>
+          <a:blip xmlns:r="http://schemas.openxmlformats.org/officeDocument/2006/relationships" xmlns:a="http://schemas.openxmlformats.org/drawingml/2006/main" r:embed="R588877b64bdd49cf"/>
           <a:stretch xmlns:a="http://schemas.openxmlformats.org/drawingml/2006/main"/>
         </p:blipFill>
         <p:spPr>
           <a:xfrm xmlns:a="http://schemas.openxmlformats.org/drawingml/2006/main">
-            <a:off x="3395074" y="1695450"/>
-            <a:ext cx="1820451" cy="4191000"/>
+            <a:off x="3586740" y="1695450"/>
+            <a:ext cx="1437120" cy="4191000"/>
           </a:xfrm>
           <a:prstGeom xmlns:a="http://schemas.openxmlformats.org/drawingml/2006/main" prst="rect">
             <a:avLst/>
@@ -5446,7 +5351,7 @@
           <p:cNvPr id="6" name="">
             <a:extLst xmlns:a="http://schemas.openxmlformats.org/drawingml/2006/main">
               <a:ext uri="{FF2B5EF4-FFF2-40B4-BE49-F238E27FC236}">
-                <a16:creationId xmlns:a16="http://schemas.microsoft.com/office/drawing/2014/main" id="{CEC7A0F5-3575-4975-BCE2-B3DAC3364D33}"/>
+                <a16:creationId xmlns:a16="http://schemas.microsoft.com/office/drawing/2014/main" id="{E474A611-5FF5-4BC3-95A2-42FD21EAB295}"/>
               </a:ext>
             </a:extLst>
           </p:cNvPr>
@@ -5485,7 +5390,7 @@
           <p:nvPr/>
         </p:nvPicPr>
         <p:blipFill>
-          <a:blip xmlns:r="http://schemas.openxmlformats.org/officeDocument/2006/relationships" xmlns:a="http://schemas.openxmlformats.org/drawingml/2006/main" r:embed="R63f464fa670f405c"/>
+          <a:blip xmlns:r="http://schemas.openxmlformats.org/officeDocument/2006/relationships" xmlns:a="http://schemas.openxmlformats.org/drawingml/2006/main" r:embed="Ra9807bb934624364"/>
           <a:stretch xmlns:a="http://schemas.openxmlformats.org/drawingml/2006/main"/>
         </p:blipFill>
         <p:spPr>
@@ -5503,7 +5408,7 @@
     </p:spTree>
     <p:extLst>
       <p:ext uri="{BB962C8B-B14F-4D97-AF65-F5344CB8AC3E}">
-        <p14:creationId xmlns:p14="http://schemas.microsoft.com/office/powerpoint/2010/main" val="1958468411"/>
+        <p14:creationId xmlns:p14="http://schemas.microsoft.com/office/powerpoint/2010/main" val="1970072964"/>
       </p:ext>
     </p:extLst>
   </p:cSld>
@@ -5531,10 +5436,10 @@
       </p:grpSpPr>
       <p:sp>
         <p:nvSpPr>
-          <p:cNvPr id="1" name="">
-            <a:extLst xmlns:a="http://schemas.openxmlformats.org/drawingml/2006/main">
-              <a:ext uri="{FF2B5EF4-FFF2-40B4-BE49-F238E27FC236}">
-                <a16:creationId xmlns:a16="http://schemas.microsoft.com/office/drawing/2014/main" id="{DE500EFC-EFC8-49DA-9969-AB10EFA2750C}"/>
+          <p:cNvPr id="7" name="">
+            <a:extLst xmlns:a="http://schemas.openxmlformats.org/drawingml/2006/main">
+              <a:ext uri="{FF2B5EF4-FFF2-40B4-BE49-F238E27FC236}">
+                <a16:creationId xmlns:a16="http://schemas.microsoft.com/office/drawing/2014/main" id="{948C3D3F-EF56-477C-9164-D54C57411249}"/>
               </a:ext>
             </a:extLst>
           </p:cNvPr>
@@ -5584,7 +5489,7 @@
           <p:cNvPr id="2" name="wide-title-16">
             <a:extLst xmlns:a="http://schemas.openxmlformats.org/drawingml/2006/main">
               <a:ext uri="{FF2B5EF4-FFF2-40B4-BE49-F238E27FC236}">
-                <a16:creationId xmlns:a16="http://schemas.microsoft.com/office/drawing/2014/main" id="{0C68B272-8898-45E2-B9ED-19DB62D96DBE}"/>
+                <a16:creationId xmlns:a16="http://schemas.microsoft.com/office/drawing/2014/main" id="{82402531-BD4B-40F2-AA4A-807A21773953}"/>
               </a:ext>
             </a:extLst>
           </p:cNvPr>
@@ -5634,7 +5539,7 @@
           <p:cNvPr id="3" name="">
             <a:extLst xmlns:a="http://schemas.openxmlformats.org/drawingml/2006/main">
               <a:ext uri="{FF2B5EF4-FFF2-40B4-BE49-F238E27FC236}">
-                <a16:creationId xmlns:a16="http://schemas.microsoft.com/office/drawing/2014/main" id="{1154F326-2834-4F3F-93EB-6D0D70331502}"/>
+                <a16:creationId xmlns:a16="http://schemas.microsoft.com/office/drawing/2014/main" id="{2DD1DCE0-B1D6-4B19-BCD2-92EA79AB5BF7}"/>
               </a:ext>
             </a:extLst>
           </p:cNvPr>
@@ -5684,7 +5589,7 @@
           <p:cNvPr id="4" name="">
             <a:extLst xmlns:a="http://schemas.openxmlformats.org/drawingml/2006/main">
               <a:ext uri="{FF2B5EF4-FFF2-40B4-BE49-F238E27FC236}">
-                <a16:creationId xmlns:a16="http://schemas.microsoft.com/office/drawing/2014/main" id="{19B48D81-9190-40C5-85B8-AB7A7506EF99}"/>
+                <a16:creationId xmlns:a16="http://schemas.microsoft.com/office/drawing/2014/main" id="{052F9B1E-D5E1-4731-9D66-39FBD524744E}"/>
               </a:ext>
             </a:extLst>
           </p:cNvPr>
@@ -5723,13 +5628,13 @@
           <p:nvPr/>
         </p:nvPicPr>
         <p:blipFill>
-          <a:blip xmlns:r="http://schemas.openxmlformats.org/officeDocument/2006/relationships" xmlns:a="http://schemas.openxmlformats.org/drawingml/2006/main" r:embed="R3607a4bd634b4b45"/>
+          <a:blip xmlns:r="http://schemas.openxmlformats.org/officeDocument/2006/relationships" xmlns:a="http://schemas.openxmlformats.org/drawingml/2006/main" r:embed="Rdf94d79fc9564cfb"/>
           <a:stretch xmlns:a="http://schemas.openxmlformats.org/drawingml/2006/main"/>
         </p:blipFill>
         <p:spPr>
           <a:xfrm xmlns:a="http://schemas.openxmlformats.org/drawingml/2006/main">
-            <a:off x="5380314" y="1695450"/>
-            <a:ext cx="1431372" cy="4000500"/>
+            <a:off x="5424169" y="1695450"/>
+            <a:ext cx="1343661" cy="4000500"/>
           </a:xfrm>
           <a:prstGeom xmlns:a="http://schemas.openxmlformats.org/drawingml/2006/main" prst="rect">
             <a:avLst/>
@@ -5741,7 +5646,7 @@
           <p:cNvPr id="6" name="">
             <a:extLst xmlns:a="http://schemas.openxmlformats.org/drawingml/2006/main">
               <a:ext uri="{FF2B5EF4-FFF2-40B4-BE49-F238E27FC236}">
-                <a16:creationId xmlns:a16="http://schemas.microsoft.com/office/drawing/2014/main" id="{C6794297-4D73-49FA-8D96-1002B792322F}"/>
+                <a16:creationId xmlns:a16="http://schemas.microsoft.com/office/drawing/2014/main" id="{5C3762CC-43D8-4BB8-85BD-0A5C40F8A23D}"/>
               </a:ext>
             </a:extLst>
           </p:cNvPr>
@@ -5789,7 +5694,7 @@
     </p:spTree>
     <p:extLst>
       <p:ext uri="{BB962C8B-B14F-4D97-AF65-F5344CB8AC3E}">
-        <p14:creationId xmlns:p14="http://schemas.microsoft.com/office/powerpoint/2010/main" val="2139492983"/>
+        <p14:creationId xmlns:p14="http://schemas.microsoft.com/office/powerpoint/2010/main" val="180594480"/>
       </p:ext>
     </p:extLst>
   </p:cSld>
@@ -5817,10 +5722,10 @@
       </p:grpSpPr>
       <p:sp>
         <p:nvSpPr>
-          <p:cNvPr id="1" name="">
-            <a:extLst xmlns:a="http://schemas.openxmlformats.org/drawingml/2006/main">
-              <a:ext uri="{FF2B5EF4-FFF2-40B4-BE49-F238E27FC236}">
-                <a16:creationId xmlns:a16="http://schemas.microsoft.com/office/drawing/2014/main" id="{5DD503E5-A991-4213-9D2D-9C6EEDE1B1FE}"/>
+          <p:cNvPr id="9" name="">
+            <a:extLst xmlns:a="http://schemas.openxmlformats.org/drawingml/2006/main">
+              <a:ext uri="{FF2B5EF4-FFF2-40B4-BE49-F238E27FC236}">
+                <a16:creationId xmlns:a16="http://schemas.microsoft.com/office/drawing/2014/main" id="{5B171C74-57B3-411E-934A-2E5F3131B20E}"/>
               </a:ext>
             </a:extLst>
           </p:cNvPr>
@@ -5870,7 +5775,7 @@
           <p:cNvPr id="2" name="wide-title-17">
             <a:extLst xmlns:a="http://schemas.openxmlformats.org/drawingml/2006/main">
               <a:ext uri="{FF2B5EF4-FFF2-40B4-BE49-F238E27FC236}">
-                <a16:creationId xmlns:a16="http://schemas.microsoft.com/office/drawing/2014/main" id="{1F1842A8-FA2C-48BA-AAFF-83D9FC661965}"/>
+                <a16:creationId xmlns:a16="http://schemas.microsoft.com/office/drawing/2014/main" id="{492A6DE7-E852-4A61-B229-3ADE024B1F0A}"/>
               </a:ext>
             </a:extLst>
           </p:cNvPr>
@@ -5920,7 +5825,7 @@
           <p:cNvPr id="3" name="">
             <a:extLst xmlns:a="http://schemas.openxmlformats.org/drawingml/2006/main">
               <a:ext uri="{FF2B5EF4-FFF2-40B4-BE49-F238E27FC236}">
-                <a16:creationId xmlns:a16="http://schemas.microsoft.com/office/drawing/2014/main" id="{8D4D844A-0246-4EB1-8AB1-C22E8832D5BF}"/>
+                <a16:creationId xmlns:a16="http://schemas.microsoft.com/office/drawing/2014/main" id="{200252EF-6280-4592-B267-277F272997A3}"/>
               </a:ext>
             </a:extLst>
           </p:cNvPr>
@@ -5970,7 +5875,7 @@
           <p:cNvPr id="4" name="">
             <a:extLst xmlns:a="http://schemas.openxmlformats.org/drawingml/2006/main">
               <a:ext uri="{FF2B5EF4-FFF2-40B4-BE49-F238E27FC236}">
-                <a16:creationId xmlns:a16="http://schemas.microsoft.com/office/drawing/2014/main" id="{EF5966A5-84BD-45ED-AAAC-4B7BB9F9F0D4}"/>
+                <a16:creationId xmlns:a16="http://schemas.microsoft.com/office/drawing/2014/main" id="{C0CE07FD-4B20-406A-9CF8-5CF1AFB62DE6}"/>
               </a:ext>
             </a:extLst>
           </p:cNvPr>
@@ -6009,7 +5914,7 @@
           <p:nvPr/>
         </p:nvPicPr>
         <p:blipFill>
-          <a:blip xmlns:r="http://schemas.openxmlformats.org/officeDocument/2006/relationships" xmlns:a="http://schemas.openxmlformats.org/drawingml/2006/main" r:embed="Rfc0b02fd8d1e4b4d"/>
+          <a:blip xmlns:r="http://schemas.openxmlformats.org/officeDocument/2006/relationships" xmlns:a="http://schemas.openxmlformats.org/drawingml/2006/main" r:embed="R854fc372b5294aed"/>
           <a:stretch xmlns:a="http://schemas.openxmlformats.org/drawingml/2006/main"/>
         </p:blipFill>
         <p:spPr>
@@ -6029,7 +5934,7 @@
           <p:cNvPr id="6" name="">
             <a:extLst xmlns:a="http://schemas.openxmlformats.org/drawingml/2006/main">
               <a:ext uri="{FF2B5EF4-FFF2-40B4-BE49-F238E27FC236}">
-                <a16:creationId xmlns:a16="http://schemas.microsoft.com/office/drawing/2014/main" id="{D4A6D8EB-BF0F-4503-803C-E7D54CAA319D}"/>
+                <a16:creationId xmlns:a16="http://schemas.microsoft.com/office/drawing/2014/main" id="{AF7B9504-E9C1-4B19-B28D-3E615AC49EBF}"/>
               </a:ext>
             </a:extLst>
           </p:cNvPr>
@@ -6068,13 +5973,13 @@
           <p:nvPr/>
         </p:nvPicPr>
         <p:blipFill>
-          <a:blip xmlns:r="http://schemas.openxmlformats.org/officeDocument/2006/relationships" xmlns:a="http://schemas.openxmlformats.org/drawingml/2006/main" r:embed="Re2b7f7e2260f4ccf"/>
+          <a:blip xmlns:r="http://schemas.openxmlformats.org/officeDocument/2006/relationships" xmlns:a="http://schemas.openxmlformats.org/drawingml/2006/main" r:embed="R007d4a5da6554a80"/>
           <a:stretch xmlns:a="http://schemas.openxmlformats.org/drawingml/2006/main"/>
         </p:blipFill>
         <p:spPr>
           <a:xfrm xmlns:a="http://schemas.openxmlformats.org/drawingml/2006/main">
-            <a:off x="6561348" y="1771650"/>
-            <a:ext cx="2555454" cy="3619500"/>
+            <a:off x="6369471" y="1771650"/>
+            <a:ext cx="2939208" cy="3619500"/>
           </a:xfrm>
           <a:prstGeom xmlns:a="http://schemas.openxmlformats.org/drawingml/2006/main" prst="rect">
             <a:avLst/>
@@ -6086,7 +5991,7 @@
           <p:cNvPr id="8" name="">
             <a:extLst xmlns:a="http://schemas.openxmlformats.org/drawingml/2006/main">
               <a:ext uri="{FF2B5EF4-FFF2-40B4-BE49-F238E27FC236}">
-                <a16:creationId xmlns:a16="http://schemas.microsoft.com/office/drawing/2014/main" id="{4FB88F3D-E008-4C3F-97C4-E375B1C5A93D}"/>
+                <a16:creationId xmlns:a16="http://schemas.microsoft.com/office/drawing/2014/main" id="{DA7D2762-F87E-4AB4-A9A3-B67AB6559972}"/>
               </a:ext>
             </a:extLst>
           </p:cNvPr>
@@ -6134,7 +6039,7 @@
     </p:spTree>
     <p:extLst>
       <p:ext uri="{BB962C8B-B14F-4D97-AF65-F5344CB8AC3E}">
-        <p14:creationId xmlns:p14="http://schemas.microsoft.com/office/powerpoint/2010/main" val="1599578563"/>
+        <p14:creationId xmlns:p14="http://schemas.microsoft.com/office/powerpoint/2010/main" val="1579399011"/>
       </p:ext>
     </p:extLst>
   </p:cSld>
@@ -6162,10 +6067,10 @@
       </p:grpSpPr>
       <p:sp>
         <p:nvSpPr>
-          <p:cNvPr id="1" name="">
-            <a:extLst xmlns:a="http://schemas.openxmlformats.org/drawingml/2006/main">
-              <a:ext uri="{FF2B5EF4-FFF2-40B4-BE49-F238E27FC236}">
-                <a16:creationId xmlns:a16="http://schemas.microsoft.com/office/drawing/2014/main" id="{08DCFC3A-748D-4ECD-A2E8-BE17A1B3F4FF}"/>
+          <p:cNvPr id="7" name="">
+            <a:extLst xmlns:a="http://schemas.openxmlformats.org/drawingml/2006/main">
+              <a:ext uri="{FF2B5EF4-FFF2-40B4-BE49-F238E27FC236}">
+                <a16:creationId xmlns:a16="http://schemas.microsoft.com/office/drawing/2014/main" id="{1426495D-B84B-48B5-ACE7-AAB0608FFFCE}"/>
               </a:ext>
             </a:extLst>
           </p:cNvPr>
@@ -6215,7 +6120,7 @@
           <p:cNvPr id="2" name="wide-title-18">
             <a:extLst xmlns:a="http://schemas.openxmlformats.org/drawingml/2006/main">
               <a:ext uri="{FF2B5EF4-FFF2-40B4-BE49-F238E27FC236}">
-                <a16:creationId xmlns:a16="http://schemas.microsoft.com/office/drawing/2014/main" id="{5EDFB217-2830-48D5-ABC1-7D468D43C049}"/>
+                <a16:creationId xmlns:a16="http://schemas.microsoft.com/office/drawing/2014/main" id="{DC55B50F-A987-4CA1-81B6-FBF2684D6D54}"/>
               </a:ext>
             </a:extLst>
           </p:cNvPr>
@@ -6255,7 +6160,7 @@
                   <a:srgbClr val="25242B"/>
                 </a:solidFill>
               </a:rPr>
-              <a:t>一条 CS336 故事可以讲完完整产品闭环</a:t>
+              <a:t>一条 CS336 故事连接 iPhone 与 Web 判断</a:t>
             </a:r>
           </a:p>
         </p:txBody>
@@ -6265,7 +6170,7 @@
           <p:cNvPr id="3" name="">
             <a:extLst xmlns:a="http://schemas.openxmlformats.org/drawingml/2006/main">
               <a:ext uri="{FF2B5EF4-FFF2-40B4-BE49-F238E27FC236}">
-                <a16:creationId xmlns:a16="http://schemas.microsoft.com/office/drawing/2014/main" id="{DA609D73-ED17-4374-B810-8C74BB9A505F}"/>
+                <a16:creationId xmlns:a16="http://schemas.microsoft.com/office/drawing/2014/main" id="{DA4B6CC3-F2E9-4B33-AF48-7863F1D55956}"/>
               </a:ext>
             </a:extLst>
           </p:cNvPr>
@@ -6315,7 +6220,7 @@
           <p:cNvPr id="4" name="">
             <a:extLst xmlns:a="http://schemas.openxmlformats.org/drawingml/2006/main">
               <a:ext uri="{FF2B5EF4-FFF2-40B4-BE49-F238E27FC236}">
-                <a16:creationId xmlns:a16="http://schemas.microsoft.com/office/drawing/2014/main" id="{2F288392-5983-4809-AA2F-E846287EA341}"/>
+                <a16:creationId xmlns:a16="http://schemas.microsoft.com/office/drawing/2014/main" id="{D36EABBA-6DFC-4A31-8AE9-FFA10603FCBB}"/>
               </a:ext>
             </a:extLst>
           </p:cNvPr>
@@ -6354,13 +6259,13 @@
           <p:nvPr/>
         </p:nvPicPr>
         <p:blipFill>
-          <a:blip xmlns:r="http://schemas.openxmlformats.org/officeDocument/2006/relationships" xmlns:a="http://schemas.openxmlformats.org/drawingml/2006/main" r:embed="R7efd8ea7a5214953"/>
+          <a:blip xmlns:r="http://schemas.openxmlformats.org/officeDocument/2006/relationships" xmlns:a="http://schemas.openxmlformats.org/drawingml/2006/main" r:embed="R061a6647e38645dd"/>
           <a:stretch xmlns:a="http://schemas.openxmlformats.org/drawingml/2006/main"/>
         </p:blipFill>
         <p:spPr>
           <a:xfrm xmlns:a="http://schemas.openxmlformats.org/drawingml/2006/main">
-            <a:off x="933450" y="3390301"/>
-            <a:ext cx="10325100" cy="610799"/>
+            <a:off x="933450" y="3276098"/>
+            <a:ext cx="10325100" cy="839204"/>
           </a:xfrm>
           <a:prstGeom xmlns:a="http://schemas.openxmlformats.org/drawingml/2006/main" prst="rect">
             <a:avLst/>
@@ -6372,7 +6277,7 @@
           <p:cNvPr id="6" name="">
             <a:extLst xmlns:a="http://schemas.openxmlformats.org/drawingml/2006/main">
               <a:ext uri="{FF2B5EF4-FFF2-40B4-BE49-F238E27FC236}">
-                <a16:creationId xmlns:a16="http://schemas.microsoft.com/office/drawing/2014/main" id="{7777CA4B-F897-4169-9AC0-87C947862289}"/>
+                <a16:creationId xmlns:a16="http://schemas.microsoft.com/office/drawing/2014/main" id="{442FB2AC-E5F8-4B7A-886F-5DCA94067E83}"/>
               </a:ext>
             </a:extLst>
           </p:cNvPr>
@@ -6412,7 +6317,7 @@
                   <a:srgbClr val="6F6C76"/>
                 </a:solidFill>
               </a:rPr>
-              <a:t>Today → Timer/Quick Log → Proof → Trail → Weekly Review。</a:t>
+              <a:t>Today → Routine/Timer/Quick Log → Proof → Trail → Stage/Weekly Review → guarded Plan decision。</a:t>
             </a:r>
           </a:p>
         </p:txBody>
@@ -6420,7 +6325,7 @@
     </p:spTree>
     <p:extLst>
       <p:ext uri="{BB962C8B-B14F-4D97-AF65-F5344CB8AC3E}">
-        <p14:creationId xmlns:p14="http://schemas.microsoft.com/office/powerpoint/2010/main" val="281771104"/>
+        <p14:creationId xmlns:p14="http://schemas.microsoft.com/office/powerpoint/2010/main" val="978973404"/>
       </p:ext>
     </p:extLst>
   </p:cSld>
@@ -6448,10 +6353,10 @@
       </p:grpSpPr>
       <p:sp>
         <p:nvSpPr>
-          <p:cNvPr id="1" name="">
-            <a:extLst xmlns:a="http://schemas.openxmlformats.org/drawingml/2006/main">
-              <a:ext uri="{FF2B5EF4-FFF2-40B4-BE49-F238E27FC236}">
-                <a16:creationId xmlns:a16="http://schemas.microsoft.com/office/drawing/2014/main" id="{8AF82E9B-F197-47FB-8DBF-72B0AFC57706}"/>
+          <p:cNvPr id="54" name="">
+            <a:extLst xmlns:a="http://schemas.openxmlformats.org/drawingml/2006/main">
+              <a:ext uri="{FF2B5EF4-FFF2-40B4-BE49-F238E27FC236}">
+                <a16:creationId xmlns:a16="http://schemas.microsoft.com/office/drawing/2014/main" id="{8C395055-A3AF-4F91-AF5E-CE1CCE220F6F}"/>
               </a:ext>
             </a:extLst>
           </p:cNvPr>
@@ -6501,7 +6406,7 @@
           <p:cNvPr id="2" name="wide-title-19">
             <a:extLst xmlns:a="http://schemas.openxmlformats.org/drawingml/2006/main">
               <a:ext uri="{FF2B5EF4-FFF2-40B4-BE49-F238E27FC236}">
-                <a16:creationId xmlns:a16="http://schemas.microsoft.com/office/drawing/2014/main" id="{3717D4E4-B6BD-4EE0-B4FA-55D23485AB8A}"/>
+                <a16:creationId xmlns:a16="http://schemas.microsoft.com/office/drawing/2014/main" id="{6DC2B555-913C-4417-9DA8-A817B38D07CC}"/>
               </a:ext>
             </a:extLst>
           </p:cNvPr>
@@ -6541,7 +6446,7 @@
                   <a:srgbClr val="25242B"/>
                 </a:solidFill>
               </a:rPr>
-              <a:t>v0.1 闭环可运行，规划能力不冒充已实现</a:t>
+              <a:t>B1–B6 与 C1/C2 已有本地证据，D1 live gates 单独标注</a:t>
             </a:r>
           </a:p>
         </p:txBody>
@@ -6551,7 +6456,7 @@
           <p:cNvPr id="3" name="">
             <a:extLst xmlns:a="http://schemas.openxmlformats.org/drawingml/2006/main">
               <a:ext uri="{FF2B5EF4-FFF2-40B4-BE49-F238E27FC236}">
-                <a16:creationId xmlns:a16="http://schemas.microsoft.com/office/drawing/2014/main" id="{FB92DF0C-5020-4948-9E5B-9A746A56F86E}"/>
+                <a16:creationId xmlns:a16="http://schemas.microsoft.com/office/drawing/2014/main" id="{1A0BB26C-4A4F-4D54-8575-E921B78A3A03}"/>
               </a:ext>
             </a:extLst>
           </p:cNvPr>
@@ -6601,7 +6506,7 @@
           <p:cNvPr id="4" name="">
             <a:extLst xmlns:a="http://schemas.openxmlformats.org/drawingml/2006/main">
               <a:ext uri="{FF2B5EF4-FFF2-40B4-BE49-F238E27FC236}">
-                <a16:creationId xmlns:a16="http://schemas.microsoft.com/office/drawing/2014/main" id="{5427EB33-9D43-4ECD-8039-0CAF476E604D}"/>
+                <a16:creationId xmlns:a16="http://schemas.microsoft.com/office/drawing/2014/main" id="{08BC266D-39A6-4A7C-A1B0-F626CF132F13}"/>
               </a:ext>
             </a:extLst>
           </p:cNvPr>
@@ -6613,11 +6518,11 @@
         <p:spPr>
           <a:xfrm xmlns:a="http://schemas.openxmlformats.org/drawingml/2006/main">
             <a:off x="704850" y="1562100"/>
-            <a:ext cx="10782300" cy="574221"/>
+            <a:ext cx="10782300" cy="379095"/>
           </a:xfrm>
           <a:prstGeom xmlns:a="http://schemas.openxmlformats.org/drawingml/2006/main" prst="roundRect">
             <a:avLst>
-              <a:gd name="adj" fmla="val 19905"/>
+              <a:gd name="adj" fmla="val 30151"/>
             </a:avLst>
           </a:prstGeom>
           <a:solidFill xmlns:a="http://schemas.openxmlformats.org/drawingml/2006/main">
@@ -6636,7 +6541,7 @@
           <p:cNvPr id="5" name="">
             <a:extLst xmlns:a="http://schemas.openxmlformats.org/drawingml/2006/main">
               <a:ext uri="{FF2B5EF4-FFF2-40B4-BE49-F238E27FC236}">
-                <a16:creationId xmlns:a16="http://schemas.microsoft.com/office/drawing/2014/main" id="{76892451-7708-4798-A779-0BF01AC1A3D6}"/>
+                <a16:creationId xmlns:a16="http://schemas.microsoft.com/office/drawing/2014/main" id="{6625F202-ED21-4522-A6C9-ACA17375C680}"/>
               </a:ext>
             </a:extLst>
           </p:cNvPr>
@@ -6648,11 +6553,11 @@
         <p:spPr>
           <a:xfrm xmlns:a="http://schemas.openxmlformats.org/drawingml/2006/main">
             <a:off x="857250" y="1676400"/>
-            <a:ext cx="990600" cy="345621"/>
+            <a:ext cx="990600" cy="150495"/>
           </a:xfrm>
           <a:prstGeom xmlns:a="http://schemas.openxmlformats.org/drawingml/2006/main" prst="roundRect">
             <a:avLst>
-              <a:gd name="adj" fmla="val 33071"/>
+              <a:gd name="adj" fmla="val 50000"/>
             </a:avLst>
           </a:prstGeom>
           <a:solidFill xmlns:a="http://schemas.openxmlformats.org/drawingml/2006/main">
@@ -6669,7 +6574,7 @@
           <p:cNvPr id="6" name="">
             <a:extLst xmlns:a="http://schemas.openxmlformats.org/drawingml/2006/main">
               <a:ext uri="{FF2B5EF4-FFF2-40B4-BE49-F238E27FC236}">
-                <a16:creationId xmlns:a16="http://schemas.microsoft.com/office/drawing/2014/main" id="{3E9B2DAD-1131-44EC-9AC4-9E0E22788090}"/>
+                <a16:creationId xmlns:a16="http://schemas.microsoft.com/office/drawing/2014/main" id="{7C6C69DB-9C8B-4C88-9AD8-747F1363D90E}"/>
               </a:ext>
             </a:extLst>
           </p:cNvPr>
@@ -6681,7 +6586,7 @@
         <p:spPr>
           <a:xfrm xmlns:a="http://schemas.openxmlformats.org/drawingml/2006/main">
             <a:off x="914400" y="1695450"/>
-            <a:ext cx="876300" cy="307521"/>
+            <a:ext cx="876300" cy="112395"/>
           </a:xfrm>
           <a:prstGeom xmlns:a="http://schemas.openxmlformats.org/drawingml/2006/main" prst="rect">
             <a:avLst/>
@@ -6719,7 +6624,7 @@
           <p:cNvPr id="7" name="">
             <a:extLst xmlns:a="http://schemas.openxmlformats.org/drawingml/2006/main">
               <a:ext uri="{FF2B5EF4-FFF2-40B4-BE49-F238E27FC236}">
-                <a16:creationId xmlns:a16="http://schemas.microsoft.com/office/drawing/2014/main" id="{89214172-D444-441F-A48D-8B1ABDD1D531}"/>
+                <a16:creationId xmlns:a16="http://schemas.microsoft.com/office/drawing/2014/main" id="{9D6CB06E-664E-4205-9F0B-38F86F092DBF}"/>
               </a:ext>
             </a:extLst>
           </p:cNvPr>
@@ -6731,7 +6636,7 @@
         <p:spPr>
           <a:xfrm xmlns:a="http://schemas.openxmlformats.org/drawingml/2006/main">
             <a:off x="2038350" y="1695450"/>
-            <a:ext cx="2476500" cy="307521"/>
+            <a:ext cx="2476500" cy="112395"/>
           </a:xfrm>
           <a:prstGeom xmlns:a="http://schemas.openxmlformats.org/drawingml/2006/main" prst="rect">
             <a:avLst/>
@@ -6759,7 +6664,7 @@
                   <a:srgbClr val="25242B"/>
                 </a:solidFill>
               </a:rPr>
-              <a:t>Today Continue</a:t>
+              <a:t>Today Agenda、Carryover 与 Daily Override</a:t>
             </a:r>
           </a:p>
         </p:txBody>
@@ -6769,7 +6674,7 @@
           <p:cNvPr id="8" name="">
             <a:extLst xmlns:a="http://schemas.openxmlformats.org/drawingml/2006/main">
               <a:ext uri="{FF2B5EF4-FFF2-40B4-BE49-F238E27FC236}">
-                <a16:creationId xmlns:a16="http://schemas.microsoft.com/office/drawing/2014/main" id="{0B4265EE-64FF-4A15-ACAE-2734ED942F2B}"/>
+                <a16:creationId xmlns:a16="http://schemas.microsoft.com/office/drawing/2014/main" id="{056451A1-FE20-4771-9C5A-584E72B3B2D6}"/>
               </a:ext>
             </a:extLst>
           </p:cNvPr>
@@ -6781,7 +6686,7 @@
         <p:spPr>
           <a:xfrm xmlns:a="http://schemas.openxmlformats.org/drawingml/2006/main">
             <a:off x="4705350" y="1695450"/>
-            <a:ext cx="6591300" cy="307521"/>
+            <a:ext cx="6591300" cy="112395"/>
           </a:xfrm>
           <a:prstGeom xmlns:a="http://schemas.openxmlformats.org/drawingml/2006/main" prst="rect">
             <a:avLst/>
@@ -6809,7 +6714,7 @@
                   <a:srgbClr val="6F6C76"/>
                 </a:solidFill>
               </a:rPr>
-              <a:t>显示可继续项目、Next Step、最近 Session 与 Proof。</a:t>
+              <a:t>组合 Planned Session、Practice occurrence 与 Next Step，保留原窗口并支持当天展示调整。</a:t>
             </a:r>
           </a:p>
         </p:txBody>
@@ -6819,23 +6724,23 @@
           <p:cNvPr id="9" name="">
             <a:extLst xmlns:a="http://schemas.openxmlformats.org/drawingml/2006/main">
               <a:ext uri="{FF2B5EF4-FFF2-40B4-BE49-F238E27FC236}">
-                <a16:creationId xmlns:a16="http://schemas.microsoft.com/office/drawing/2014/main" id="{96746F2C-1B94-457B-90EC-B262A04E9941}"/>
-              </a:ext>
-            </a:extLst>
-          </p:cNvPr>
-          <p:cNvSpPr>
-            <a:spLocks xmlns:a="http://schemas.openxmlformats.org/drawingml/2006/main" noGrp="1"/>
-          </p:cNvSpPr>
-          <p:nvPr/>
-        </p:nvSpPr>
-        <p:spPr>
-          <a:xfrm xmlns:a="http://schemas.openxmlformats.org/drawingml/2006/main">
-            <a:off x="704850" y="2212521"/>
-            <a:ext cx="10782300" cy="574221"/>
+                <a16:creationId xmlns:a16="http://schemas.microsoft.com/office/drawing/2014/main" id="{6C156632-DF3A-44ED-9A77-117E4B001DB3}"/>
+              </a:ext>
+            </a:extLst>
+          </p:cNvPr>
+          <p:cNvSpPr>
+            <a:spLocks xmlns:a="http://schemas.openxmlformats.org/drawingml/2006/main" noGrp="1"/>
+          </p:cNvSpPr>
+          <p:nvPr/>
+        </p:nvSpPr>
+        <p:spPr>
+          <a:xfrm xmlns:a="http://schemas.openxmlformats.org/drawingml/2006/main">
+            <a:off x="704850" y="2017395"/>
+            <a:ext cx="10782300" cy="379095"/>
           </a:xfrm>
           <a:prstGeom xmlns:a="http://schemas.openxmlformats.org/drawingml/2006/main" prst="roundRect">
             <a:avLst>
-              <a:gd name="adj" fmla="val 19905"/>
+              <a:gd name="adj" fmla="val 30151"/>
             </a:avLst>
           </a:prstGeom>
           <a:solidFill xmlns:a="http://schemas.openxmlformats.org/drawingml/2006/main">
@@ -6854,23 +6759,23 @@
           <p:cNvPr id="10" name="">
             <a:extLst xmlns:a="http://schemas.openxmlformats.org/drawingml/2006/main">
               <a:ext uri="{FF2B5EF4-FFF2-40B4-BE49-F238E27FC236}">
-                <a16:creationId xmlns:a16="http://schemas.microsoft.com/office/drawing/2014/main" id="{9CE83941-B3A4-4FBB-B16A-CD76F2975699}"/>
-              </a:ext>
-            </a:extLst>
-          </p:cNvPr>
-          <p:cNvSpPr>
-            <a:spLocks xmlns:a="http://schemas.openxmlformats.org/drawingml/2006/main" noGrp="1"/>
-          </p:cNvSpPr>
-          <p:nvPr/>
-        </p:nvSpPr>
-        <p:spPr>
-          <a:xfrm xmlns:a="http://schemas.openxmlformats.org/drawingml/2006/main">
-            <a:off x="857250" y="2326821"/>
-            <a:ext cx="990600" cy="345621"/>
+                <a16:creationId xmlns:a16="http://schemas.microsoft.com/office/drawing/2014/main" id="{88AFA6A7-D695-4772-882E-1FB8FF1A112D}"/>
+              </a:ext>
+            </a:extLst>
+          </p:cNvPr>
+          <p:cNvSpPr>
+            <a:spLocks xmlns:a="http://schemas.openxmlformats.org/drawingml/2006/main" noGrp="1"/>
+          </p:cNvSpPr>
+          <p:nvPr/>
+        </p:nvSpPr>
+        <p:spPr>
+          <a:xfrm xmlns:a="http://schemas.openxmlformats.org/drawingml/2006/main">
+            <a:off x="857250" y="2131695"/>
+            <a:ext cx="990600" cy="150495"/>
           </a:xfrm>
           <a:prstGeom xmlns:a="http://schemas.openxmlformats.org/drawingml/2006/main" prst="roundRect">
             <a:avLst>
-              <a:gd name="adj" fmla="val 33071"/>
+              <a:gd name="adj" fmla="val 50000"/>
             </a:avLst>
           </a:prstGeom>
           <a:solidFill xmlns:a="http://schemas.openxmlformats.org/drawingml/2006/main">
@@ -6887,19 +6792,19 @@
           <p:cNvPr id="11" name="">
             <a:extLst xmlns:a="http://schemas.openxmlformats.org/drawingml/2006/main">
               <a:ext uri="{FF2B5EF4-FFF2-40B4-BE49-F238E27FC236}">
-                <a16:creationId xmlns:a16="http://schemas.microsoft.com/office/drawing/2014/main" id="{DA50C97F-9C0D-4F69-97FB-5470FDFD30E1}"/>
-              </a:ext>
-            </a:extLst>
-          </p:cNvPr>
-          <p:cNvSpPr>
-            <a:spLocks xmlns:a="http://schemas.openxmlformats.org/drawingml/2006/main" noGrp="1"/>
-          </p:cNvSpPr>
-          <p:nvPr/>
-        </p:nvSpPr>
-        <p:spPr>
-          <a:xfrm xmlns:a="http://schemas.openxmlformats.org/drawingml/2006/main">
-            <a:off x="914400" y="2345871"/>
-            <a:ext cx="876300" cy="307521"/>
+                <a16:creationId xmlns:a16="http://schemas.microsoft.com/office/drawing/2014/main" id="{ED927679-95C6-43F8-AE26-054B5E1004D5}"/>
+              </a:ext>
+            </a:extLst>
+          </p:cNvPr>
+          <p:cNvSpPr>
+            <a:spLocks xmlns:a="http://schemas.openxmlformats.org/drawingml/2006/main" noGrp="1"/>
+          </p:cNvSpPr>
+          <p:nvPr/>
+        </p:nvSpPr>
+        <p:spPr>
+          <a:xfrm xmlns:a="http://schemas.openxmlformats.org/drawingml/2006/main">
+            <a:off x="914400" y="2150745"/>
+            <a:ext cx="876300" cy="112395"/>
           </a:xfrm>
           <a:prstGeom xmlns:a="http://schemas.openxmlformats.org/drawingml/2006/main" prst="rect">
             <a:avLst/>
@@ -6937,19 +6842,19 @@
           <p:cNvPr id="12" name="">
             <a:extLst xmlns:a="http://schemas.openxmlformats.org/drawingml/2006/main">
               <a:ext uri="{FF2B5EF4-FFF2-40B4-BE49-F238E27FC236}">
-                <a16:creationId xmlns:a16="http://schemas.microsoft.com/office/drawing/2014/main" id="{BD142D65-7790-4B4E-B6D7-A7FB00B27B40}"/>
-              </a:ext>
-            </a:extLst>
-          </p:cNvPr>
-          <p:cNvSpPr>
-            <a:spLocks xmlns:a="http://schemas.openxmlformats.org/drawingml/2006/main" noGrp="1"/>
-          </p:cNvSpPr>
-          <p:nvPr/>
-        </p:nvSpPr>
-        <p:spPr>
-          <a:xfrm xmlns:a="http://schemas.openxmlformats.org/drawingml/2006/main">
-            <a:off x="2038350" y="2345871"/>
-            <a:ext cx="2476500" cy="307521"/>
+                <a16:creationId xmlns:a16="http://schemas.microsoft.com/office/drawing/2014/main" id="{034302F2-224D-45AB-8661-CCBA77889108}"/>
+              </a:ext>
+            </a:extLst>
+          </p:cNvPr>
+          <p:cNvSpPr>
+            <a:spLocks xmlns:a="http://schemas.openxmlformats.org/drawingml/2006/main" noGrp="1"/>
+          </p:cNvSpPr>
+          <p:nvPr/>
+        </p:nvSpPr>
+        <p:spPr>
+          <a:xfrm xmlns:a="http://schemas.openxmlformats.org/drawingml/2006/main">
+            <a:off x="2038350" y="2150745"/>
+            <a:ext cx="2476500" cy="112395"/>
           </a:xfrm>
           <a:prstGeom xmlns:a="http://schemas.openxmlformats.org/drawingml/2006/main" prst="rect">
             <a:avLst/>
@@ -6977,7 +6882,7 @@
                   <a:srgbClr val="25242B"/>
                 </a:solidFill>
               </a:rPr>
-              <a:t>Quick Log</a:t>
+              <a:t>Learning Plan 与 Plan Revision</a:t>
             </a:r>
           </a:p>
         </p:txBody>
@@ -6987,19 +6892,19 @@
           <p:cNvPr id="13" name="">
             <a:extLst xmlns:a="http://schemas.openxmlformats.org/drawingml/2006/main">
               <a:ext uri="{FF2B5EF4-FFF2-40B4-BE49-F238E27FC236}">
-                <a16:creationId xmlns:a16="http://schemas.microsoft.com/office/drawing/2014/main" id="{184F84DE-28C2-4BDF-97FF-3C3E07524199}"/>
-              </a:ext>
-            </a:extLst>
-          </p:cNvPr>
-          <p:cNvSpPr>
-            <a:spLocks xmlns:a="http://schemas.openxmlformats.org/drawingml/2006/main" noGrp="1"/>
-          </p:cNvSpPr>
-          <p:nvPr/>
-        </p:nvSpPr>
-        <p:spPr>
-          <a:xfrm xmlns:a="http://schemas.openxmlformats.org/drawingml/2006/main">
-            <a:off x="4705350" y="2345871"/>
-            <a:ext cx="6591300" cy="307521"/>
+                <a16:creationId xmlns:a16="http://schemas.microsoft.com/office/drawing/2014/main" id="{8FD81301-F77C-41EB-A881-B8A393CF0AD5}"/>
+              </a:ext>
+            </a:extLst>
+          </p:cNvPr>
+          <p:cNvSpPr>
+            <a:spLocks xmlns:a="http://schemas.openxmlformats.org/drawingml/2006/main" noGrp="1"/>
+          </p:cNvSpPr>
+          <p:nvPr/>
+        </p:nvSpPr>
+        <p:spPr>
+          <a:xfrm xmlns:a="http://schemas.openxmlformats.org/drawingml/2006/main">
+            <a:off x="4705350" y="2150745"/>
+            <a:ext cx="6591300" cy="112395"/>
           </a:xfrm>
           <a:prstGeom xmlns:a="http://schemas.openxmlformats.org/drawingml/2006/main" prst="rect">
             <a:avLst/>
@@ -7027,7 +6932,7 @@
                   <a:srgbClr val="6F6C76"/>
                 </a:solidFill>
               </a:rPr>
-              <a:t>用预设或自定义时长补记 Session，并可更新 Next Step。</a:t>
+              <a:t>结构性计划变化创建不可变 revision；执行层 Planned Session 仍可单独完成或改期。</a:t>
             </a:r>
           </a:p>
         </p:txBody>
@@ -7037,23 +6942,23 @@
           <p:cNvPr id="14" name="">
             <a:extLst xmlns:a="http://schemas.openxmlformats.org/drawingml/2006/main">
               <a:ext uri="{FF2B5EF4-FFF2-40B4-BE49-F238E27FC236}">
-                <a16:creationId xmlns:a16="http://schemas.microsoft.com/office/drawing/2014/main" id="{BE92335E-D22D-443B-9645-86D756EE8F8E}"/>
-              </a:ext>
-            </a:extLst>
-          </p:cNvPr>
-          <p:cNvSpPr>
-            <a:spLocks xmlns:a="http://schemas.openxmlformats.org/drawingml/2006/main" noGrp="1"/>
-          </p:cNvSpPr>
-          <p:nvPr/>
-        </p:nvSpPr>
-        <p:spPr>
-          <a:xfrm xmlns:a="http://schemas.openxmlformats.org/drawingml/2006/main">
-            <a:off x="704850" y="2862943"/>
-            <a:ext cx="10782300" cy="574221"/>
+                <a16:creationId xmlns:a16="http://schemas.microsoft.com/office/drawing/2014/main" id="{55FAA01E-8141-40CA-AE73-5BB2F82BBCE4}"/>
+              </a:ext>
+            </a:extLst>
+          </p:cNvPr>
+          <p:cNvSpPr>
+            <a:spLocks xmlns:a="http://schemas.openxmlformats.org/drawingml/2006/main" noGrp="1"/>
+          </p:cNvSpPr>
+          <p:nvPr/>
+        </p:nvSpPr>
+        <p:spPr>
+          <a:xfrm xmlns:a="http://schemas.openxmlformats.org/drawingml/2006/main">
+            <a:off x="704850" y="2472690"/>
+            <a:ext cx="10782300" cy="379095"/>
           </a:xfrm>
           <a:prstGeom xmlns:a="http://schemas.openxmlformats.org/drawingml/2006/main" prst="roundRect">
             <a:avLst>
-              <a:gd name="adj" fmla="val 19905"/>
+              <a:gd name="adj" fmla="val 30151"/>
             </a:avLst>
           </a:prstGeom>
           <a:solidFill xmlns:a="http://schemas.openxmlformats.org/drawingml/2006/main">
@@ -7072,23 +6977,23 @@
           <p:cNvPr id="15" name="">
             <a:extLst xmlns:a="http://schemas.openxmlformats.org/drawingml/2006/main">
               <a:ext uri="{FF2B5EF4-FFF2-40B4-BE49-F238E27FC236}">
-                <a16:creationId xmlns:a16="http://schemas.microsoft.com/office/drawing/2014/main" id="{A8876277-0240-4698-9BF8-90C816C2E164}"/>
-              </a:ext>
-            </a:extLst>
-          </p:cNvPr>
-          <p:cNvSpPr>
-            <a:spLocks xmlns:a="http://schemas.openxmlformats.org/drawingml/2006/main" noGrp="1"/>
-          </p:cNvSpPr>
-          <p:nvPr/>
-        </p:nvSpPr>
-        <p:spPr>
-          <a:xfrm xmlns:a="http://schemas.openxmlformats.org/drawingml/2006/main">
-            <a:off x="857250" y="2977243"/>
-            <a:ext cx="990600" cy="345621"/>
+                <a16:creationId xmlns:a16="http://schemas.microsoft.com/office/drawing/2014/main" id="{0E4C97A9-1348-47D7-A8AC-2202D834426B}"/>
+              </a:ext>
+            </a:extLst>
+          </p:cNvPr>
+          <p:cNvSpPr>
+            <a:spLocks xmlns:a="http://schemas.openxmlformats.org/drawingml/2006/main" noGrp="1"/>
+          </p:cNvSpPr>
+          <p:nvPr/>
+        </p:nvSpPr>
+        <p:spPr>
+          <a:xfrm xmlns:a="http://schemas.openxmlformats.org/drawingml/2006/main">
+            <a:off x="857250" y="2586990"/>
+            <a:ext cx="990600" cy="150495"/>
           </a:xfrm>
           <a:prstGeom xmlns:a="http://schemas.openxmlformats.org/drawingml/2006/main" prst="roundRect">
             <a:avLst>
-              <a:gd name="adj" fmla="val 33071"/>
+              <a:gd name="adj" fmla="val 50000"/>
             </a:avLst>
           </a:prstGeom>
           <a:solidFill xmlns:a="http://schemas.openxmlformats.org/drawingml/2006/main">
@@ -7105,19 +7010,19 @@
           <p:cNvPr id="16" name="">
             <a:extLst xmlns:a="http://schemas.openxmlformats.org/drawingml/2006/main">
               <a:ext uri="{FF2B5EF4-FFF2-40B4-BE49-F238E27FC236}">
-                <a16:creationId xmlns:a16="http://schemas.microsoft.com/office/drawing/2014/main" id="{B2275066-692C-462B-BE14-132ACDD919B8}"/>
-              </a:ext>
-            </a:extLst>
-          </p:cNvPr>
-          <p:cNvSpPr>
-            <a:spLocks xmlns:a="http://schemas.openxmlformats.org/drawingml/2006/main" noGrp="1"/>
-          </p:cNvSpPr>
-          <p:nvPr/>
-        </p:nvSpPr>
-        <p:spPr>
-          <a:xfrm xmlns:a="http://schemas.openxmlformats.org/drawingml/2006/main">
-            <a:off x="914400" y="2996293"/>
-            <a:ext cx="876300" cy="307521"/>
+                <a16:creationId xmlns:a16="http://schemas.microsoft.com/office/drawing/2014/main" id="{9418C6F1-0D8F-4F4B-B65C-E01CD273963E}"/>
+              </a:ext>
+            </a:extLst>
+          </p:cNvPr>
+          <p:cNvSpPr>
+            <a:spLocks xmlns:a="http://schemas.openxmlformats.org/drawingml/2006/main" noGrp="1"/>
+          </p:cNvSpPr>
+          <p:nvPr/>
+        </p:nvSpPr>
+        <p:spPr>
+          <a:xfrm xmlns:a="http://schemas.openxmlformats.org/drawingml/2006/main">
+            <a:off x="914400" y="2606040"/>
+            <a:ext cx="876300" cy="112395"/>
           </a:xfrm>
           <a:prstGeom xmlns:a="http://schemas.openxmlformats.org/drawingml/2006/main" prst="rect">
             <a:avLst/>
@@ -7155,19 +7060,19 @@
           <p:cNvPr id="17" name="">
             <a:extLst xmlns:a="http://schemas.openxmlformats.org/drawingml/2006/main">
               <a:ext uri="{FF2B5EF4-FFF2-40B4-BE49-F238E27FC236}">
-                <a16:creationId xmlns:a16="http://schemas.microsoft.com/office/drawing/2014/main" id="{B544BE30-8D7F-4CA3-B228-D8CD9CC89524}"/>
-              </a:ext>
-            </a:extLst>
-          </p:cNvPr>
-          <p:cNvSpPr>
-            <a:spLocks xmlns:a="http://schemas.openxmlformats.org/drawingml/2006/main" noGrp="1"/>
-          </p:cNvSpPr>
-          <p:nvPr/>
-        </p:nvSpPr>
-        <p:spPr>
-          <a:xfrm xmlns:a="http://schemas.openxmlformats.org/drawingml/2006/main">
-            <a:off x="2038350" y="2996293"/>
-            <a:ext cx="2476500" cy="307521"/>
+                <a16:creationId xmlns:a16="http://schemas.microsoft.com/office/drawing/2014/main" id="{C20FB49B-EE3C-4509-AB67-2FDCC980A5D1}"/>
+              </a:ext>
+            </a:extLst>
+          </p:cNvPr>
+          <p:cNvSpPr>
+            <a:spLocks xmlns:a="http://schemas.openxmlformats.org/drawingml/2006/main" noGrp="1"/>
+          </p:cNvSpPr>
+          <p:nvPr/>
+        </p:nvSpPr>
+        <p:spPr>
+          <a:xfrm xmlns:a="http://schemas.openxmlformats.org/drawingml/2006/main">
+            <a:off x="2038350" y="2606040"/>
+            <a:ext cx="2476500" cy="112395"/>
           </a:xfrm>
           <a:prstGeom xmlns:a="http://schemas.openxmlformats.org/drawingml/2006/main" prst="rect">
             <a:avLst/>
@@ -7195,7 +7100,7 @@
                   <a:srgbClr val="25242B"/>
                 </a:solidFill>
               </a:rPr>
-              <a:t>Timer Session</a:t>
+              <a:t>Practice Blocks、Focus 与 Routine Player</a:t>
             </a:r>
           </a:p>
         </p:txBody>
@@ -7205,19 +7110,19 @@
           <p:cNvPr id="18" name="">
             <a:extLst xmlns:a="http://schemas.openxmlformats.org/drawingml/2006/main">
               <a:ext uri="{FF2B5EF4-FFF2-40B4-BE49-F238E27FC236}">
-                <a16:creationId xmlns:a16="http://schemas.microsoft.com/office/drawing/2014/main" id="{F6C1D61E-BE1A-4836-AA89-AD3F77F04B1D}"/>
-              </a:ext>
-            </a:extLst>
-          </p:cNvPr>
-          <p:cNvSpPr>
-            <a:spLocks xmlns:a="http://schemas.openxmlformats.org/drawingml/2006/main" noGrp="1"/>
-          </p:cNvSpPr>
-          <p:nvPr/>
-        </p:nvSpPr>
-        <p:spPr>
-          <a:xfrm xmlns:a="http://schemas.openxmlformats.org/drawingml/2006/main">
-            <a:off x="4705350" y="2996293"/>
-            <a:ext cx="6591300" cy="307521"/>
+                <a16:creationId xmlns:a16="http://schemas.microsoft.com/office/drawing/2014/main" id="{BC33337F-03D5-4094-81DE-2260A62E8785}"/>
+              </a:ext>
+            </a:extLst>
+          </p:cNvPr>
+          <p:cNvSpPr>
+            <a:spLocks xmlns:a="http://schemas.openxmlformats.org/drawingml/2006/main" noGrp="1"/>
+          </p:cNvSpPr>
+          <p:nvPr/>
+        </p:nvSpPr>
+        <p:spPr>
+          <a:xfrm xmlns:a="http://schemas.openxmlformats.org/drawingml/2006/main">
+            <a:off x="4705350" y="2606040"/>
+            <a:ext cx="6591300" cy="112395"/>
           </a:xfrm>
           <a:prstGeom xmlns:a="http://schemas.openxmlformats.org/drawingml/2006/main" prst="rect">
             <a:avLst/>
@@ -7245,7 +7150,7 @@
                   <a:srgbClr val="6F6C76"/>
                 </a:solidFill>
               </a:rPr>
-              <a:t>开始、暂停、继续、结束或舍弃现场学习计时。</a:t>
+              <a:t>有序 Block、Focus、Segments、跳过/重访与崩溃恢复写入一个 Practice Session。</a:t>
             </a:r>
           </a:p>
         </p:txBody>
@@ -7255,23 +7160,23 @@
           <p:cNvPr id="19" name="">
             <a:extLst xmlns:a="http://schemas.openxmlformats.org/drawingml/2006/main">
               <a:ext uri="{FF2B5EF4-FFF2-40B4-BE49-F238E27FC236}">
-                <a16:creationId xmlns:a16="http://schemas.microsoft.com/office/drawing/2014/main" id="{E4DCADAA-082F-4400-9DB4-84C7FCA6D91B}"/>
-              </a:ext>
-            </a:extLst>
-          </p:cNvPr>
-          <p:cNvSpPr>
-            <a:spLocks xmlns:a="http://schemas.openxmlformats.org/drawingml/2006/main" noGrp="1"/>
-          </p:cNvSpPr>
-          <p:nvPr/>
-        </p:nvSpPr>
-        <p:spPr>
-          <a:xfrm xmlns:a="http://schemas.openxmlformats.org/drawingml/2006/main">
-            <a:off x="704850" y="3513364"/>
-            <a:ext cx="10782300" cy="574221"/>
+                <a16:creationId xmlns:a16="http://schemas.microsoft.com/office/drawing/2014/main" id="{3AB4039D-301E-4FCA-AB3C-9B0D694CFA2C}"/>
+              </a:ext>
+            </a:extLst>
+          </p:cNvPr>
+          <p:cNvSpPr>
+            <a:spLocks xmlns:a="http://schemas.openxmlformats.org/drawingml/2006/main" noGrp="1"/>
+          </p:cNvSpPr>
+          <p:nvPr/>
+        </p:nvSpPr>
+        <p:spPr>
+          <a:xfrm xmlns:a="http://schemas.openxmlformats.org/drawingml/2006/main">
+            <a:off x="704850" y="2927985"/>
+            <a:ext cx="10782300" cy="379095"/>
           </a:xfrm>
           <a:prstGeom xmlns:a="http://schemas.openxmlformats.org/drawingml/2006/main" prst="roundRect">
             <a:avLst>
-              <a:gd name="adj" fmla="val 19905"/>
+              <a:gd name="adj" fmla="val 30151"/>
             </a:avLst>
           </a:prstGeom>
           <a:solidFill xmlns:a="http://schemas.openxmlformats.org/drawingml/2006/main">
@@ -7290,23 +7195,23 @@
           <p:cNvPr id="20" name="">
             <a:extLst xmlns:a="http://schemas.openxmlformats.org/drawingml/2006/main">
               <a:ext uri="{FF2B5EF4-FFF2-40B4-BE49-F238E27FC236}">
-                <a16:creationId xmlns:a16="http://schemas.microsoft.com/office/drawing/2014/main" id="{FDF8E9ED-EDDA-4D1F-8567-27ECCBCE784D}"/>
-              </a:ext>
-            </a:extLst>
-          </p:cNvPr>
-          <p:cNvSpPr>
-            <a:spLocks xmlns:a="http://schemas.openxmlformats.org/drawingml/2006/main" noGrp="1"/>
-          </p:cNvSpPr>
-          <p:nvPr/>
-        </p:nvSpPr>
-        <p:spPr>
-          <a:xfrm xmlns:a="http://schemas.openxmlformats.org/drawingml/2006/main">
-            <a:off x="857250" y="3627664"/>
-            <a:ext cx="990600" cy="345621"/>
+                <a16:creationId xmlns:a16="http://schemas.microsoft.com/office/drawing/2014/main" id="{BB5F7D9D-7393-42D9-8E0B-FAE2BFB9A232}"/>
+              </a:ext>
+            </a:extLst>
+          </p:cNvPr>
+          <p:cNvSpPr>
+            <a:spLocks xmlns:a="http://schemas.openxmlformats.org/drawingml/2006/main" noGrp="1"/>
+          </p:cNvSpPr>
+          <p:nvPr/>
+        </p:nvSpPr>
+        <p:spPr>
+          <a:xfrm xmlns:a="http://schemas.openxmlformats.org/drawingml/2006/main">
+            <a:off x="857250" y="3042285"/>
+            <a:ext cx="990600" cy="150495"/>
           </a:xfrm>
           <a:prstGeom xmlns:a="http://schemas.openxmlformats.org/drawingml/2006/main" prst="roundRect">
             <a:avLst>
-              <a:gd name="adj" fmla="val 33071"/>
+              <a:gd name="adj" fmla="val 50000"/>
             </a:avLst>
           </a:prstGeom>
           <a:solidFill xmlns:a="http://schemas.openxmlformats.org/drawingml/2006/main">
@@ -7323,19 +7228,19 @@
           <p:cNvPr id="21" name="">
             <a:extLst xmlns:a="http://schemas.openxmlformats.org/drawingml/2006/main">
               <a:ext uri="{FF2B5EF4-FFF2-40B4-BE49-F238E27FC236}">
-                <a16:creationId xmlns:a16="http://schemas.microsoft.com/office/drawing/2014/main" id="{86BD8F88-61EF-4C0F-A482-F7A467E68C1B}"/>
-              </a:ext>
-            </a:extLst>
-          </p:cNvPr>
-          <p:cNvSpPr>
-            <a:spLocks xmlns:a="http://schemas.openxmlformats.org/drawingml/2006/main" noGrp="1"/>
-          </p:cNvSpPr>
-          <p:nvPr/>
-        </p:nvSpPr>
-        <p:spPr>
-          <a:xfrm xmlns:a="http://schemas.openxmlformats.org/drawingml/2006/main">
-            <a:off x="914400" y="3646714"/>
-            <a:ext cx="876300" cy="307521"/>
+                <a16:creationId xmlns:a16="http://schemas.microsoft.com/office/drawing/2014/main" id="{22B943C9-6FCF-41DB-BA8D-B97E7ED4FB60}"/>
+              </a:ext>
+            </a:extLst>
+          </p:cNvPr>
+          <p:cNvSpPr>
+            <a:spLocks xmlns:a="http://schemas.openxmlformats.org/drawingml/2006/main" noGrp="1"/>
+          </p:cNvSpPr>
+          <p:nvPr/>
+        </p:nvSpPr>
+        <p:spPr>
+          <a:xfrm xmlns:a="http://schemas.openxmlformats.org/drawingml/2006/main">
+            <a:off x="914400" y="3061335"/>
+            <a:ext cx="876300" cy="112395"/>
           </a:xfrm>
           <a:prstGeom xmlns:a="http://schemas.openxmlformats.org/drawingml/2006/main" prst="rect">
             <a:avLst/>
@@ -7373,19 +7278,19 @@
           <p:cNvPr id="22" name="">
             <a:extLst xmlns:a="http://schemas.openxmlformats.org/drawingml/2006/main">
               <a:ext uri="{FF2B5EF4-FFF2-40B4-BE49-F238E27FC236}">
-                <a16:creationId xmlns:a16="http://schemas.microsoft.com/office/drawing/2014/main" id="{333C7891-41B7-47BA-9895-FB091E675BAB}"/>
-              </a:ext>
-            </a:extLst>
-          </p:cNvPr>
-          <p:cNvSpPr>
-            <a:spLocks xmlns:a="http://schemas.openxmlformats.org/drawingml/2006/main" noGrp="1"/>
-          </p:cNvSpPr>
-          <p:nvPr/>
-        </p:nvSpPr>
-        <p:spPr>
-          <a:xfrm xmlns:a="http://schemas.openxmlformats.org/drawingml/2006/main">
-            <a:off x="2038350" y="3646714"/>
-            <a:ext cx="2476500" cy="307521"/>
+                <a16:creationId xmlns:a16="http://schemas.microsoft.com/office/drawing/2014/main" id="{A2CD5AE4-A228-4194-9A8A-161984DA0193}"/>
+              </a:ext>
+            </a:extLst>
+          </p:cNvPr>
+          <p:cNvSpPr>
+            <a:spLocks xmlns:a="http://schemas.openxmlformats.org/drawingml/2006/main" noGrp="1"/>
+          </p:cNvSpPr>
+          <p:nvPr/>
+        </p:nvSpPr>
+        <p:spPr>
+          <a:xfrm xmlns:a="http://schemas.openxmlformats.org/drawingml/2006/main">
+            <a:off x="2038350" y="3061335"/>
+            <a:ext cx="2476500" cy="112395"/>
           </a:xfrm>
           <a:prstGeom xmlns:a="http://schemas.openxmlformats.org/drawingml/2006/main" prst="rect">
             <a:avLst/>
@@ -7413,7 +7318,7 @@
                   <a:srgbClr val="25242B"/>
                 </a:solidFill>
               </a:rPr>
-              <a:t>Proof</a:t>
+              <a:t>Stage Review 与 Qualifying Proof</a:t>
             </a:r>
           </a:p>
         </p:txBody>
@@ -7423,19 +7328,19 @@
           <p:cNvPr id="23" name="">
             <a:extLst xmlns:a="http://schemas.openxmlformats.org/drawingml/2006/main">
               <a:ext uri="{FF2B5EF4-FFF2-40B4-BE49-F238E27FC236}">
-                <a16:creationId xmlns:a16="http://schemas.microsoft.com/office/drawing/2014/main" id="{7FFEA420-61B1-4982-B34D-D3891EF8A1EF}"/>
-              </a:ext>
-            </a:extLst>
-          </p:cNvPr>
-          <p:cNvSpPr>
-            <a:spLocks xmlns:a="http://schemas.openxmlformats.org/drawingml/2006/main" noGrp="1"/>
-          </p:cNvSpPr>
-          <p:nvPr/>
-        </p:nvSpPr>
-        <p:spPr>
-          <a:xfrm xmlns:a="http://schemas.openxmlformats.org/drawingml/2006/main">
-            <a:off x="4705350" y="3646714"/>
-            <a:ext cx="6591300" cy="307521"/>
+                <a16:creationId xmlns:a16="http://schemas.microsoft.com/office/drawing/2014/main" id="{20E38CAD-59E9-453F-95AB-DAAF131B3E92}"/>
+              </a:ext>
+            </a:extLst>
+          </p:cNvPr>
+          <p:cNvSpPr>
+            <a:spLocks xmlns:a="http://schemas.openxmlformats.org/drawingml/2006/main" noGrp="1"/>
+          </p:cNvSpPr>
+          <p:nvPr/>
+        </p:nvSpPr>
+        <p:spPr>
+          <a:xfrm xmlns:a="http://schemas.openxmlformats.org/drawingml/2006/main">
+            <a:off x="4705350" y="3061335"/>
+            <a:ext cx="6591300" cy="112395"/>
           </a:xfrm>
           <a:prstGeom xmlns:a="http://schemas.openxmlformats.org/drawingml/2006/main" prst="rect">
             <a:avLst/>
@@ -7463,7 +7368,7 @@
                   <a:srgbClr val="6F6C76"/>
                 </a:solidFill>
               </a:rPr>
-              <a:t>添加图片、录音、文件或链接，并查看对应预览。</a:t>
+              <a:t>阶段锚定的 Readiness、Proof Revision、Evidence Contract 验收和显式 Review Decision 可原子发布。</a:t>
             </a:r>
           </a:p>
         </p:txBody>
@@ -7473,23 +7378,23 @@
           <p:cNvPr id="24" name="">
             <a:extLst xmlns:a="http://schemas.openxmlformats.org/drawingml/2006/main">
               <a:ext uri="{FF2B5EF4-FFF2-40B4-BE49-F238E27FC236}">
-                <a16:creationId xmlns:a16="http://schemas.microsoft.com/office/drawing/2014/main" id="{41572306-C7DB-4C69-8DA6-88EF11E0DDFB}"/>
-              </a:ext>
-            </a:extLst>
-          </p:cNvPr>
-          <p:cNvSpPr>
-            <a:spLocks xmlns:a="http://schemas.openxmlformats.org/drawingml/2006/main" noGrp="1"/>
-          </p:cNvSpPr>
-          <p:nvPr/>
-        </p:nvSpPr>
-        <p:spPr>
-          <a:xfrm xmlns:a="http://schemas.openxmlformats.org/drawingml/2006/main">
-            <a:off x="704850" y="4163786"/>
-            <a:ext cx="10782300" cy="574221"/>
+                <a16:creationId xmlns:a16="http://schemas.microsoft.com/office/drawing/2014/main" id="{474AB76F-814B-42BF-8F53-A28675498706}"/>
+              </a:ext>
+            </a:extLst>
+          </p:cNvPr>
+          <p:cNvSpPr>
+            <a:spLocks xmlns:a="http://schemas.openxmlformats.org/drawingml/2006/main" noGrp="1"/>
+          </p:cNvSpPr>
+          <p:nvPr/>
+        </p:nvSpPr>
+        <p:spPr>
+          <a:xfrm xmlns:a="http://schemas.openxmlformats.org/drawingml/2006/main">
+            <a:off x="704850" y="3383280"/>
+            <a:ext cx="10782300" cy="379095"/>
           </a:xfrm>
           <a:prstGeom xmlns:a="http://schemas.openxmlformats.org/drawingml/2006/main" prst="roundRect">
             <a:avLst>
-              <a:gd name="adj" fmla="val 19905"/>
+              <a:gd name="adj" fmla="val 30151"/>
             </a:avLst>
           </a:prstGeom>
           <a:solidFill xmlns:a="http://schemas.openxmlformats.org/drawingml/2006/main">
@@ -7508,23 +7413,23 @@
           <p:cNvPr id="25" name="">
             <a:extLst xmlns:a="http://schemas.openxmlformats.org/drawingml/2006/main">
               <a:ext uri="{FF2B5EF4-FFF2-40B4-BE49-F238E27FC236}">
-                <a16:creationId xmlns:a16="http://schemas.microsoft.com/office/drawing/2014/main" id="{E89CBED2-458E-46DD-9C12-D26591A2C294}"/>
-              </a:ext>
-            </a:extLst>
-          </p:cNvPr>
-          <p:cNvSpPr>
-            <a:spLocks xmlns:a="http://schemas.openxmlformats.org/drawingml/2006/main" noGrp="1"/>
-          </p:cNvSpPr>
-          <p:nvPr/>
-        </p:nvSpPr>
-        <p:spPr>
-          <a:xfrm xmlns:a="http://schemas.openxmlformats.org/drawingml/2006/main">
-            <a:off x="857250" y="4278086"/>
-            <a:ext cx="990600" cy="345621"/>
+                <a16:creationId xmlns:a16="http://schemas.microsoft.com/office/drawing/2014/main" id="{52C6CE26-57D9-44EC-BA7E-5A01D6273ED4}"/>
+              </a:ext>
+            </a:extLst>
+          </p:cNvPr>
+          <p:cNvSpPr>
+            <a:spLocks xmlns:a="http://schemas.openxmlformats.org/drawingml/2006/main" noGrp="1"/>
+          </p:cNvSpPr>
+          <p:nvPr/>
+        </p:nvSpPr>
+        <p:spPr>
+          <a:xfrm xmlns:a="http://schemas.openxmlformats.org/drawingml/2006/main">
+            <a:off x="857250" y="3497580"/>
+            <a:ext cx="990600" cy="150495"/>
           </a:xfrm>
           <a:prstGeom xmlns:a="http://schemas.openxmlformats.org/drawingml/2006/main" prst="roundRect">
             <a:avLst>
-              <a:gd name="adj" fmla="val 33071"/>
+              <a:gd name="adj" fmla="val 50000"/>
             </a:avLst>
           </a:prstGeom>
           <a:solidFill xmlns:a="http://schemas.openxmlformats.org/drawingml/2006/main">
@@ -7541,19 +7446,19 @@
           <p:cNvPr id="26" name="">
             <a:extLst xmlns:a="http://schemas.openxmlformats.org/drawingml/2006/main">
               <a:ext uri="{FF2B5EF4-FFF2-40B4-BE49-F238E27FC236}">
-                <a16:creationId xmlns:a16="http://schemas.microsoft.com/office/drawing/2014/main" id="{500082C4-7F4C-4EBA-9324-7A26645EDD3C}"/>
-              </a:ext>
-            </a:extLst>
-          </p:cNvPr>
-          <p:cNvSpPr>
-            <a:spLocks xmlns:a="http://schemas.openxmlformats.org/drawingml/2006/main" noGrp="1"/>
-          </p:cNvSpPr>
-          <p:nvPr/>
-        </p:nvSpPr>
-        <p:spPr>
-          <a:xfrm xmlns:a="http://schemas.openxmlformats.org/drawingml/2006/main">
-            <a:off x="914400" y="4297136"/>
-            <a:ext cx="876300" cy="307521"/>
+                <a16:creationId xmlns:a16="http://schemas.microsoft.com/office/drawing/2014/main" id="{E4C6E5CE-F97A-4214-AD95-20C6C7DDEE34}"/>
+              </a:ext>
+            </a:extLst>
+          </p:cNvPr>
+          <p:cNvSpPr>
+            <a:spLocks xmlns:a="http://schemas.openxmlformats.org/drawingml/2006/main" noGrp="1"/>
+          </p:cNvSpPr>
+          <p:nvPr/>
+        </p:nvSpPr>
+        <p:spPr>
+          <a:xfrm xmlns:a="http://schemas.openxmlformats.org/drawingml/2006/main">
+            <a:off x="914400" y="3516630"/>
+            <a:ext cx="876300" cy="112395"/>
           </a:xfrm>
           <a:prstGeom xmlns:a="http://schemas.openxmlformats.org/drawingml/2006/main" prst="rect">
             <a:avLst/>
@@ -7591,19 +7496,19 @@
           <p:cNvPr id="27" name="">
             <a:extLst xmlns:a="http://schemas.openxmlformats.org/drawingml/2006/main">
               <a:ext uri="{FF2B5EF4-FFF2-40B4-BE49-F238E27FC236}">
-                <a16:creationId xmlns:a16="http://schemas.microsoft.com/office/drawing/2014/main" id="{B18E33BB-01B8-4BC2-B2E4-6734A72BB1AA}"/>
-              </a:ext>
-            </a:extLst>
-          </p:cNvPr>
-          <p:cNvSpPr>
-            <a:spLocks xmlns:a="http://schemas.openxmlformats.org/drawingml/2006/main" noGrp="1"/>
-          </p:cNvSpPr>
-          <p:nvPr/>
-        </p:nvSpPr>
-        <p:spPr>
-          <a:xfrm xmlns:a="http://schemas.openxmlformats.org/drawingml/2006/main">
-            <a:off x="2038350" y="4297136"/>
-            <a:ext cx="2476500" cy="307521"/>
+                <a16:creationId xmlns:a16="http://schemas.microsoft.com/office/drawing/2014/main" id="{1215C047-8F18-49A4-9A28-66E02EF79EFC}"/>
+              </a:ext>
+            </a:extLst>
+          </p:cNvPr>
+          <p:cNvSpPr>
+            <a:spLocks xmlns:a="http://schemas.openxmlformats.org/drawingml/2006/main" noGrp="1"/>
+          </p:cNvSpPr>
+          <p:nvPr/>
+        </p:nvSpPr>
+        <p:spPr>
+          <a:xfrm xmlns:a="http://schemas.openxmlformats.org/drawingml/2006/main">
+            <a:off x="2038350" y="3516630"/>
+            <a:ext cx="2476500" cy="112395"/>
           </a:xfrm>
           <a:prstGeom xmlns:a="http://schemas.openxmlformats.org/drawingml/2006/main" prst="rect">
             <a:avLst/>
@@ -7631,7 +7536,7 @@
                   <a:srgbClr val="25242B"/>
                 </a:solidFill>
               </a:rPr>
-              <a:t>Weekly Review</a:t>
+              <a:t>Planning Window 与 Capacity Check</a:t>
             </a:r>
           </a:p>
         </p:txBody>
@@ -7641,19 +7546,19 @@
           <p:cNvPr id="28" name="">
             <a:extLst xmlns:a="http://schemas.openxmlformats.org/drawingml/2006/main">
               <a:ext uri="{FF2B5EF4-FFF2-40B4-BE49-F238E27FC236}">
-                <a16:creationId xmlns:a16="http://schemas.microsoft.com/office/drawing/2014/main" id="{E047EF9E-CF62-499E-BB23-39EA3E426BB4}"/>
-              </a:ext>
-            </a:extLst>
-          </p:cNvPr>
-          <p:cNvSpPr>
-            <a:spLocks xmlns:a="http://schemas.openxmlformats.org/drawingml/2006/main" noGrp="1"/>
-          </p:cNvSpPr>
-          <p:nvPr/>
-        </p:nvSpPr>
-        <p:spPr>
-          <a:xfrm xmlns:a="http://schemas.openxmlformats.org/drawingml/2006/main">
-            <a:off x="4705350" y="4297136"/>
-            <a:ext cx="6591300" cy="307521"/>
+                <a16:creationId xmlns:a16="http://schemas.microsoft.com/office/drawing/2014/main" id="{9D116C09-72E2-48C1-A3A9-E133B3422CAF}"/>
+              </a:ext>
+            </a:extLst>
+          </p:cNvPr>
+          <p:cNvSpPr>
+            <a:spLocks xmlns:a="http://schemas.openxmlformats.org/drawingml/2006/main" noGrp="1"/>
+          </p:cNvSpPr>
+          <p:nvPr/>
+        </p:nvSpPr>
+        <p:spPr>
+          <a:xfrm xmlns:a="http://schemas.openxmlformats.org/drawingml/2006/main">
+            <a:off x="4705350" y="3516630"/>
+            <a:ext cx="6591300" cy="112395"/>
           </a:xfrm>
           <a:prstGeom xmlns:a="http://schemas.openxmlformats.org/drawingml/2006/main" prst="rect">
             <a:avLst/>
@@ -7681,7 +7586,7 @@
                   <a:srgbClr val="6F6C76"/>
                 </a:solidFill>
               </a:rPr>
-              <a:t>生成、编辑并保存 Facts、Patterns、Decisions 和 Next Steps。</a:t>
+              <a:t>按周/项目汇总计划与练习负载，支持 DST 安全的可用时间检查并要求确认。</a:t>
             </a:r>
           </a:p>
         </p:txBody>
@@ -7691,23 +7596,23 @@
           <p:cNvPr id="29" name="">
             <a:extLst xmlns:a="http://schemas.openxmlformats.org/drawingml/2006/main">
               <a:ext uri="{FF2B5EF4-FFF2-40B4-BE49-F238E27FC236}">
-                <a16:creationId xmlns:a16="http://schemas.microsoft.com/office/drawing/2014/main" id="{6A697BA5-13C3-4EB8-BC69-A539C9244D88}"/>
-              </a:ext>
-            </a:extLst>
-          </p:cNvPr>
-          <p:cNvSpPr>
-            <a:spLocks xmlns:a="http://schemas.openxmlformats.org/drawingml/2006/main" noGrp="1"/>
-          </p:cNvSpPr>
-          <p:nvPr/>
-        </p:nvSpPr>
-        <p:spPr>
-          <a:xfrm xmlns:a="http://schemas.openxmlformats.org/drawingml/2006/main">
-            <a:off x="704850" y="4814207"/>
-            <a:ext cx="10782300" cy="574221"/>
+                <a16:creationId xmlns:a16="http://schemas.microsoft.com/office/drawing/2014/main" id="{19A378CD-6031-4F6B-9945-756538F6FCB7}"/>
+              </a:ext>
+            </a:extLst>
+          </p:cNvPr>
+          <p:cNvSpPr>
+            <a:spLocks xmlns:a="http://schemas.openxmlformats.org/drawingml/2006/main" noGrp="1"/>
+          </p:cNvSpPr>
+          <p:nvPr/>
+        </p:nvSpPr>
+        <p:spPr>
+          <a:xfrm xmlns:a="http://schemas.openxmlformats.org/drawingml/2006/main">
+            <a:off x="704850" y="3838575"/>
+            <a:ext cx="10782300" cy="379095"/>
           </a:xfrm>
           <a:prstGeom xmlns:a="http://schemas.openxmlformats.org/drawingml/2006/main" prst="roundRect">
             <a:avLst>
-              <a:gd name="adj" fmla="val 19905"/>
+              <a:gd name="adj" fmla="val 30151"/>
             </a:avLst>
           </a:prstGeom>
           <a:solidFill xmlns:a="http://schemas.openxmlformats.org/drawingml/2006/main">
@@ -7726,27 +7631,27 @@
           <p:cNvPr id="30" name="">
             <a:extLst xmlns:a="http://schemas.openxmlformats.org/drawingml/2006/main">
               <a:ext uri="{FF2B5EF4-FFF2-40B4-BE49-F238E27FC236}">
-                <a16:creationId xmlns:a16="http://schemas.microsoft.com/office/drawing/2014/main" id="{7A3D3830-3019-4A04-B0C6-5D072BE2771F}"/>
-              </a:ext>
-            </a:extLst>
-          </p:cNvPr>
-          <p:cNvSpPr>
-            <a:spLocks xmlns:a="http://schemas.openxmlformats.org/drawingml/2006/main" noGrp="1"/>
-          </p:cNvSpPr>
-          <p:nvPr/>
-        </p:nvSpPr>
-        <p:spPr>
-          <a:xfrm xmlns:a="http://schemas.openxmlformats.org/drawingml/2006/main">
-            <a:off x="857250" y="4928507"/>
-            <a:ext cx="990600" cy="345621"/>
+                <a16:creationId xmlns:a16="http://schemas.microsoft.com/office/drawing/2014/main" id="{85918625-A825-4447-ABA0-4117426D17F8}"/>
+              </a:ext>
+            </a:extLst>
+          </p:cNvPr>
+          <p:cNvSpPr>
+            <a:spLocks xmlns:a="http://schemas.openxmlformats.org/drawingml/2006/main" noGrp="1"/>
+          </p:cNvSpPr>
+          <p:nvPr/>
+        </p:nvSpPr>
+        <p:spPr>
+          <a:xfrm xmlns:a="http://schemas.openxmlformats.org/drawingml/2006/main">
+            <a:off x="857250" y="3952875"/>
+            <a:ext cx="990600" cy="150495"/>
           </a:xfrm>
           <a:prstGeom xmlns:a="http://schemas.openxmlformats.org/drawingml/2006/main" prst="roundRect">
             <a:avLst>
-              <a:gd name="adj" fmla="val 33071"/>
+              <a:gd name="adj" fmla="val 50000"/>
             </a:avLst>
           </a:prstGeom>
           <a:solidFill xmlns:a="http://schemas.openxmlformats.org/drawingml/2006/main">
-            <a:srgbClr val="F6E7D7"/>
+            <a:srgbClr val="DDEFE8"/>
           </a:solidFill>
           <a:ln xmlns:a="http://schemas.openxmlformats.org/drawingml/2006/main" w="0">
             <a:noFill/>
@@ -7759,19 +7664,19 @@
           <p:cNvPr id="31" name="">
             <a:extLst xmlns:a="http://schemas.openxmlformats.org/drawingml/2006/main">
               <a:ext uri="{FF2B5EF4-FFF2-40B4-BE49-F238E27FC236}">
-                <a16:creationId xmlns:a16="http://schemas.microsoft.com/office/drawing/2014/main" id="{67022D23-FEFB-4B2E-86B1-97F377AF3B10}"/>
-              </a:ext>
-            </a:extLst>
-          </p:cNvPr>
-          <p:cNvSpPr>
-            <a:spLocks xmlns:a="http://schemas.openxmlformats.org/drawingml/2006/main" noGrp="1"/>
-          </p:cNvSpPr>
-          <p:nvPr/>
-        </p:nvSpPr>
-        <p:spPr>
-          <a:xfrm xmlns:a="http://schemas.openxmlformats.org/drawingml/2006/main">
-            <a:off x="914400" y="4947557"/>
-            <a:ext cx="876300" cy="307521"/>
+                <a16:creationId xmlns:a16="http://schemas.microsoft.com/office/drawing/2014/main" id="{FAC90DC7-04E3-4B2E-B88A-A4E07C32535E}"/>
+              </a:ext>
+            </a:extLst>
+          </p:cNvPr>
+          <p:cNvSpPr>
+            <a:spLocks xmlns:a="http://schemas.openxmlformats.org/drawingml/2006/main" noGrp="1"/>
+          </p:cNvSpPr>
+          <p:nvPr/>
+        </p:nvSpPr>
+        <p:spPr>
+          <a:xfrm xmlns:a="http://schemas.openxmlformats.org/drawingml/2006/main">
+            <a:off x="914400" y="3971925"/>
+            <a:ext cx="876300" cy="112395"/>
           </a:xfrm>
           <a:prstGeom xmlns:a="http://schemas.openxmlformats.org/drawingml/2006/main" prst="rect">
             <a:avLst/>
@@ -7789,17 +7694,17 @@
             <a:pPr algn="ctr">
               <a:defRPr sz="1200" b="1">
                 <a:solidFill>
-                  <a:srgbClr val="C77932"/>
+                  <a:srgbClr val="34866B"/>
                 </a:solidFill>
               </a:defRPr>
             </a:pPr>
             <a:r>
               <a:rPr sz="1200" b="1">
                 <a:solidFill>
-                  <a:srgbClr val="C77932"/>
-                </a:solidFill>
-              </a:rPr>
-              <a:t>部分实现</a:t>
+                  <a:srgbClr val="34866B"/>
+                </a:solidFill>
+              </a:rPr>
+              <a:t>已实现</a:t>
             </a:r>
           </a:p>
         </p:txBody>
@@ -7809,19 +7714,19 @@
           <p:cNvPr id="32" name="">
             <a:extLst xmlns:a="http://schemas.openxmlformats.org/drawingml/2006/main">
               <a:ext uri="{FF2B5EF4-FFF2-40B4-BE49-F238E27FC236}">
-                <a16:creationId xmlns:a16="http://schemas.microsoft.com/office/drawing/2014/main" id="{3F87F79E-18C1-4C8A-9BC7-CF00E1116149}"/>
-              </a:ext>
-            </a:extLst>
-          </p:cNvPr>
-          <p:cNvSpPr>
-            <a:spLocks xmlns:a="http://schemas.openxmlformats.org/drawingml/2006/main" noGrp="1"/>
-          </p:cNvSpPr>
-          <p:nvPr/>
-        </p:nvSpPr>
-        <p:spPr>
-          <a:xfrm xmlns:a="http://schemas.openxmlformats.org/drawingml/2006/main">
-            <a:off x="2038350" y="4947557"/>
-            <a:ext cx="2476500" cy="307521"/>
+                <a16:creationId xmlns:a16="http://schemas.microsoft.com/office/drawing/2014/main" id="{17E2BD81-FCB8-4122-BACD-48871D7CFBFE}"/>
+              </a:ext>
+            </a:extLst>
+          </p:cNvPr>
+          <p:cNvSpPr>
+            <a:spLocks xmlns:a="http://schemas.openxmlformats.org/drawingml/2006/main" noGrp="1"/>
+          </p:cNvSpPr>
+          <p:nvPr/>
+        </p:nvSpPr>
+        <p:spPr>
+          <a:xfrm xmlns:a="http://schemas.openxmlformats.org/drawingml/2006/main">
+            <a:off x="2038350" y="3971925"/>
+            <a:ext cx="2476500" cy="112395"/>
           </a:xfrm>
           <a:prstGeom xmlns:a="http://schemas.openxmlformats.org/drawingml/2006/main" prst="rect">
             <a:avLst/>
@@ -7849,7 +7754,7 @@
                   <a:srgbClr val="25242B"/>
                 </a:solidFill>
               </a:rPr>
-              <a:t>OpenAI-compatible Review</a:t>
+              <a:t>iPhone CloudKit/iCloud</a:t>
             </a:r>
           </a:p>
         </p:txBody>
@@ -7859,19 +7764,19 @@
           <p:cNvPr id="33" name="">
             <a:extLst xmlns:a="http://schemas.openxmlformats.org/drawingml/2006/main">
               <a:ext uri="{FF2B5EF4-FFF2-40B4-BE49-F238E27FC236}">
-                <a16:creationId xmlns:a16="http://schemas.microsoft.com/office/drawing/2014/main" id="{FB347BD7-2615-42E9-8B4E-276118EEC3EE}"/>
-              </a:ext>
-            </a:extLst>
-          </p:cNvPr>
-          <p:cNvSpPr>
-            <a:spLocks xmlns:a="http://schemas.openxmlformats.org/drawingml/2006/main" noGrp="1"/>
-          </p:cNvSpPr>
-          <p:nvPr/>
-        </p:nvSpPr>
-        <p:spPr>
-          <a:xfrm xmlns:a="http://schemas.openxmlformats.org/drawingml/2006/main">
-            <a:off x="4705350" y="4947557"/>
-            <a:ext cx="6591300" cy="307521"/>
+                <a16:creationId xmlns:a16="http://schemas.microsoft.com/office/drawing/2014/main" id="{B3643DB4-0A71-4E13-AE49-B505D8376A54}"/>
+              </a:ext>
+            </a:extLst>
+          </p:cNvPr>
+          <p:cNvSpPr>
+            <a:spLocks xmlns:a="http://schemas.openxmlformats.org/drawingml/2006/main" noGrp="1"/>
+          </p:cNvSpPr>
+          <p:nvPr/>
+        </p:nvSpPr>
+        <p:spPr>
+          <a:xfrm xmlns:a="http://schemas.openxmlformats.org/drawingml/2006/main">
+            <a:off x="4705350" y="3971925"/>
+            <a:ext cx="6591300" cy="112395"/>
           </a:xfrm>
           <a:prstGeom xmlns:a="http://schemas.openxmlformats.org/drawingml/2006/main" prst="rect">
             <a:avLst/>
@@ -7899,7 +7804,7 @@
                   <a:srgbClr val="6F6C76"/>
                 </a:solidFill>
               </a:rPr>
-              <a:t>配置 Endpoint、Model 与 API Key 后调用 Chat Completions。</a:t>
+              <a:t>账号隔离、outbox、冲突审阅、重试上传与恢复路径已在本地/伪客户端测试覆盖。</a:t>
             </a:r>
           </a:p>
         </p:txBody>
@@ -7909,23 +7814,23 @@
           <p:cNvPr id="34" name="">
             <a:extLst xmlns:a="http://schemas.openxmlformats.org/drawingml/2006/main">
               <a:ext uri="{FF2B5EF4-FFF2-40B4-BE49-F238E27FC236}">
-                <a16:creationId xmlns:a16="http://schemas.microsoft.com/office/drawing/2014/main" id="{39E40AAE-F1AF-4CB2-A723-A8D7F7B133EF}"/>
-              </a:ext>
-            </a:extLst>
-          </p:cNvPr>
-          <p:cNvSpPr>
-            <a:spLocks xmlns:a="http://schemas.openxmlformats.org/drawingml/2006/main" noGrp="1"/>
-          </p:cNvSpPr>
-          <p:nvPr/>
-        </p:nvSpPr>
-        <p:spPr>
-          <a:xfrm xmlns:a="http://schemas.openxmlformats.org/drawingml/2006/main">
-            <a:off x="704850" y="5464629"/>
-            <a:ext cx="10782300" cy="574221"/>
+                <a16:creationId xmlns:a16="http://schemas.microsoft.com/office/drawing/2014/main" id="{78551B64-41D6-48C1-A033-D0767D8F1881}"/>
+              </a:ext>
+            </a:extLst>
+          </p:cNvPr>
+          <p:cNvSpPr>
+            <a:spLocks xmlns:a="http://schemas.openxmlformats.org/drawingml/2006/main" noGrp="1"/>
+          </p:cNvSpPr>
+          <p:nvPr/>
+        </p:nvSpPr>
+        <p:spPr>
+          <a:xfrm xmlns:a="http://schemas.openxmlformats.org/drawingml/2006/main">
+            <a:off x="704850" y="4293870"/>
+            <a:ext cx="10782300" cy="379095"/>
           </a:xfrm>
           <a:prstGeom xmlns:a="http://schemas.openxmlformats.org/drawingml/2006/main" prst="roundRect">
             <a:avLst>
-              <a:gd name="adj" fmla="val 19905"/>
+              <a:gd name="adj" fmla="val 30151"/>
             </a:avLst>
           </a:prstGeom>
           <a:solidFill xmlns:a="http://schemas.openxmlformats.org/drawingml/2006/main">
@@ -7944,27 +7849,27 @@
           <p:cNvPr id="35" name="">
             <a:extLst xmlns:a="http://schemas.openxmlformats.org/drawingml/2006/main">
               <a:ext uri="{FF2B5EF4-FFF2-40B4-BE49-F238E27FC236}">
-                <a16:creationId xmlns:a16="http://schemas.microsoft.com/office/drawing/2014/main" id="{1BFA3882-1EC5-4565-A304-9D77D2DE812A}"/>
-              </a:ext>
-            </a:extLst>
-          </p:cNvPr>
-          <p:cNvSpPr>
-            <a:spLocks xmlns:a="http://schemas.openxmlformats.org/drawingml/2006/main" noGrp="1"/>
-          </p:cNvSpPr>
-          <p:nvPr/>
-        </p:nvSpPr>
-        <p:spPr>
-          <a:xfrm xmlns:a="http://schemas.openxmlformats.org/drawingml/2006/main">
-            <a:off x="857250" y="5578929"/>
-            <a:ext cx="990600" cy="345621"/>
+                <a16:creationId xmlns:a16="http://schemas.microsoft.com/office/drawing/2014/main" id="{E51DD127-E450-46EB-8E23-1EB48DB35E26}"/>
+              </a:ext>
+            </a:extLst>
+          </p:cNvPr>
+          <p:cNvSpPr>
+            <a:spLocks xmlns:a="http://schemas.openxmlformats.org/drawingml/2006/main" noGrp="1"/>
+          </p:cNvSpPr>
+          <p:nvPr/>
+        </p:nvSpPr>
+        <p:spPr>
+          <a:xfrm xmlns:a="http://schemas.openxmlformats.org/drawingml/2006/main">
+            <a:off x="857250" y="4408170"/>
+            <a:ext cx="990600" cy="150495"/>
           </a:xfrm>
           <a:prstGeom xmlns:a="http://schemas.openxmlformats.org/drawingml/2006/main" prst="roundRect">
             <a:avLst>
-              <a:gd name="adj" fmla="val 33071"/>
+              <a:gd name="adj" fmla="val 50000"/>
             </a:avLst>
           </a:prstGeom>
           <a:solidFill xmlns:a="http://schemas.openxmlformats.org/drawingml/2006/main">
-            <a:srgbClr val="E7E2FA"/>
+            <a:srgbClr val="F6E7D7"/>
           </a:solidFill>
           <a:ln xmlns:a="http://schemas.openxmlformats.org/drawingml/2006/main" w="0">
             <a:noFill/>
@@ -7977,19 +7882,19 @@
           <p:cNvPr id="36" name="">
             <a:extLst xmlns:a="http://schemas.openxmlformats.org/drawingml/2006/main">
               <a:ext uri="{FF2B5EF4-FFF2-40B4-BE49-F238E27FC236}">
-                <a16:creationId xmlns:a16="http://schemas.microsoft.com/office/drawing/2014/main" id="{12917808-1FC8-4816-AB9F-4E117D0170A1}"/>
-              </a:ext>
-            </a:extLst>
-          </p:cNvPr>
-          <p:cNvSpPr>
-            <a:spLocks xmlns:a="http://schemas.openxmlformats.org/drawingml/2006/main" noGrp="1"/>
-          </p:cNvSpPr>
-          <p:nvPr/>
-        </p:nvSpPr>
-        <p:spPr>
-          <a:xfrm xmlns:a="http://schemas.openxmlformats.org/drawingml/2006/main">
-            <a:off x="914400" y="5597979"/>
-            <a:ext cx="876300" cy="307521"/>
+                <a16:creationId xmlns:a16="http://schemas.microsoft.com/office/drawing/2014/main" id="{C918ADB2-79B1-43FE-B4D3-4E3E6C746254}"/>
+              </a:ext>
+            </a:extLst>
+          </p:cNvPr>
+          <p:cNvSpPr>
+            <a:spLocks xmlns:a="http://schemas.openxmlformats.org/drawingml/2006/main" noGrp="1"/>
+          </p:cNvSpPr>
+          <p:nvPr/>
+        </p:nvSpPr>
+        <p:spPr>
+          <a:xfrm xmlns:a="http://schemas.openxmlformats.org/drawingml/2006/main">
+            <a:off x="914400" y="4427220"/>
+            <a:ext cx="876300" cy="112395"/>
           </a:xfrm>
           <a:prstGeom xmlns:a="http://schemas.openxmlformats.org/drawingml/2006/main" prst="rect">
             <a:avLst/>
@@ -8007,17 +7912,17 @@
             <a:pPr algn="ctr">
               <a:defRPr sz="1200" b="1">
                 <a:solidFill>
-                  <a:srgbClr val="6657D9"/>
+                  <a:srgbClr val="C77932"/>
                 </a:solidFill>
               </a:defRPr>
             </a:pPr>
             <a:r>
               <a:rPr sz="1200" b="1">
                 <a:solidFill>
-                  <a:srgbClr val="6657D9"/>
-                </a:solidFill>
-              </a:rPr>
-              <a:t>已设计</a:t>
+                  <a:srgbClr val="C77932"/>
+                </a:solidFill>
+              </a:rPr>
+              <a:t>部分实现</a:t>
             </a:r>
           </a:p>
         </p:txBody>
@@ -8027,19 +7932,19 @@
           <p:cNvPr id="37" name="">
             <a:extLst xmlns:a="http://schemas.openxmlformats.org/drawingml/2006/main">
               <a:ext uri="{FF2B5EF4-FFF2-40B4-BE49-F238E27FC236}">
-                <a16:creationId xmlns:a16="http://schemas.microsoft.com/office/drawing/2014/main" id="{E3A027D3-1944-461F-B299-977F07DF7D1A}"/>
-              </a:ext>
-            </a:extLst>
-          </p:cNvPr>
-          <p:cNvSpPr>
-            <a:spLocks xmlns:a="http://schemas.openxmlformats.org/drawingml/2006/main" noGrp="1"/>
-          </p:cNvSpPr>
-          <p:nvPr/>
-        </p:nvSpPr>
-        <p:spPr>
-          <a:xfrm xmlns:a="http://schemas.openxmlformats.org/drawingml/2006/main">
-            <a:off x="2038350" y="5597979"/>
-            <a:ext cx="2476500" cy="307521"/>
+                <a16:creationId xmlns:a16="http://schemas.microsoft.com/office/drawing/2014/main" id="{9E96BEB8-4320-4582-A19D-8A19ECE04B5D}"/>
+              </a:ext>
+            </a:extLst>
+          </p:cNvPr>
+          <p:cNvSpPr>
+            <a:spLocks xmlns:a="http://schemas.openxmlformats.org/drawingml/2006/main" noGrp="1"/>
+          </p:cNvSpPr>
+          <p:nvPr/>
+        </p:nvSpPr>
+        <p:spPr>
+          <a:xfrm xmlns:a="http://schemas.openxmlformats.org/drawingml/2006/main">
+            <a:off x="2038350" y="4427220"/>
+            <a:ext cx="2476500" cy="112395"/>
           </a:xfrm>
           <a:prstGeom xmlns:a="http://schemas.openxmlformats.org/drawingml/2006/main" prst="rect">
             <a:avLst/>
@@ -8067,7 +7972,7 @@
                   <a:srgbClr val="25242B"/>
                 </a:solidFill>
               </a:rPr>
-              <a:t>CloudKit/iCloud 私有同步</a:t>
+              <a:t>Web C1 Demo/Real Journal</a:t>
             </a:r>
           </a:p>
         </p:txBody>
@@ -8077,19 +7982,19 @@
           <p:cNvPr id="38" name="">
             <a:extLst xmlns:a="http://schemas.openxmlformats.org/drawingml/2006/main">
               <a:ext uri="{FF2B5EF4-FFF2-40B4-BE49-F238E27FC236}">
-                <a16:creationId xmlns:a16="http://schemas.microsoft.com/office/drawing/2014/main" id="{10E534C1-CA21-4857-9872-AD0A5509E802}"/>
-              </a:ext>
-            </a:extLst>
-          </p:cNvPr>
-          <p:cNvSpPr>
-            <a:spLocks xmlns:a="http://schemas.openxmlformats.org/drawingml/2006/main" noGrp="1"/>
-          </p:cNvSpPr>
-          <p:nvPr/>
-        </p:nvSpPr>
-        <p:spPr>
-          <a:xfrm xmlns:a="http://schemas.openxmlformats.org/drawingml/2006/main">
-            <a:off x="4705350" y="5597979"/>
-            <a:ext cx="6591300" cy="307521"/>
+                <a16:creationId xmlns:a16="http://schemas.microsoft.com/office/drawing/2014/main" id="{24003EE8-C720-4FD2-B533-2748403918C6}"/>
+              </a:ext>
+            </a:extLst>
+          </p:cNvPr>
+          <p:cNvSpPr>
+            <a:spLocks xmlns:a="http://schemas.openxmlformats.org/drawingml/2006/main" noGrp="1"/>
+          </p:cNvSpPr>
+          <p:nvPr/>
+        </p:nvSpPr>
+        <p:spPr>
+          <a:xfrm xmlns:a="http://schemas.openxmlformats.org/drawingml/2006/main">
+            <a:off x="4705350" y="4427220"/>
+            <a:ext cx="6591300" cy="112395"/>
           </a:xfrm>
           <a:prstGeom xmlns:a="http://schemas.openxmlformats.org/drawingml/2006/main" prst="rect">
             <a:avLst/>
@@ -8117,7 +8022,661 @@
                   <a:srgbClr val="6F6C76"/>
                 </a:solidFill>
               </a:rPr>
-              <a:t>当前 App 不显示同步入口。</a:t>
+              <a:t>Demo 是明确的非 canonical fixture；Real 模式读取同一私有 CloudKit zone，不静默回退。</a:t>
+            </a:r>
+          </a:p>
+        </p:txBody>
+      </p:sp>
+      <p:sp>
+        <p:nvSpPr>
+          <p:cNvPr id="39" name="">
+            <a:extLst xmlns:a="http://schemas.openxmlformats.org/drawingml/2006/main">
+              <a:ext uri="{FF2B5EF4-FFF2-40B4-BE49-F238E27FC236}">
+                <a16:creationId xmlns:a16="http://schemas.microsoft.com/office/drawing/2014/main" id="{F1A97EA5-1D58-4632-9EEA-A5340052BA2D}"/>
+              </a:ext>
+            </a:extLst>
+          </p:cNvPr>
+          <p:cNvSpPr>
+            <a:spLocks xmlns:a="http://schemas.openxmlformats.org/drawingml/2006/main" noGrp="1"/>
+          </p:cNvSpPr>
+          <p:nvPr/>
+        </p:nvSpPr>
+        <p:spPr>
+          <a:xfrm xmlns:a="http://schemas.openxmlformats.org/drawingml/2006/main">
+            <a:off x="704850" y="4749165"/>
+            <a:ext cx="10782300" cy="379095"/>
+          </a:xfrm>
+          <a:prstGeom xmlns:a="http://schemas.openxmlformats.org/drawingml/2006/main" prst="roundRect">
+            <a:avLst>
+              <a:gd name="adj" fmla="val 30151"/>
+            </a:avLst>
+          </a:prstGeom>
+          <a:solidFill xmlns:a="http://schemas.openxmlformats.org/drawingml/2006/main">
+            <a:srgbClr val="FFFFFF"/>
+          </a:solidFill>
+          <a:ln xmlns:a="http://schemas.openxmlformats.org/drawingml/2006/main" w="9525">
+            <a:solidFill>
+              <a:srgbClr val="D9D4CB"/>
+            </a:solidFill>
+            <a:prstDash val="solid"/>
+          </a:ln>
+        </p:spPr>
+      </p:sp>
+      <p:sp>
+        <p:nvSpPr>
+          <p:cNvPr id="40" name="">
+            <a:extLst xmlns:a="http://schemas.openxmlformats.org/drawingml/2006/main">
+              <a:ext uri="{FF2B5EF4-FFF2-40B4-BE49-F238E27FC236}">
+                <a16:creationId xmlns:a16="http://schemas.microsoft.com/office/drawing/2014/main" id="{CFA5B89B-A9AF-4795-B85C-C7B05886B212}"/>
+              </a:ext>
+            </a:extLst>
+          </p:cNvPr>
+          <p:cNvSpPr>
+            <a:spLocks xmlns:a="http://schemas.openxmlformats.org/drawingml/2006/main" noGrp="1"/>
+          </p:cNvSpPr>
+          <p:nvPr/>
+        </p:nvSpPr>
+        <p:spPr>
+          <a:xfrm xmlns:a="http://schemas.openxmlformats.org/drawingml/2006/main">
+            <a:off x="857250" y="4863465"/>
+            <a:ext cx="990600" cy="150495"/>
+          </a:xfrm>
+          <a:prstGeom xmlns:a="http://schemas.openxmlformats.org/drawingml/2006/main" prst="roundRect">
+            <a:avLst>
+              <a:gd name="adj" fmla="val 50000"/>
+            </a:avLst>
+          </a:prstGeom>
+          <a:solidFill xmlns:a="http://schemas.openxmlformats.org/drawingml/2006/main">
+            <a:srgbClr val="F6E7D7"/>
+          </a:solidFill>
+          <a:ln xmlns:a="http://schemas.openxmlformats.org/drawingml/2006/main" w="0">
+            <a:noFill/>
+            <a:prstDash val="solid"/>
+          </a:ln>
+        </p:spPr>
+      </p:sp>
+      <p:sp>
+        <p:nvSpPr>
+          <p:cNvPr id="41" name="">
+            <a:extLst xmlns:a="http://schemas.openxmlformats.org/drawingml/2006/main">
+              <a:ext uri="{FF2B5EF4-FFF2-40B4-BE49-F238E27FC236}">
+                <a16:creationId xmlns:a16="http://schemas.microsoft.com/office/drawing/2014/main" id="{A28A5E82-AC5E-4819-B330-67454DF835C1}"/>
+              </a:ext>
+            </a:extLst>
+          </p:cNvPr>
+          <p:cNvSpPr>
+            <a:spLocks xmlns:a="http://schemas.openxmlformats.org/drawingml/2006/main" noGrp="1"/>
+          </p:cNvSpPr>
+          <p:nvPr/>
+        </p:nvSpPr>
+        <p:spPr>
+          <a:xfrm xmlns:a="http://schemas.openxmlformats.org/drawingml/2006/main">
+            <a:off x="914400" y="4882515"/>
+            <a:ext cx="876300" cy="112395"/>
+          </a:xfrm>
+          <a:prstGeom xmlns:a="http://schemas.openxmlformats.org/drawingml/2006/main" prst="rect">
+            <a:avLst/>
+          </a:prstGeom>
+          <a:noFill xmlns:a="http://schemas.openxmlformats.org/drawingml/2006/main"/>
+          <a:ln xmlns:a="http://schemas.openxmlformats.org/drawingml/2006/main" w="0">
+            <a:noFill/>
+            <a:prstDash val="solid"/>
+          </a:ln>
+        </p:spPr>
+        <p:txBody>
+          <a:bodyPr xmlns:a="http://schemas.openxmlformats.org/drawingml/2006/main" anchor="ctr"/>
+          <a:lstStyle xmlns:a="http://schemas.openxmlformats.org/drawingml/2006/main"/>
+          <a:p xmlns:a="http://schemas.openxmlformats.org/drawingml/2006/main">
+            <a:pPr algn="ctr">
+              <a:defRPr sz="1200" b="1">
+                <a:solidFill>
+                  <a:srgbClr val="C77932"/>
+                </a:solidFill>
+              </a:defRPr>
+            </a:pPr>
+            <a:r>
+              <a:rPr sz="1200" b="1">
+                <a:solidFill>
+                  <a:srgbClr val="C77932"/>
+                </a:solidFill>
+              </a:rPr>
+              <a:t>部分实现</a:t>
+            </a:r>
+          </a:p>
+        </p:txBody>
+      </p:sp>
+      <p:sp>
+        <p:nvSpPr>
+          <p:cNvPr id="42" name="">
+            <a:extLst xmlns:a="http://schemas.openxmlformats.org/drawingml/2006/main">
+              <a:ext uri="{FF2B5EF4-FFF2-40B4-BE49-F238E27FC236}">
+                <a16:creationId xmlns:a16="http://schemas.microsoft.com/office/drawing/2014/main" id="{5ACD5981-A2F6-43BB-8044-381445339160}"/>
+              </a:ext>
+            </a:extLst>
+          </p:cNvPr>
+          <p:cNvSpPr>
+            <a:spLocks xmlns:a="http://schemas.openxmlformats.org/drawingml/2006/main" noGrp="1"/>
+          </p:cNvSpPr>
+          <p:nvPr/>
+        </p:nvSpPr>
+        <p:spPr>
+          <a:xfrm xmlns:a="http://schemas.openxmlformats.org/drawingml/2006/main">
+            <a:off x="2038350" y="4882515"/>
+            <a:ext cx="2476500" cy="112395"/>
+          </a:xfrm>
+          <a:prstGeom xmlns:a="http://schemas.openxmlformats.org/drawingml/2006/main" prst="rect">
+            <a:avLst/>
+          </a:prstGeom>
+          <a:noFill xmlns:a="http://schemas.openxmlformats.org/drawingml/2006/main"/>
+          <a:ln xmlns:a="http://schemas.openxmlformats.org/drawingml/2006/main" w="0">
+            <a:noFill/>
+            <a:prstDash val="solid"/>
+          </a:ln>
+        </p:spPr>
+        <p:txBody>
+          <a:bodyPr xmlns:a="http://schemas.openxmlformats.org/drawingml/2006/main" anchor="ctr"/>
+          <a:lstStyle xmlns:a="http://schemas.openxmlformats.org/drawingml/2006/main"/>
+          <a:p xmlns:a="http://schemas.openxmlformats.org/drawingml/2006/main">
+            <a:pPr algn="l">
+              <a:defRPr sz="1275" b="1">
+                <a:solidFill>
+                  <a:srgbClr val="25242B"/>
+                </a:solidFill>
+              </a:defRPr>
+            </a:pPr>
+            <a:r>
+              <a:rPr sz="1275" b="1">
+                <a:solidFill>
+                  <a:srgbClr val="25242B"/>
+                </a:solidFill>
+              </a:rPr>
+              <a:t>Web C2 guarded writes</a:t>
+            </a:r>
+          </a:p>
+        </p:txBody>
+      </p:sp>
+      <p:sp>
+        <p:nvSpPr>
+          <p:cNvPr id="43" name="">
+            <a:extLst xmlns:a="http://schemas.openxmlformats.org/drawingml/2006/main">
+              <a:ext uri="{FF2B5EF4-FFF2-40B4-BE49-F238E27FC236}">
+                <a16:creationId xmlns:a16="http://schemas.microsoft.com/office/drawing/2014/main" id="{DB16CC72-0042-44A2-8248-D48D9589BFC0}"/>
+              </a:ext>
+            </a:extLst>
+          </p:cNvPr>
+          <p:cNvSpPr>
+            <a:spLocks xmlns:a="http://schemas.openxmlformats.org/drawingml/2006/main" noGrp="1"/>
+          </p:cNvSpPr>
+          <p:nvPr/>
+        </p:nvSpPr>
+        <p:spPr>
+          <a:xfrm xmlns:a="http://schemas.openxmlformats.org/drawingml/2006/main">
+            <a:off x="4705350" y="4882515"/>
+            <a:ext cx="6591300" cy="112395"/>
+          </a:xfrm>
+          <a:prstGeom xmlns:a="http://schemas.openxmlformats.org/drawingml/2006/main" prst="rect">
+            <a:avLst/>
+          </a:prstGeom>
+          <a:noFill xmlns:a="http://schemas.openxmlformats.org/drawingml/2006/main"/>
+          <a:ln xmlns:a="http://schemas.openxmlformats.org/drawingml/2006/main" w="0">
+            <a:noFill/>
+            <a:prstDash val="solid"/>
+          </a:ln>
+        </p:spPr>
+        <p:txBody>
+          <a:bodyPr xmlns:a="http://schemas.openxmlformats.org/drawingml/2006/main" anchor="ctr"/>
+          <a:lstStyle xmlns:a="http://schemas.openxmlformats.org/drawingml/2006/main"/>
+          <a:p xmlns:a="http://schemas.openxmlformats.org/drawingml/2006/main">
+            <a:pPr algn="l">
+              <a:defRPr sz="1200" b="0">
+                <a:solidFill>
+                  <a:srgbClr val="6F6C76"/>
+                </a:solidFill>
+              </a:defRPr>
+            </a:pPr>
+            <a:r>
+              <a:rPr sz="1200" b="0">
+                <a:solidFill>
+                  <a:srgbClr val="6F6C76"/>
+                </a:solidFill>
+              </a:rPr>
+              <a:t>Next Step、Learning Plan、Routine、Qualifying Proof 与 Stage Review 通过 typed atomic writer 和 change-tag guard。</a:t>
+            </a:r>
+          </a:p>
+        </p:txBody>
+      </p:sp>
+      <p:sp>
+        <p:nvSpPr>
+          <p:cNvPr id="44" name="">
+            <a:extLst xmlns:a="http://schemas.openxmlformats.org/drawingml/2006/main">
+              <a:ext uri="{FF2B5EF4-FFF2-40B4-BE49-F238E27FC236}">
+                <a16:creationId xmlns:a16="http://schemas.microsoft.com/office/drawing/2014/main" id="{00874F1E-3151-47C6-B97C-CBF9F48CDDBE}"/>
+              </a:ext>
+            </a:extLst>
+          </p:cNvPr>
+          <p:cNvSpPr>
+            <a:spLocks xmlns:a="http://schemas.openxmlformats.org/drawingml/2006/main" noGrp="1"/>
+          </p:cNvSpPr>
+          <p:nvPr/>
+        </p:nvSpPr>
+        <p:spPr>
+          <a:xfrm xmlns:a="http://schemas.openxmlformats.org/drawingml/2006/main">
+            <a:off x="704850" y="5204460"/>
+            <a:ext cx="10782300" cy="379095"/>
+          </a:xfrm>
+          <a:prstGeom xmlns:a="http://schemas.openxmlformats.org/drawingml/2006/main" prst="roundRect">
+            <a:avLst>
+              <a:gd name="adj" fmla="val 30151"/>
+            </a:avLst>
+          </a:prstGeom>
+          <a:solidFill xmlns:a="http://schemas.openxmlformats.org/drawingml/2006/main">
+            <a:srgbClr val="FFFFFF"/>
+          </a:solidFill>
+          <a:ln xmlns:a="http://schemas.openxmlformats.org/drawingml/2006/main" w="9525">
+            <a:solidFill>
+              <a:srgbClr val="D9D4CB"/>
+            </a:solidFill>
+            <a:prstDash val="solid"/>
+          </a:ln>
+        </p:spPr>
+      </p:sp>
+      <p:sp>
+        <p:nvSpPr>
+          <p:cNvPr id="45" name="">
+            <a:extLst xmlns:a="http://schemas.openxmlformats.org/drawingml/2006/main">
+              <a:ext uri="{FF2B5EF4-FFF2-40B4-BE49-F238E27FC236}">
+                <a16:creationId xmlns:a16="http://schemas.microsoft.com/office/drawing/2014/main" id="{58ECCAE8-A479-4707-BA7D-6D8E629DFAB3}"/>
+              </a:ext>
+            </a:extLst>
+          </p:cNvPr>
+          <p:cNvSpPr>
+            <a:spLocks xmlns:a="http://schemas.openxmlformats.org/drawingml/2006/main" noGrp="1"/>
+          </p:cNvSpPr>
+          <p:nvPr/>
+        </p:nvSpPr>
+        <p:spPr>
+          <a:xfrm xmlns:a="http://schemas.openxmlformats.org/drawingml/2006/main">
+            <a:off x="857250" y="5318760"/>
+            <a:ext cx="990600" cy="150495"/>
+          </a:xfrm>
+          <a:prstGeom xmlns:a="http://schemas.openxmlformats.org/drawingml/2006/main" prst="roundRect">
+            <a:avLst>
+              <a:gd name="adj" fmla="val 50000"/>
+            </a:avLst>
+          </a:prstGeom>
+          <a:solidFill xmlns:a="http://schemas.openxmlformats.org/drawingml/2006/main">
+            <a:srgbClr val="F6E7D7"/>
+          </a:solidFill>
+          <a:ln xmlns:a="http://schemas.openxmlformats.org/drawingml/2006/main" w="0">
+            <a:noFill/>
+            <a:prstDash val="solid"/>
+          </a:ln>
+        </p:spPr>
+      </p:sp>
+      <p:sp>
+        <p:nvSpPr>
+          <p:cNvPr id="46" name="">
+            <a:extLst xmlns:a="http://schemas.openxmlformats.org/drawingml/2006/main">
+              <a:ext uri="{FF2B5EF4-FFF2-40B4-BE49-F238E27FC236}">
+                <a16:creationId xmlns:a16="http://schemas.microsoft.com/office/drawing/2014/main" id="{7EC3E31A-6416-4ABF-8303-29FC96D6F99A}"/>
+              </a:ext>
+            </a:extLst>
+          </p:cNvPr>
+          <p:cNvSpPr>
+            <a:spLocks xmlns:a="http://schemas.openxmlformats.org/drawingml/2006/main" noGrp="1"/>
+          </p:cNvSpPr>
+          <p:nvPr/>
+        </p:nvSpPr>
+        <p:spPr>
+          <a:xfrm xmlns:a="http://schemas.openxmlformats.org/drawingml/2006/main">
+            <a:off x="914400" y="5337810"/>
+            <a:ext cx="876300" cy="112395"/>
+          </a:xfrm>
+          <a:prstGeom xmlns:a="http://schemas.openxmlformats.org/drawingml/2006/main" prst="rect">
+            <a:avLst/>
+          </a:prstGeom>
+          <a:noFill xmlns:a="http://schemas.openxmlformats.org/drawingml/2006/main"/>
+          <a:ln xmlns:a="http://schemas.openxmlformats.org/drawingml/2006/main" w="0">
+            <a:noFill/>
+            <a:prstDash val="solid"/>
+          </a:ln>
+        </p:spPr>
+        <p:txBody>
+          <a:bodyPr xmlns:a="http://schemas.openxmlformats.org/drawingml/2006/main" anchor="ctr"/>
+          <a:lstStyle xmlns:a="http://schemas.openxmlformats.org/drawingml/2006/main"/>
+          <a:p xmlns:a="http://schemas.openxmlformats.org/drawingml/2006/main">
+            <a:pPr algn="ctr">
+              <a:defRPr sz="1200" b="1">
+                <a:solidFill>
+                  <a:srgbClr val="C77932"/>
+                </a:solidFill>
+              </a:defRPr>
+            </a:pPr>
+            <a:r>
+              <a:rPr sz="1200" b="1">
+                <a:solidFill>
+                  <a:srgbClr val="C77932"/>
+                </a:solidFill>
+              </a:rPr>
+              <a:t>部分实现</a:t>
+            </a:r>
+          </a:p>
+        </p:txBody>
+      </p:sp>
+      <p:sp>
+        <p:nvSpPr>
+          <p:cNvPr id="47" name="">
+            <a:extLst xmlns:a="http://schemas.openxmlformats.org/drawingml/2006/main">
+              <a:ext uri="{FF2B5EF4-FFF2-40B4-BE49-F238E27FC236}">
+                <a16:creationId xmlns:a16="http://schemas.microsoft.com/office/drawing/2014/main" id="{3E2C22AF-B9B2-4C3A-B8C2-8F128695056B}"/>
+              </a:ext>
+            </a:extLst>
+          </p:cNvPr>
+          <p:cNvSpPr>
+            <a:spLocks xmlns:a="http://schemas.openxmlformats.org/drawingml/2006/main" noGrp="1"/>
+          </p:cNvSpPr>
+          <p:nvPr/>
+        </p:nvSpPr>
+        <p:spPr>
+          <a:xfrm xmlns:a="http://schemas.openxmlformats.org/drawingml/2006/main">
+            <a:off x="2038350" y="5337810"/>
+            <a:ext cx="2476500" cy="112395"/>
+          </a:xfrm>
+          <a:prstGeom xmlns:a="http://schemas.openxmlformats.org/drawingml/2006/main" prst="rect">
+            <a:avLst/>
+          </a:prstGeom>
+          <a:noFill xmlns:a="http://schemas.openxmlformats.org/drawingml/2006/main"/>
+          <a:ln xmlns:a="http://schemas.openxmlformats.org/drawingml/2006/main" w="0">
+            <a:noFill/>
+            <a:prstDash val="solid"/>
+          </a:ln>
+        </p:spPr>
+        <p:txBody>
+          <a:bodyPr xmlns:a="http://schemas.openxmlformats.org/drawingml/2006/main" anchor="ctr"/>
+          <a:lstStyle xmlns:a="http://schemas.openxmlformats.org/drawingml/2006/main"/>
+          <a:p xmlns:a="http://schemas.openxmlformats.org/drawingml/2006/main">
+            <a:pPr algn="l">
+              <a:defRPr sz="1275" b="1">
+                <a:solidFill>
+                  <a:srgbClr val="25242B"/>
+                </a:solidFill>
+              </a:defRPr>
+            </a:pPr>
+            <a:r>
+              <a:rPr sz="1275" b="1">
+                <a:solidFill>
+                  <a:srgbClr val="25242B"/>
+                </a:solidFill>
+              </a:rPr>
+              <a:t>Sync Conflicts 与 Recoverable Drafts</a:t>
+            </a:r>
+          </a:p>
+        </p:txBody>
+      </p:sp>
+      <p:sp>
+        <p:nvSpPr>
+          <p:cNvPr id="48" name="">
+            <a:extLst xmlns:a="http://schemas.openxmlformats.org/drawingml/2006/main">
+              <a:ext uri="{FF2B5EF4-FFF2-40B4-BE49-F238E27FC236}">
+                <a16:creationId xmlns:a16="http://schemas.microsoft.com/office/drawing/2014/main" id="{FAD9EDEE-3352-4D6E-9C15-0C78EF64E1CB}"/>
+              </a:ext>
+            </a:extLst>
+          </p:cNvPr>
+          <p:cNvSpPr>
+            <a:spLocks xmlns:a="http://schemas.openxmlformats.org/drawingml/2006/main" noGrp="1"/>
+          </p:cNvSpPr>
+          <p:nvPr/>
+        </p:nvSpPr>
+        <p:spPr>
+          <a:xfrm xmlns:a="http://schemas.openxmlformats.org/drawingml/2006/main">
+            <a:off x="4705350" y="5337810"/>
+            <a:ext cx="6591300" cy="112395"/>
+          </a:xfrm>
+          <a:prstGeom xmlns:a="http://schemas.openxmlformats.org/drawingml/2006/main" prst="rect">
+            <a:avLst/>
+          </a:prstGeom>
+          <a:noFill xmlns:a="http://schemas.openxmlformats.org/drawingml/2006/main"/>
+          <a:ln xmlns:a="http://schemas.openxmlformats.org/drawingml/2006/main" w="0">
+            <a:noFill/>
+            <a:prstDash val="solid"/>
+          </a:ln>
+        </p:spPr>
+        <p:txBody>
+          <a:bodyPr xmlns:a="http://schemas.openxmlformats.org/drawingml/2006/main" anchor="ctr"/>
+          <a:lstStyle xmlns:a="http://schemas.openxmlformats.org/drawingml/2006/main"/>
+          <a:p xmlns:a="http://schemas.openxmlformats.org/drawingml/2006/main">
+            <a:pPr algn="l">
+              <a:defRPr sz="1200" b="0">
+                <a:solidFill>
+                  <a:srgbClr val="6F6C76"/>
+                </a:solidFill>
+              </a:defRPr>
+            </a:pPr>
+            <a:r>
+              <a:rPr sz="1200" b="0">
+                <a:solidFill>
+                  <a:srgbClr val="6F6C76"/>
+                </a:solidFill>
+              </a:rPr>
+              <a:t>三方合并展示 base/local/remote；同字段冲突必须选择，未完成草稿可在 IndexedDB/localStorage 恢复。</a:t>
+            </a:r>
+          </a:p>
+        </p:txBody>
+      </p:sp>
+      <p:sp>
+        <p:nvSpPr>
+          <p:cNvPr id="49" name="">
+            <a:extLst xmlns:a="http://schemas.openxmlformats.org/drawingml/2006/main">
+              <a:ext uri="{FF2B5EF4-FFF2-40B4-BE49-F238E27FC236}">
+                <a16:creationId xmlns:a16="http://schemas.microsoft.com/office/drawing/2014/main" id="{5D49BFE0-277E-4821-823F-5D8E4240D995}"/>
+              </a:ext>
+            </a:extLst>
+          </p:cNvPr>
+          <p:cNvSpPr>
+            <a:spLocks xmlns:a="http://schemas.openxmlformats.org/drawingml/2006/main" noGrp="1"/>
+          </p:cNvSpPr>
+          <p:nvPr/>
+        </p:nvSpPr>
+        <p:spPr>
+          <a:xfrm xmlns:a="http://schemas.openxmlformats.org/drawingml/2006/main">
+            <a:off x="704850" y="5659755"/>
+            <a:ext cx="10782300" cy="379095"/>
+          </a:xfrm>
+          <a:prstGeom xmlns:a="http://schemas.openxmlformats.org/drawingml/2006/main" prst="roundRect">
+            <a:avLst>
+              <a:gd name="adj" fmla="val 30151"/>
+            </a:avLst>
+          </a:prstGeom>
+          <a:solidFill xmlns:a="http://schemas.openxmlformats.org/drawingml/2006/main">
+            <a:srgbClr val="FFFFFF"/>
+          </a:solidFill>
+          <a:ln xmlns:a="http://schemas.openxmlformats.org/drawingml/2006/main" w="9525">
+            <a:solidFill>
+              <a:srgbClr val="D9D4CB"/>
+            </a:solidFill>
+            <a:prstDash val="solid"/>
+          </a:ln>
+        </p:spPr>
+      </p:sp>
+      <p:sp>
+        <p:nvSpPr>
+          <p:cNvPr id="50" name="">
+            <a:extLst xmlns:a="http://schemas.openxmlformats.org/drawingml/2006/main">
+              <a:ext uri="{FF2B5EF4-FFF2-40B4-BE49-F238E27FC236}">
+                <a16:creationId xmlns:a16="http://schemas.microsoft.com/office/drawing/2014/main" id="{78F71829-F434-4700-B616-55D81EECF789}"/>
+              </a:ext>
+            </a:extLst>
+          </p:cNvPr>
+          <p:cNvSpPr>
+            <a:spLocks xmlns:a="http://schemas.openxmlformats.org/drawingml/2006/main" noGrp="1"/>
+          </p:cNvSpPr>
+          <p:nvPr/>
+        </p:nvSpPr>
+        <p:spPr>
+          <a:xfrm xmlns:a="http://schemas.openxmlformats.org/drawingml/2006/main">
+            <a:off x="857250" y="5774055"/>
+            <a:ext cx="990600" cy="150495"/>
+          </a:xfrm>
+          <a:prstGeom xmlns:a="http://schemas.openxmlformats.org/drawingml/2006/main" prst="roundRect">
+            <a:avLst>
+              <a:gd name="adj" fmla="val 50000"/>
+            </a:avLst>
+          </a:prstGeom>
+          <a:solidFill xmlns:a="http://schemas.openxmlformats.org/drawingml/2006/main">
+            <a:srgbClr val="F6E7D7"/>
+          </a:solidFill>
+          <a:ln xmlns:a="http://schemas.openxmlformats.org/drawingml/2006/main" w="0">
+            <a:noFill/>
+            <a:prstDash val="solid"/>
+          </a:ln>
+        </p:spPr>
+      </p:sp>
+      <p:sp>
+        <p:nvSpPr>
+          <p:cNvPr id="51" name="">
+            <a:extLst xmlns:a="http://schemas.openxmlformats.org/drawingml/2006/main">
+              <a:ext uri="{FF2B5EF4-FFF2-40B4-BE49-F238E27FC236}">
+                <a16:creationId xmlns:a16="http://schemas.microsoft.com/office/drawing/2014/main" id="{C451A151-95A9-4A7E-B9F8-B5637903B419}"/>
+              </a:ext>
+            </a:extLst>
+          </p:cNvPr>
+          <p:cNvSpPr>
+            <a:spLocks xmlns:a="http://schemas.openxmlformats.org/drawingml/2006/main" noGrp="1"/>
+          </p:cNvSpPr>
+          <p:nvPr/>
+        </p:nvSpPr>
+        <p:spPr>
+          <a:xfrm xmlns:a="http://schemas.openxmlformats.org/drawingml/2006/main">
+            <a:off x="914400" y="5793105"/>
+            <a:ext cx="876300" cy="112395"/>
+          </a:xfrm>
+          <a:prstGeom xmlns:a="http://schemas.openxmlformats.org/drawingml/2006/main" prst="rect">
+            <a:avLst/>
+          </a:prstGeom>
+          <a:noFill xmlns:a="http://schemas.openxmlformats.org/drawingml/2006/main"/>
+          <a:ln xmlns:a="http://schemas.openxmlformats.org/drawingml/2006/main" w="0">
+            <a:noFill/>
+            <a:prstDash val="solid"/>
+          </a:ln>
+        </p:spPr>
+        <p:txBody>
+          <a:bodyPr xmlns:a="http://schemas.openxmlformats.org/drawingml/2006/main" anchor="ctr"/>
+          <a:lstStyle xmlns:a="http://schemas.openxmlformats.org/drawingml/2006/main"/>
+          <a:p xmlns:a="http://schemas.openxmlformats.org/drawingml/2006/main">
+            <a:pPr algn="ctr">
+              <a:defRPr sz="1200" b="1">
+                <a:solidFill>
+                  <a:srgbClr val="C77932"/>
+                </a:solidFill>
+              </a:defRPr>
+            </a:pPr>
+            <a:r>
+              <a:rPr sz="1200" b="1">
+                <a:solidFill>
+                  <a:srgbClr val="C77932"/>
+                </a:solidFill>
+              </a:rPr>
+              <a:t>部分实现</a:t>
+            </a:r>
+          </a:p>
+        </p:txBody>
+      </p:sp>
+      <p:sp>
+        <p:nvSpPr>
+          <p:cNvPr id="52" name="">
+            <a:extLst xmlns:a="http://schemas.openxmlformats.org/drawingml/2006/main">
+              <a:ext uri="{FF2B5EF4-FFF2-40B4-BE49-F238E27FC236}">
+                <a16:creationId xmlns:a16="http://schemas.microsoft.com/office/drawing/2014/main" id="{FFA13A75-A410-4B98-9FBE-4DD6359123D5}"/>
+              </a:ext>
+            </a:extLst>
+          </p:cNvPr>
+          <p:cNvSpPr>
+            <a:spLocks xmlns:a="http://schemas.openxmlformats.org/drawingml/2006/main" noGrp="1"/>
+          </p:cNvSpPr>
+          <p:nvPr/>
+        </p:nvSpPr>
+        <p:spPr>
+          <a:xfrm xmlns:a="http://schemas.openxmlformats.org/drawingml/2006/main">
+            <a:off x="2038350" y="5793105"/>
+            <a:ext cx="2476500" cy="112395"/>
+          </a:xfrm>
+          <a:prstGeom xmlns:a="http://schemas.openxmlformats.org/drawingml/2006/main" prst="rect">
+            <a:avLst/>
+          </a:prstGeom>
+          <a:noFill xmlns:a="http://schemas.openxmlformats.org/drawingml/2006/main"/>
+          <a:ln xmlns:a="http://schemas.openxmlformats.org/drawingml/2006/main" w="0">
+            <a:noFill/>
+            <a:prstDash val="solid"/>
+          </a:ln>
+        </p:spPr>
+        <p:txBody>
+          <a:bodyPr xmlns:a="http://schemas.openxmlformats.org/drawingml/2006/main" anchor="ctr"/>
+          <a:lstStyle xmlns:a="http://schemas.openxmlformats.org/drawingml/2006/main"/>
+          <a:p xmlns:a="http://schemas.openxmlformats.org/drawingml/2006/main">
+            <a:pPr algn="l">
+              <a:defRPr sz="1275" b="1">
+                <a:solidFill>
+                  <a:srgbClr val="25242B"/>
+                </a:solidFill>
+              </a:defRPr>
+            </a:pPr>
+            <a:r>
+              <a:rPr sz="1275" b="1">
+                <a:solidFill>
+                  <a:srgbClr val="25242B"/>
+                </a:solidFill>
+              </a:rPr>
+              <a:t>D1 本地自动化验收</a:t>
+            </a:r>
+          </a:p>
+        </p:txBody>
+      </p:sp>
+      <p:sp>
+        <p:nvSpPr>
+          <p:cNvPr id="53" name="">
+            <a:extLst xmlns:a="http://schemas.openxmlformats.org/drawingml/2006/main">
+              <a:ext uri="{FF2B5EF4-FFF2-40B4-BE49-F238E27FC236}">
+                <a16:creationId xmlns:a16="http://schemas.microsoft.com/office/drawing/2014/main" id="{CD74D0CA-62B6-4ACF-8982-AC3DE4A0719F}"/>
+              </a:ext>
+            </a:extLst>
+          </p:cNvPr>
+          <p:cNvSpPr>
+            <a:spLocks xmlns:a="http://schemas.openxmlformats.org/drawingml/2006/main" noGrp="1"/>
+          </p:cNvSpPr>
+          <p:nvPr/>
+        </p:nvSpPr>
+        <p:spPr>
+          <a:xfrm xmlns:a="http://schemas.openxmlformats.org/drawingml/2006/main">
+            <a:off x="4705350" y="5793105"/>
+            <a:ext cx="6591300" cy="112395"/>
+          </a:xfrm>
+          <a:prstGeom xmlns:a="http://schemas.openxmlformats.org/drawingml/2006/main" prst="rect">
+            <a:avLst/>
+          </a:prstGeom>
+          <a:noFill xmlns:a="http://schemas.openxmlformats.org/drawingml/2006/main"/>
+          <a:ln xmlns:a="http://schemas.openxmlformats.org/drawingml/2006/main" w="0">
+            <a:noFill/>
+            <a:prstDash val="solid"/>
+          </a:ln>
+        </p:spPr>
+        <p:txBody>
+          <a:bodyPr xmlns:a="http://schemas.openxmlformats.org/drawingml/2006/main" anchor="ctr"/>
+          <a:lstStyle xmlns:a="http://schemas.openxmlformats.org/drawingml/2006/main"/>
+          <a:p xmlns:a="http://schemas.openxmlformats.org/drawingml/2006/main">
+            <a:pPr algn="l">
+              <a:defRPr sz="1200" b="0">
+                <a:solidFill>
+                  <a:srgbClr val="6F6C76"/>
+                </a:solidFill>
+              </a:defRPr>
+            </a:pPr>
+            <a:r>
+              <a:rPr sz="1200" b="0">
+                <a:solidFill>
+                  <a:srgbClr val="6F6C76"/>
+                </a:solidFill>
+              </a:rPr>
+              <a:t>脚本映射 12 个 MVP 场景并运行 Swift/Web 本地检查，报告明确区分本地通过与 live gates。</a:t>
             </a:r>
           </a:p>
         </p:txBody>
@@ -8125,7 +8684,7 @@
     </p:spTree>
     <p:extLst>
       <p:ext uri="{BB962C8B-B14F-4D97-AF65-F5344CB8AC3E}">
-        <p14:creationId xmlns:p14="http://schemas.microsoft.com/office/powerpoint/2010/main" val="56201881"/>
+        <p14:creationId xmlns:p14="http://schemas.microsoft.com/office/powerpoint/2010/main" val="493896945"/>
       </p:ext>
     </p:extLst>
   </p:cSld>
@@ -8153,10 +8712,10 @@
       </p:grpSpPr>
       <p:sp>
         <p:nvSpPr>
-          <p:cNvPr id="1" name="">
-            <a:extLst xmlns:a="http://schemas.openxmlformats.org/drawingml/2006/main">
-              <a:ext uri="{FF2B5EF4-FFF2-40B4-BE49-F238E27FC236}">
-                <a16:creationId xmlns:a16="http://schemas.microsoft.com/office/drawing/2014/main" id="{12A8EFF3-4887-42C8-BEC5-BE4A443F9355}"/>
+          <p:cNvPr id="13" name="">
+            <a:extLst xmlns:a="http://schemas.openxmlformats.org/drawingml/2006/main">
+              <a:ext uri="{FF2B5EF4-FFF2-40B4-BE49-F238E27FC236}">
+                <a16:creationId xmlns:a16="http://schemas.microsoft.com/office/drawing/2014/main" id="{4508C4F0-777C-4297-8555-02027D03C8BF}"/>
               </a:ext>
             </a:extLst>
           </p:cNvPr>
@@ -8206,7 +8765,7 @@
           <p:cNvPr id="2" name="wide-title-2">
             <a:extLst xmlns:a="http://schemas.openxmlformats.org/drawingml/2006/main">
               <a:ext uri="{FF2B5EF4-FFF2-40B4-BE49-F238E27FC236}">
-                <a16:creationId xmlns:a16="http://schemas.microsoft.com/office/drawing/2014/main" id="{DAB06759-427B-4BD7-AC86-1A6EE7622766}"/>
+                <a16:creationId xmlns:a16="http://schemas.microsoft.com/office/drawing/2014/main" id="{8574F945-A734-4DCC-93B6-720CFA9D9E0F}"/>
               </a:ext>
             </a:extLst>
           </p:cNvPr>
@@ -8256,7 +8815,7 @@
           <p:cNvPr id="3" name="">
             <a:extLst xmlns:a="http://schemas.openxmlformats.org/drawingml/2006/main">
               <a:ext uri="{FF2B5EF4-FFF2-40B4-BE49-F238E27FC236}">
-                <a16:creationId xmlns:a16="http://schemas.microsoft.com/office/drawing/2014/main" id="{051FEB88-0548-4119-B9B0-5922E139D3A9}"/>
+                <a16:creationId xmlns:a16="http://schemas.microsoft.com/office/drawing/2014/main" id="{D22723EB-335D-4192-9F84-77908AF7E570}"/>
               </a:ext>
             </a:extLst>
           </p:cNvPr>
@@ -8306,7 +8865,7 @@
           <p:cNvPr id="4" name="">
             <a:extLst xmlns:a="http://schemas.openxmlformats.org/drawingml/2006/main">
               <a:ext uri="{FF2B5EF4-FFF2-40B4-BE49-F238E27FC236}">
-                <a16:creationId xmlns:a16="http://schemas.microsoft.com/office/drawing/2014/main" id="{1CF910BC-2BFC-4C8E-82E7-2B84EB5B99EE}"/>
+                <a16:creationId xmlns:a16="http://schemas.microsoft.com/office/drawing/2014/main" id="{F0223292-245F-40A4-9632-74FB9FF9A1E1}"/>
               </a:ext>
             </a:extLst>
           </p:cNvPr>
@@ -8337,7 +8896,7 @@
           <p:cNvPr id="5" name="">
             <a:extLst xmlns:a="http://schemas.openxmlformats.org/drawingml/2006/main">
               <a:ext uri="{FF2B5EF4-FFF2-40B4-BE49-F238E27FC236}">
-                <a16:creationId xmlns:a16="http://schemas.microsoft.com/office/drawing/2014/main" id="{45E9BDB0-3382-4CD2-BC22-7B9CD09ACB87}"/>
+                <a16:creationId xmlns:a16="http://schemas.microsoft.com/office/drawing/2014/main" id="{215F481B-E9C6-4B0C-B4A3-3F9181194137}"/>
               </a:ext>
             </a:extLst>
           </p:cNvPr>
@@ -8387,7 +8946,7 @@
           <p:cNvPr id="6" name="">
             <a:extLst xmlns:a="http://schemas.openxmlformats.org/drawingml/2006/main">
               <a:ext uri="{FF2B5EF4-FFF2-40B4-BE49-F238E27FC236}">
-                <a16:creationId xmlns:a16="http://schemas.microsoft.com/office/drawing/2014/main" id="{CB30250A-B964-49D8-9F28-0DB04A48B830}"/>
+                <a16:creationId xmlns:a16="http://schemas.microsoft.com/office/drawing/2014/main" id="{071479AD-8D8B-49D3-9109-AEB89EFADDF9}"/>
               </a:ext>
             </a:extLst>
           </p:cNvPr>
@@ -8437,7 +8996,7 @@
           <p:cNvPr id="7" name="">
             <a:extLst xmlns:a="http://schemas.openxmlformats.org/drawingml/2006/main">
               <a:ext uri="{FF2B5EF4-FFF2-40B4-BE49-F238E27FC236}">
-                <a16:creationId xmlns:a16="http://schemas.microsoft.com/office/drawing/2014/main" id="{CFDE6645-5CC1-458A-B752-5B03D3EBA9E3}"/>
+                <a16:creationId xmlns:a16="http://schemas.microsoft.com/office/drawing/2014/main" id="{B590A0E9-578C-447D-8B44-AFAD9A3C4DF8}"/>
               </a:ext>
             </a:extLst>
           </p:cNvPr>
@@ -8487,7 +9046,7 @@
           <p:cNvPr id="8" name="">
             <a:extLst xmlns:a="http://schemas.openxmlformats.org/drawingml/2006/main">
               <a:ext uri="{FF2B5EF4-FFF2-40B4-BE49-F238E27FC236}">
-                <a16:creationId xmlns:a16="http://schemas.microsoft.com/office/drawing/2014/main" id="{F215FFA0-7E5F-42B9-A375-DD186C91E5E4}"/>
+                <a16:creationId xmlns:a16="http://schemas.microsoft.com/office/drawing/2014/main" id="{7772A4E4-6193-4075-A5C0-35FDA65A42D0}"/>
               </a:ext>
             </a:extLst>
           </p:cNvPr>
@@ -8537,7 +9096,7 @@
           <p:cNvPr id="9" name="">
             <a:extLst xmlns:a="http://schemas.openxmlformats.org/drawingml/2006/main">
               <a:ext uri="{FF2B5EF4-FFF2-40B4-BE49-F238E27FC236}">
-                <a16:creationId xmlns:a16="http://schemas.microsoft.com/office/drawing/2014/main" id="{15A11BB6-6709-4820-96D2-A21855EF7925}"/>
+                <a16:creationId xmlns:a16="http://schemas.microsoft.com/office/drawing/2014/main" id="{AE8E2DEE-0DE6-4A4E-A85C-7A77FCCBB772}"/>
               </a:ext>
             </a:extLst>
           </p:cNvPr>
@@ -8587,7 +9146,7 @@
           <p:cNvPr id="10" name="">
             <a:extLst xmlns:a="http://schemas.openxmlformats.org/drawingml/2006/main">
               <a:ext uri="{FF2B5EF4-FFF2-40B4-BE49-F238E27FC236}">
-                <a16:creationId xmlns:a16="http://schemas.microsoft.com/office/drawing/2014/main" id="{4F1EAFCC-CC83-42FF-8CD0-8817B683A9E9}"/>
+                <a16:creationId xmlns:a16="http://schemas.microsoft.com/office/drawing/2014/main" id="{4473DF2E-3971-4120-A236-31B1F2530F2F}"/>
               </a:ext>
             </a:extLst>
           </p:cNvPr>
@@ -8637,7 +9196,7 @@
           <p:cNvPr id="11" name="">
             <a:extLst xmlns:a="http://schemas.openxmlformats.org/drawingml/2006/main">
               <a:ext uri="{FF2B5EF4-FFF2-40B4-BE49-F238E27FC236}">
-                <a16:creationId xmlns:a16="http://schemas.microsoft.com/office/drawing/2014/main" id="{FF920D24-128C-42C4-8452-0C416C70EA7A}"/>
+                <a16:creationId xmlns:a16="http://schemas.microsoft.com/office/drawing/2014/main" id="{7E356A42-8D66-4E37-97F5-F3DB18DFCE8C}"/>
               </a:ext>
             </a:extLst>
           </p:cNvPr>
@@ -8687,7 +9246,7 @@
           <p:cNvPr id="12" name="">
             <a:extLst xmlns:a="http://schemas.openxmlformats.org/drawingml/2006/main">
               <a:ext uri="{FF2B5EF4-FFF2-40B4-BE49-F238E27FC236}">
-                <a16:creationId xmlns:a16="http://schemas.microsoft.com/office/drawing/2014/main" id="{28469ED6-8E2D-44B6-AEBB-C19500E193A8}"/>
+                <a16:creationId xmlns:a16="http://schemas.microsoft.com/office/drawing/2014/main" id="{C6C07608-9634-4561-969B-82339A09DF2F}"/>
               </a:ext>
             </a:extLst>
           </p:cNvPr>
@@ -8735,7 +9294,7 @@
     </p:spTree>
     <p:extLst>
       <p:ext uri="{BB962C8B-B14F-4D97-AF65-F5344CB8AC3E}">
-        <p14:creationId xmlns:p14="http://schemas.microsoft.com/office/powerpoint/2010/main" val="1706029912"/>
+        <p14:creationId xmlns:p14="http://schemas.microsoft.com/office/powerpoint/2010/main" val="1786328200"/>
       </p:ext>
     </p:extLst>
   </p:cSld>
@@ -8763,10 +9322,10 @@
       </p:grpSpPr>
       <p:sp>
         <p:nvSpPr>
-          <p:cNvPr id="1" name="">
-            <a:extLst xmlns:a="http://schemas.openxmlformats.org/drawingml/2006/main">
-              <a:ext uri="{FF2B5EF4-FFF2-40B4-BE49-F238E27FC236}">
-                <a16:creationId xmlns:a16="http://schemas.microsoft.com/office/drawing/2014/main" id="{8B260F53-57AC-4B35-B994-A5A3AF5328FF}"/>
+          <p:cNvPr id="16" name="">
+            <a:extLst xmlns:a="http://schemas.openxmlformats.org/drawingml/2006/main">
+              <a:ext uri="{FF2B5EF4-FFF2-40B4-BE49-F238E27FC236}">
+                <a16:creationId xmlns:a16="http://schemas.microsoft.com/office/drawing/2014/main" id="{AD9D5F39-4777-422F-A756-B23C82F3204A}"/>
               </a:ext>
             </a:extLst>
           </p:cNvPr>
@@ -8816,7 +9375,7 @@
           <p:cNvPr id="2" name="wide-title-20">
             <a:extLst xmlns:a="http://schemas.openxmlformats.org/drawingml/2006/main">
               <a:ext uri="{FF2B5EF4-FFF2-40B4-BE49-F238E27FC236}">
-                <a16:creationId xmlns:a16="http://schemas.microsoft.com/office/drawing/2014/main" id="{7D97D9F7-431A-4A4A-9A0C-5C038D559701}"/>
+                <a16:creationId xmlns:a16="http://schemas.microsoft.com/office/drawing/2014/main" id="{77A626B0-2B11-4552-A1AD-AF3886110BEA}"/>
               </a:ext>
             </a:extLst>
           </p:cNvPr>
@@ -8866,7 +9425,7 @@
           <p:cNvPr id="3" name="">
             <a:extLst xmlns:a="http://schemas.openxmlformats.org/drawingml/2006/main">
               <a:ext uri="{FF2B5EF4-FFF2-40B4-BE49-F238E27FC236}">
-                <a16:creationId xmlns:a16="http://schemas.microsoft.com/office/drawing/2014/main" id="{3B182E08-9BAC-4265-B513-27A540E7B05B}"/>
+                <a16:creationId xmlns:a16="http://schemas.microsoft.com/office/drawing/2014/main" id="{EFF0A679-4B11-4360-953D-A5F53D4A127D}"/>
               </a:ext>
             </a:extLst>
           </p:cNvPr>
@@ -8916,7 +9475,7 @@
           <p:cNvPr id="4" name="">
             <a:extLst xmlns:a="http://schemas.openxmlformats.org/drawingml/2006/main">
               <a:ext uri="{FF2B5EF4-FFF2-40B4-BE49-F238E27FC236}">
-                <a16:creationId xmlns:a16="http://schemas.microsoft.com/office/drawing/2014/main" id="{A3DBA3EA-6D01-40DA-BF89-880D6928BF26}"/>
+                <a16:creationId xmlns:a16="http://schemas.microsoft.com/office/drawing/2014/main" id="{BA372265-B99B-4B07-8982-B5EED471FD5C}"/>
               </a:ext>
             </a:extLst>
           </p:cNvPr>
@@ -8947,7 +9506,7 @@
           <p:cNvPr id="5" name="">
             <a:extLst xmlns:a="http://schemas.openxmlformats.org/drawingml/2006/main">
               <a:ext uri="{FF2B5EF4-FFF2-40B4-BE49-F238E27FC236}">
-                <a16:creationId xmlns:a16="http://schemas.microsoft.com/office/drawing/2014/main" id="{C9F5E881-9F72-4935-B643-274EE8C83952}"/>
+                <a16:creationId xmlns:a16="http://schemas.microsoft.com/office/drawing/2014/main" id="{D9D77341-0673-4BA1-982F-90E3A49D34C6}"/>
               </a:ext>
             </a:extLst>
           </p:cNvPr>
@@ -8997,7 +9556,7 @@
           <p:cNvPr id="6" name="">
             <a:extLst xmlns:a="http://schemas.openxmlformats.org/drawingml/2006/main">
               <a:ext uri="{FF2B5EF4-FFF2-40B4-BE49-F238E27FC236}">
-                <a16:creationId xmlns:a16="http://schemas.microsoft.com/office/drawing/2014/main" id="{4C4E74EF-8817-4494-8E8C-4A2A9D66F842}"/>
+                <a16:creationId xmlns:a16="http://schemas.microsoft.com/office/drawing/2014/main" id="{014F9EAC-DB35-427F-9476-DB4FDE5AB80E}"/>
               </a:ext>
             </a:extLst>
           </p:cNvPr>
@@ -9047,7 +9606,7 @@
           <p:cNvPr id="7" name="">
             <a:extLst xmlns:a="http://schemas.openxmlformats.org/drawingml/2006/main">
               <a:ext uri="{FF2B5EF4-FFF2-40B4-BE49-F238E27FC236}">
-                <a16:creationId xmlns:a16="http://schemas.microsoft.com/office/drawing/2014/main" id="{D95CF592-79F0-497D-8087-A5E878A195AC}"/>
+                <a16:creationId xmlns:a16="http://schemas.microsoft.com/office/drawing/2014/main" id="{2B578675-1577-4D31-AD6E-89D8C9092CBC}"/>
               </a:ext>
             </a:extLst>
           </p:cNvPr>
@@ -9080,7 +9639,7 @@
           <p:cNvPr id="8" name="">
             <a:extLst xmlns:a="http://schemas.openxmlformats.org/drawingml/2006/main">
               <a:ext uri="{FF2B5EF4-FFF2-40B4-BE49-F238E27FC236}">
-                <a16:creationId xmlns:a16="http://schemas.microsoft.com/office/drawing/2014/main" id="{382BEC49-0C38-4183-8244-54A29F0C3758}"/>
+                <a16:creationId xmlns:a16="http://schemas.microsoft.com/office/drawing/2014/main" id="{6C7A805A-5E48-48FF-A8D2-85D08B9052D4}"/>
               </a:ext>
             </a:extLst>
           </p:cNvPr>
@@ -9130,7 +9689,7 @@
           <p:cNvPr id="9" name="">
             <a:extLst xmlns:a="http://schemas.openxmlformats.org/drawingml/2006/main">
               <a:ext uri="{FF2B5EF4-FFF2-40B4-BE49-F238E27FC236}">
-                <a16:creationId xmlns:a16="http://schemas.microsoft.com/office/drawing/2014/main" id="{3BF76131-8B43-44C5-82EF-C5E590FDA6BB}"/>
+                <a16:creationId xmlns:a16="http://schemas.microsoft.com/office/drawing/2014/main" id="{84C2496B-B96E-4682-B08D-9180B38171F4}"/>
               </a:ext>
             </a:extLst>
           </p:cNvPr>
@@ -9163,7 +9722,7 @@
           <p:cNvPr id="10" name="">
             <a:extLst xmlns:a="http://schemas.openxmlformats.org/drawingml/2006/main">
               <a:ext uri="{FF2B5EF4-FFF2-40B4-BE49-F238E27FC236}">
-                <a16:creationId xmlns:a16="http://schemas.microsoft.com/office/drawing/2014/main" id="{85BA1F5B-370F-420B-A2CC-710077DD4FC4}"/>
+                <a16:creationId xmlns:a16="http://schemas.microsoft.com/office/drawing/2014/main" id="{B1BBFF33-0268-46CC-A12F-C8FDAAA9EF2C}"/>
               </a:ext>
             </a:extLst>
           </p:cNvPr>
@@ -9213,7 +9772,7 @@
           <p:cNvPr id="11" name="">
             <a:extLst xmlns:a="http://schemas.openxmlformats.org/drawingml/2006/main">
               <a:ext uri="{FF2B5EF4-FFF2-40B4-BE49-F238E27FC236}">
-                <a16:creationId xmlns:a16="http://schemas.microsoft.com/office/drawing/2014/main" id="{B5AB369A-02AA-4434-8349-0A86F2B20C85}"/>
+                <a16:creationId xmlns:a16="http://schemas.microsoft.com/office/drawing/2014/main" id="{1855DB28-7BE3-47DC-8540-A59B5E4B0D0D}"/>
               </a:ext>
             </a:extLst>
           </p:cNvPr>
@@ -9246,7 +9805,7 @@
           <p:cNvPr id="12" name="">
             <a:extLst xmlns:a="http://schemas.openxmlformats.org/drawingml/2006/main">
               <a:ext uri="{FF2B5EF4-FFF2-40B4-BE49-F238E27FC236}">
-                <a16:creationId xmlns:a16="http://schemas.microsoft.com/office/drawing/2014/main" id="{2F7F3C92-C077-478F-92D9-67F6D313B520}"/>
+                <a16:creationId xmlns:a16="http://schemas.microsoft.com/office/drawing/2014/main" id="{92F9029D-E3FC-46F2-8E9F-09064545D4A6}"/>
               </a:ext>
             </a:extLst>
           </p:cNvPr>
@@ -9296,7 +9855,7 @@
           <p:cNvPr id="13" name="">
             <a:extLst xmlns:a="http://schemas.openxmlformats.org/drawingml/2006/main">
               <a:ext uri="{FF2B5EF4-FFF2-40B4-BE49-F238E27FC236}">
-                <a16:creationId xmlns:a16="http://schemas.microsoft.com/office/drawing/2014/main" id="{7A592AC2-9789-414A-9946-56AFCA80A2BA}"/>
+                <a16:creationId xmlns:a16="http://schemas.microsoft.com/office/drawing/2014/main" id="{A0485C44-AC2D-4A7E-9111-19A997821A64}"/>
               </a:ext>
             </a:extLst>
           </p:cNvPr>
@@ -9329,7 +9888,7 @@
           <p:cNvPr id="14" name="">
             <a:extLst xmlns:a="http://schemas.openxmlformats.org/drawingml/2006/main">
               <a:ext uri="{FF2B5EF4-FFF2-40B4-BE49-F238E27FC236}">
-                <a16:creationId xmlns:a16="http://schemas.microsoft.com/office/drawing/2014/main" id="{3222AFC9-D8DF-43BB-A993-3840F30DC5BA}"/>
+                <a16:creationId xmlns:a16="http://schemas.microsoft.com/office/drawing/2014/main" id="{C9F68685-249C-4381-8423-C9B7AF949F15}"/>
               </a:ext>
             </a:extLst>
           </p:cNvPr>
@@ -9379,7 +9938,7 @@
           <p:cNvPr id="15" name="">
             <a:extLst xmlns:a="http://schemas.openxmlformats.org/drawingml/2006/main">
               <a:ext uri="{FF2B5EF4-FFF2-40B4-BE49-F238E27FC236}">
-                <a16:creationId xmlns:a16="http://schemas.microsoft.com/office/drawing/2014/main" id="{469847B2-F9B2-4117-A535-4D1C1DF26485}"/>
+                <a16:creationId xmlns:a16="http://schemas.microsoft.com/office/drawing/2014/main" id="{E85A0D99-5D60-4763-97E6-A8E51C8F888A}"/>
               </a:ext>
             </a:extLst>
           </p:cNvPr>
@@ -9419,7 +9978,7 @@
                   <a:srgbClr val="6F6C76"/>
                 </a:solidFill>
               </a:rPr>
-              <a:t>50 tests executed, 49 passed, 1 known assertion failure · commit a6c707e</a:t>
+              <a:t>Swift 446 tests / 0 failures; Web npm test 63 / 63; build and lint pass; D1 local mappings pass while live gates remain blocked · commit d476f32</a:t>
             </a:r>
           </a:p>
         </p:txBody>
@@ -9427,7 +9986,7 @@
     </p:spTree>
     <p:extLst>
       <p:ext uri="{BB962C8B-B14F-4D97-AF65-F5344CB8AC3E}">
-        <p14:creationId xmlns:p14="http://schemas.microsoft.com/office/powerpoint/2010/main" val="184798769"/>
+        <p14:creationId xmlns:p14="http://schemas.microsoft.com/office/powerpoint/2010/main" val="1614920078"/>
       </p:ext>
     </p:extLst>
   </p:cSld>
@@ -9455,10 +10014,10 @@
       </p:grpSpPr>
       <p:sp>
         <p:nvSpPr>
-          <p:cNvPr id="1" name="">
-            <a:extLst xmlns:a="http://schemas.openxmlformats.org/drawingml/2006/main">
-              <a:ext uri="{FF2B5EF4-FFF2-40B4-BE49-F238E27FC236}">
-                <a16:creationId xmlns:a16="http://schemas.microsoft.com/office/drawing/2014/main" id="{42263253-E345-4680-A836-75843B505AFE}"/>
+          <p:cNvPr id="7" name="">
+            <a:extLst xmlns:a="http://schemas.openxmlformats.org/drawingml/2006/main">
+              <a:ext uri="{FF2B5EF4-FFF2-40B4-BE49-F238E27FC236}">
+                <a16:creationId xmlns:a16="http://schemas.microsoft.com/office/drawing/2014/main" id="{B32EFA0F-66C0-4340-A3F1-4D798C94113E}"/>
               </a:ext>
             </a:extLst>
           </p:cNvPr>
@@ -9508,7 +10067,7 @@
           <p:cNvPr id="2" name="wide-title-3">
             <a:extLst xmlns:a="http://schemas.openxmlformats.org/drawingml/2006/main">
               <a:ext uri="{FF2B5EF4-FFF2-40B4-BE49-F238E27FC236}">
-                <a16:creationId xmlns:a16="http://schemas.microsoft.com/office/drawing/2014/main" id="{0CA7B709-185F-43A3-B08A-D84C8D7DEFCF}"/>
+                <a16:creationId xmlns:a16="http://schemas.microsoft.com/office/drawing/2014/main" id="{1E8C7300-2CAA-4082-B777-793B95C9B04C}"/>
               </a:ext>
             </a:extLst>
           </p:cNvPr>
@@ -9558,7 +10117,7 @@
           <p:cNvPr id="3" name="">
             <a:extLst xmlns:a="http://schemas.openxmlformats.org/drawingml/2006/main">
               <a:ext uri="{FF2B5EF4-FFF2-40B4-BE49-F238E27FC236}">
-                <a16:creationId xmlns:a16="http://schemas.microsoft.com/office/drawing/2014/main" id="{CF046006-F0A6-475D-8C01-A4BDAF766C02}"/>
+                <a16:creationId xmlns:a16="http://schemas.microsoft.com/office/drawing/2014/main" id="{D44120F8-0B48-4F4A-A505-1AE4FEB95C0D}"/>
               </a:ext>
             </a:extLst>
           </p:cNvPr>
@@ -9608,7 +10167,7 @@
           <p:cNvPr id="4" name="">
             <a:extLst xmlns:a="http://schemas.openxmlformats.org/drawingml/2006/main">
               <a:ext uri="{FF2B5EF4-FFF2-40B4-BE49-F238E27FC236}">
-                <a16:creationId xmlns:a16="http://schemas.microsoft.com/office/drawing/2014/main" id="{2CB39877-B1CC-4BEC-A09B-3608530ADB06}"/>
+                <a16:creationId xmlns:a16="http://schemas.microsoft.com/office/drawing/2014/main" id="{BD8A8049-C444-4698-AEF8-C3D041B48EF4}"/>
               </a:ext>
             </a:extLst>
           </p:cNvPr>
@@ -9647,13 +10206,13 @@
           <p:nvPr/>
         </p:nvPicPr>
         <p:blipFill>
-          <a:blip xmlns:r="http://schemas.openxmlformats.org/officeDocument/2006/relationships" xmlns:a="http://schemas.openxmlformats.org/drawingml/2006/main" r:embed="R71d0615085094191"/>
+          <a:blip xmlns:r="http://schemas.openxmlformats.org/officeDocument/2006/relationships" xmlns:a="http://schemas.openxmlformats.org/drawingml/2006/main" r:embed="R029ca8447b904bca"/>
           <a:stretch xmlns:a="http://schemas.openxmlformats.org/drawingml/2006/main"/>
         </p:blipFill>
         <p:spPr>
           <a:xfrm xmlns:a="http://schemas.openxmlformats.org/drawingml/2006/main">
-            <a:off x="933450" y="2969355"/>
-            <a:ext cx="10325100" cy="1452691"/>
+            <a:off x="933450" y="3079319"/>
+            <a:ext cx="10325100" cy="1232761"/>
           </a:xfrm>
           <a:prstGeom xmlns:a="http://schemas.openxmlformats.org/drawingml/2006/main" prst="rect">
             <a:avLst/>
@@ -9665,7 +10224,7 @@
           <p:cNvPr id="6" name="">
             <a:extLst xmlns:a="http://schemas.openxmlformats.org/drawingml/2006/main">
               <a:ext uri="{FF2B5EF4-FFF2-40B4-BE49-F238E27FC236}">
-                <a16:creationId xmlns:a16="http://schemas.microsoft.com/office/drawing/2014/main" id="{5F92E9F0-D2D6-4BC1-95C4-1EF90304FC98}"/>
+                <a16:creationId xmlns:a16="http://schemas.microsoft.com/office/drawing/2014/main" id="{9FD79CB3-E909-4D2E-9F37-3CAED46509E7}"/>
               </a:ext>
             </a:extLst>
           </p:cNvPr>
@@ -9713,7 +10272,7 @@
     </p:spTree>
     <p:extLst>
       <p:ext uri="{BB962C8B-B14F-4D97-AF65-F5344CB8AC3E}">
-        <p14:creationId xmlns:p14="http://schemas.microsoft.com/office/powerpoint/2010/main" val="792826347"/>
+        <p14:creationId xmlns:p14="http://schemas.microsoft.com/office/powerpoint/2010/main" val="1403999287"/>
       </p:ext>
     </p:extLst>
   </p:cSld>
@@ -9741,10 +10300,10 @@
       </p:grpSpPr>
       <p:sp>
         <p:nvSpPr>
-          <p:cNvPr id="1" name="">
-            <a:extLst xmlns:a="http://schemas.openxmlformats.org/drawingml/2006/main">
-              <a:ext uri="{FF2B5EF4-FFF2-40B4-BE49-F238E27FC236}">
-                <a16:creationId xmlns:a16="http://schemas.microsoft.com/office/drawing/2014/main" id="{E4D8E45C-07D7-46DF-B450-4A02D7A84C5F}"/>
+          <p:cNvPr id="18" name="">
+            <a:extLst xmlns:a="http://schemas.openxmlformats.org/drawingml/2006/main">
+              <a:ext uri="{FF2B5EF4-FFF2-40B4-BE49-F238E27FC236}">
+                <a16:creationId xmlns:a16="http://schemas.microsoft.com/office/drawing/2014/main" id="{5ACDC140-3FF0-4415-9630-5BDABDFB9B82}"/>
               </a:ext>
             </a:extLst>
           </p:cNvPr>
@@ -9794,7 +10353,7 @@
           <p:cNvPr id="2" name="wide-title-4">
             <a:extLst xmlns:a="http://schemas.openxmlformats.org/drawingml/2006/main">
               <a:ext uri="{FF2B5EF4-FFF2-40B4-BE49-F238E27FC236}">
-                <a16:creationId xmlns:a16="http://schemas.microsoft.com/office/drawing/2014/main" id="{1228FC1B-735D-4347-AED8-B9B9F2FA4158}"/>
+                <a16:creationId xmlns:a16="http://schemas.microsoft.com/office/drawing/2014/main" id="{1B36C492-D67A-48C7-82DA-6CD04375765B}"/>
               </a:ext>
             </a:extLst>
           </p:cNvPr>
@@ -9844,7 +10403,7 @@
           <p:cNvPr id="3" name="">
             <a:extLst xmlns:a="http://schemas.openxmlformats.org/drawingml/2006/main">
               <a:ext uri="{FF2B5EF4-FFF2-40B4-BE49-F238E27FC236}">
-                <a16:creationId xmlns:a16="http://schemas.microsoft.com/office/drawing/2014/main" id="{1C554F2F-8BDB-4993-B014-8A6435F7D00A}"/>
+                <a16:creationId xmlns:a16="http://schemas.microsoft.com/office/drawing/2014/main" id="{3F5AE6C3-6BCF-491B-AA06-A30B11402120}"/>
               </a:ext>
             </a:extLst>
           </p:cNvPr>
@@ -9894,7 +10453,7 @@
           <p:cNvPr id="4" name="">
             <a:extLst xmlns:a="http://schemas.openxmlformats.org/drawingml/2006/main">
               <a:ext uri="{FF2B5EF4-FFF2-40B4-BE49-F238E27FC236}">
-                <a16:creationId xmlns:a16="http://schemas.microsoft.com/office/drawing/2014/main" id="{D1AFA830-9560-4A4B-9247-3F8E43FDCFFE}"/>
+                <a16:creationId xmlns:a16="http://schemas.microsoft.com/office/drawing/2014/main" id="{B421AA18-1982-4ABB-9663-EEA963304B7C}"/>
               </a:ext>
             </a:extLst>
           </p:cNvPr>
@@ -9927,7 +10486,7 @@
           <p:cNvPr id="5" name="">
             <a:extLst xmlns:a="http://schemas.openxmlformats.org/drawingml/2006/main">
               <a:ext uri="{FF2B5EF4-FFF2-40B4-BE49-F238E27FC236}">
-                <a16:creationId xmlns:a16="http://schemas.microsoft.com/office/drawing/2014/main" id="{867AFC61-43D0-49F5-94D7-DF6356904C58}"/>
+                <a16:creationId xmlns:a16="http://schemas.microsoft.com/office/drawing/2014/main" id="{1D1A76ED-594D-4930-AE06-1A68EBCBEB9C}"/>
               </a:ext>
             </a:extLst>
           </p:cNvPr>
@@ -9977,7 +10536,7 @@
           <p:cNvPr id="6" name="">
             <a:extLst xmlns:a="http://schemas.openxmlformats.org/drawingml/2006/main">
               <a:ext uri="{FF2B5EF4-FFF2-40B4-BE49-F238E27FC236}">
-                <a16:creationId xmlns:a16="http://schemas.microsoft.com/office/drawing/2014/main" id="{8A9E13EC-0A20-4BFB-9DA8-8BA72ECB88B7}"/>
+                <a16:creationId xmlns:a16="http://schemas.microsoft.com/office/drawing/2014/main" id="{BD9B136C-9FB1-4E6A-8BB8-E2C46ADEB2A2}"/>
               </a:ext>
             </a:extLst>
           </p:cNvPr>
@@ -10010,7 +10569,7 @@
           <p:cNvPr id="7" name="">
             <a:extLst xmlns:a="http://schemas.openxmlformats.org/drawingml/2006/main">
               <a:ext uri="{FF2B5EF4-FFF2-40B4-BE49-F238E27FC236}">
-                <a16:creationId xmlns:a16="http://schemas.microsoft.com/office/drawing/2014/main" id="{4E07F19D-D0DC-4AFE-8006-EB5EC2F3C722}"/>
+                <a16:creationId xmlns:a16="http://schemas.microsoft.com/office/drawing/2014/main" id="{47A592FF-44DE-4383-A9BA-F39190E397D2}"/>
               </a:ext>
             </a:extLst>
           </p:cNvPr>
@@ -10060,7 +10619,7 @@
           <p:cNvPr id="8" name="">
             <a:extLst xmlns:a="http://schemas.openxmlformats.org/drawingml/2006/main">
               <a:ext uri="{FF2B5EF4-FFF2-40B4-BE49-F238E27FC236}">
-                <a16:creationId xmlns:a16="http://schemas.microsoft.com/office/drawing/2014/main" id="{BC585C27-7312-4064-BF1C-3A16DB542676}"/>
+                <a16:creationId xmlns:a16="http://schemas.microsoft.com/office/drawing/2014/main" id="{9D1CB310-851E-4717-A29C-184C809DA92E}"/>
               </a:ext>
             </a:extLst>
           </p:cNvPr>
@@ -10093,7 +10652,7 @@
           <p:cNvPr id="9" name="">
             <a:extLst xmlns:a="http://schemas.openxmlformats.org/drawingml/2006/main">
               <a:ext uri="{FF2B5EF4-FFF2-40B4-BE49-F238E27FC236}">
-                <a16:creationId xmlns:a16="http://schemas.microsoft.com/office/drawing/2014/main" id="{6CD7ED4C-20A6-4954-A434-737463E584A8}"/>
+                <a16:creationId xmlns:a16="http://schemas.microsoft.com/office/drawing/2014/main" id="{4DCB633C-562E-4792-AFC4-676B0B6EAEBD}"/>
               </a:ext>
             </a:extLst>
           </p:cNvPr>
@@ -10143,7 +10702,7 @@
           <p:cNvPr id="10" name="">
             <a:extLst xmlns:a="http://schemas.openxmlformats.org/drawingml/2006/main">
               <a:ext uri="{FF2B5EF4-FFF2-40B4-BE49-F238E27FC236}">
-                <a16:creationId xmlns:a16="http://schemas.microsoft.com/office/drawing/2014/main" id="{31BF89A3-30C1-4D84-992E-8C1005D470FC}"/>
+                <a16:creationId xmlns:a16="http://schemas.microsoft.com/office/drawing/2014/main" id="{8A52E780-F6A6-4149-AF3D-98E4382FABA3}"/>
               </a:ext>
             </a:extLst>
           </p:cNvPr>
@@ -10174,7 +10733,7 @@
           <p:cNvPr id="11" name="">
             <a:extLst xmlns:a="http://schemas.openxmlformats.org/drawingml/2006/main">
               <a:ext uri="{FF2B5EF4-FFF2-40B4-BE49-F238E27FC236}">
-                <a16:creationId xmlns:a16="http://schemas.microsoft.com/office/drawing/2014/main" id="{E92BA01A-9EB8-486A-A064-A0EC257ABFE0}"/>
+                <a16:creationId xmlns:a16="http://schemas.microsoft.com/office/drawing/2014/main" id="{DB9CAC2A-60FE-4B7F-92E7-EAC48D0D0E6C}"/>
               </a:ext>
             </a:extLst>
           </p:cNvPr>
@@ -10207,7 +10766,7 @@
           <p:cNvPr id="12" name="">
             <a:extLst xmlns:a="http://schemas.openxmlformats.org/drawingml/2006/main">
               <a:ext uri="{FF2B5EF4-FFF2-40B4-BE49-F238E27FC236}">
-                <a16:creationId xmlns:a16="http://schemas.microsoft.com/office/drawing/2014/main" id="{DC56218E-9A9C-4B99-98AC-B753B6852570}"/>
+                <a16:creationId xmlns:a16="http://schemas.microsoft.com/office/drawing/2014/main" id="{4A199D0C-03DB-4D8F-AAD5-BE07090F0679}"/>
               </a:ext>
             </a:extLst>
           </p:cNvPr>
@@ -10257,7 +10816,7 @@
           <p:cNvPr id="13" name="">
             <a:extLst xmlns:a="http://schemas.openxmlformats.org/drawingml/2006/main">
               <a:ext uri="{FF2B5EF4-FFF2-40B4-BE49-F238E27FC236}">
-                <a16:creationId xmlns:a16="http://schemas.microsoft.com/office/drawing/2014/main" id="{F5E252F5-4FD7-4869-A8F2-C9AE273BCF12}"/>
+                <a16:creationId xmlns:a16="http://schemas.microsoft.com/office/drawing/2014/main" id="{D36F2BFA-A6B1-4109-AA17-569417F1ACC0}"/>
               </a:ext>
             </a:extLst>
           </p:cNvPr>
@@ -10290,7 +10849,7 @@
           <p:cNvPr id="14" name="">
             <a:extLst xmlns:a="http://schemas.openxmlformats.org/drawingml/2006/main">
               <a:ext uri="{FF2B5EF4-FFF2-40B4-BE49-F238E27FC236}">
-                <a16:creationId xmlns:a16="http://schemas.microsoft.com/office/drawing/2014/main" id="{66747EF5-2ACD-46FE-ABF0-6717FABEAD5D}"/>
+                <a16:creationId xmlns:a16="http://schemas.microsoft.com/office/drawing/2014/main" id="{522E74BF-3FB4-4389-AAFD-85E0FAE1E472}"/>
               </a:ext>
             </a:extLst>
           </p:cNvPr>
@@ -10340,7 +10899,7 @@
           <p:cNvPr id="15" name="">
             <a:extLst xmlns:a="http://schemas.openxmlformats.org/drawingml/2006/main">
               <a:ext uri="{FF2B5EF4-FFF2-40B4-BE49-F238E27FC236}">
-                <a16:creationId xmlns:a16="http://schemas.microsoft.com/office/drawing/2014/main" id="{66C4D19B-20FC-446C-9FC3-4262705F2BF6}"/>
+                <a16:creationId xmlns:a16="http://schemas.microsoft.com/office/drawing/2014/main" id="{23616A74-4D91-4E98-A729-41E8E5210BEA}"/>
               </a:ext>
             </a:extLst>
           </p:cNvPr>
@@ -10373,7 +10932,7 @@
           <p:cNvPr id="16" name="">
             <a:extLst xmlns:a="http://schemas.openxmlformats.org/drawingml/2006/main">
               <a:ext uri="{FF2B5EF4-FFF2-40B4-BE49-F238E27FC236}">
-                <a16:creationId xmlns:a16="http://schemas.microsoft.com/office/drawing/2014/main" id="{52000E8D-C102-4A1C-ABB8-1A0F6DB99D44}"/>
+                <a16:creationId xmlns:a16="http://schemas.microsoft.com/office/drawing/2014/main" id="{3B908D96-3ED5-4018-A651-10D46CADA7E2}"/>
               </a:ext>
             </a:extLst>
           </p:cNvPr>
@@ -10423,7 +10982,7 @@
           <p:cNvPr id="17" name="">
             <a:extLst xmlns:a="http://schemas.openxmlformats.org/drawingml/2006/main">
               <a:ext uri="{FF2B5EF4-FFF2-40B4-BE49-F238E27FC236}">
-                <a16:creationId xmlns:a16="http://schemas.microsoft.com/office/drawing/2014/main" id="{E2B7324E-DF17-48B7-917F-BB3656C4D51E}"/>
+                <a16:creationId xmlns:a16="http://schemas.microsoft.com/office/drawing/2014/main" id="{5F758299-A426-4A02-BDC7-984565867328}"/>
               </a:ext>
             </a:extLst>
           </p:cNvPr>
@@ -10471,7 +11030,7 @@
     </p:spTree>
     <p:extLst>
       <p:ext uri="{BB962C8B-B14F-4D97-AF65-F5344CB8AC3E}">
-        <p14:creationId xmlns:p14="http://schemas.microsoft.com/office/powerpoint/2010/main" val="177713792"/>
+        <p14:creationId xmlns:p14="http://schemas.microsoft.com/office/powerpoint/2010/main" val="1082303474"/>
       </p:ext>
     </p:extLst>
   </p:cSld>
@@ -10499,10 +11058,10 @@
       </p:grpSpPr>
       <p:sp>
         <p:nvSpPr>
-          <p:cNvPr id="1" name="">
-            <a:extLst xmlns:a="http://schemas.openxmlformats.org/drawingml/2006/main">
-              <a:ext uri="{FF2B5EF4-FFF2-40B4-BE49-F238E27FC236}">
-                <a16:creationId xmlns:a16="http://schemas.microsoft.com/office/drawing/2014/main" id="{DC9571DB-3892-42E4-B323-630E40C79F36}"/>
+          <p:cNvPr id="23" name="">
+            <a:extLst xmlns:a="http://schemas.openxmlformats.org/drawingml/2006/main">
+              <a:ext uri="{FF2B5EF4-FFF2-40B4-BE49-F238E27FC236}">
+                <a16:creationId xmlns:a16="http://schemas.microsoft.com/office/drawing/2014/main" id="{79F22355-77D1-4EF6-8311-E63D4EA29A5E}"/>
               </a:ext>
             </a:extLst>
           </p:cNvPr>
@@ -10552,7 +11111,7 @@
           <p:cNvPr id="2" name="wide-title-5">
             <a:extLst xmlns:a="http://schemas.openxmlformats.org/drawingml/2006/main">
               <a:ext uri="{FF2B5EF4-FFF2-40B4-BE49-F238E27FC236}">
-                <a16:creationId xmlns:a16="http://schemas.microsoft.com/office/drawing/2014/main" id="{9C2F34C3-32FE-41D0-9633-F7DFE7C78ADD}"/>
+                <a16:creationId xmlns:a16="http://schemas.microsoft.com/office/drawing/2014/main" id="{7156160D-FE2C-4F74-ACA0-22A341E15514}"/>
               </a:ext>
             </a:extLst>
           </p:cNvPr>
@@ -10602,7 +11161,7 @@
           <p:cNvPr id="3" name="">
             <a:extLst xmlns:a="http://schemas.openxmlformats.org/drawingml/2006/main">
               <a:ext uri="{FF2B5EF4-FFF2-40B4-BE49-F238E27FC236}">
-                <a16:creationId xmlns:a16="http://schemas.microsoft.com/office/drawing/2014/main" id="{10392AB2-DA81-4366-92B5-60EC6D1957C2}"/>
+                <a16:creationId xmlns:a16="http://schemas.microsoft.com/office/drawing/2014/main" id="{82E2BA67-BA18-494F-A8AA-D07EEB5F5439}"/>
               </a:ext>
             </a:extLst>
           </p:cNvPr>
@@ -10652,7 +11211,7 @@
           <p:cNvPr id="4" name="">
             <a:extLst xmlns:a="http://schemas.openxmlformats.org/drawingml/2006/main">
               <a:ext uri="{FF2B5EF4-FFF2-40B4-BE49-F238E27FC236}">
-                <a16:creationId xmlns:a16="http://schemas.microsoft.com/office/drawing/2014/main" id="{F72B02D3-6AB5-4821-9A47-4AC13723FEC7}"/>
+                <a16:creationId xmlns:a16="http://schemas.microsoft.com/office/drawing/2014/main" id="{B8FE8FF9-8AF1-4003-A7F8-54553838F315}"/>
               </a:ext>
             </a:extLst>
           </p:cNvPr>
@@ -10702,7 +11261,7 @@
           <p:cNvPr id="5" name="">
             <a:extLst xmlns:a="http://schemas.openxmlformats.org/drawingml/2006/main">
               <a:ext uri="{FF2B5EF4-FFF2-40B4-BE49-F238E27FC236}">
-                <a16:creationId xmlns:a16="http://schemas.microsoft.com/office/drawing/2014/main" id="{A4B5AE81-6A2E-404B-BFAA-4C5E2ED087C4}"/>
+                <a16:creationId xmlns:a16="http://schemas.microsoft.com/office/drawing/2014/main" id="{B18034A9-2D04-4020-8EBF-C26DA7EFE108}"/>
               </a:ext>
             </a:extLst>
           </p:cNvPr>
@@ -10742,7 +11301,7 @@
                   <a:srgbClr val="6F6C76"/>
                 </a:solidFill>
               </a:rPr>
-              <a:t>一个持续学习目标及其当前状态。</a:t>
+              <a:t>一个持续学习目标及其当前生命周期状态；Archive 与 Permanent Deletion 分开。</a:t>
             </a:r>
           </a:p>
         </p:txBody>
@@ -10752,7 +11311,7 @@
           <p:cNvPr id="6" name="">
             <a:extLst xmlns:a="http://schemas.openxmlformats.org/drawingml/2006/main">
               <a:ext uri="{FF2B5EF4-FFF2-40B4-BE49-F238E27FC236}">
-                <a16:creationId xmlns:a16="http://schemas.microsoft.com/office/drawing/2014/main" id="{32765040-6039-40DE-A67B-811A363875F8}"/>
+                <a16:creationId xmlns:a16="http://schemas.microsoft.com/office/drawing/2014/main" id="{A9CD2AD7-B4B1-45F7-BBE9-70157C8805EB}"/>
               </a:ext>
             </a:extLst>
           </p:cNvPr>
@@ -10802,7 +11361,7 @@
           <p:cNvPr id="7" name="">
             <a:extLst xmlns:a="http://schemas.openxmlformats.org/drawingml/2006/main">
               <a:ext uri="{FF2B5EF4-FFF2-40B4-BE49-F238E27FC236}">
-                <a16:creationId xmlns:a16="http://schemas.microsoft.com/office/drawing/2014/main" id="{FC0C69DC-229F-462C-A3A0-B99B0C0EB6CB}"/>
+                <a16:creationId xmlns:a16="http://schemas.microsoft.com/office/drawing/2014/main" id="{B867D2F5-370F-4F24-914B-DB38E56457CB}"/>
               </a:ext>
             </a:extLst>
           </p:cNvPr>
@@ -10852,7 +11411,7 @@
           <p:cNvPr id="8" name="">
             <a:extLst xmlns:a="http://schemas.openxmlformats.org/drawingml/2006/main">
               <a:ext uri="{FF2B5EF4-FFF2-40B4-BE49-F238E27FC236}">
-                <a16:creationId xmlns:a16="http://schemas.microsoft.com/office/drawing/2014/main" id="{5504F7BF-CB25-4764-8999-CF81F55EEEF8}"/>
+                <a16:creationId xmlns:a16="http://schemas.microsoft.com/office/drawing/2014/main" id="{D7CD3886-777F-44FB-BD5B-BA929A1A573D}"/>
               </a:ext>
             </a:extLst>
           </p:cNvPr>
@@ -10892,7 +11451,7 @@
                   <a:srgbClr val="6F6C76"/>
                 </a:solidFill>
               </a:rPr>
-              <a:t>下一次打开 App 时可以直接执行的具体动作。</a:t>
+              <a:t>下一次打开 iPhone 或 Web Workspace 时可以直接执行的具体动作。</a:t>
             </a:r>
           </a:p>
         </p:txBody>
@@ -10902,7 +11461,7 @@
           <p:cNvPr id="9" name="">
             <a:extLst xmlns:a="http://schemas.openxmlformats.org/drawingml/2006/main">
               <a:ext uri="{FF2B5EF4-FFF2-40B4-BE49-F238E27FC236}">
-                <a16:creationId xmlns:a16="http://schemas.microsoft.com/office/drawing/2014/main" id="{8B2A5961-BA9E-4329-9A35-4665A256777A}"/>
+                <a16:creationId xmlns:a16="http://schemas.microsoft.com/office/drawing/2014/main" id="{4F9AB1C1-1E95-4659-A32C-7B06FC849FCF}"/>
               </a:ext>
             </a:extLst>
           </p:cNvPr>
@@ -10952,7 +11511,7 @@
           <p:cNvPr id="10" name="">
             <a:extLst xmlns:a="http://schemas.openxmlformats.org/drawingml/2006/main">
               <a:ext uri="{FF2B5EF4-FFF2-40B4-BE49-F238E27FC236}">
-                <a16:creationId xmlns:a16="http://schemas.microsoft.com/office/drawing/2014/main" id="{AE025343-7416-4894-8FE0-0B1DB5C625F4}"/>
+                <a16:creationId xmlns:a16="http://schemas.microsoft.com/office/drawing/2014/main" id="{49B16CCF-B286-40F1-82CE-C58DD6264196}"/>
               </a:ext>
             </a:extLst>
           </p:cNvPr>
@@ -11002,7 +11561,7 @@
           <p:cNvPr id="11" name="">
             <a:extLst xmlns:a="http://schemas.openxmlformats.org/drawingml/2006/main">
               <a:ext uri="{FF2B5EF4-FFF2-40B4-BE49-F238E27FC236}">
-                <a16:creationId xmlns:a16="http://schemas.microsoft.com/office/drawing/2014/main" id="{BEEF4AD8-7EF4-43AD-AEC1-58EB4BD0691C}"/>
+                <a16:creationId xmlns:a16="http://schemas.microsoft.com/office/drawing/2014/main" id="{A73BE679-8D96-4F32-A010-9F194EF28279}"/>
               </a:ext>
             </a:extLst>
           </p:cNvPr>
@@ -11042,7 +11601,7 @@
                   <a:srgbClr val="6F6C76"/>
                 </a:solidFill>
               </a:rPr>
-              <a:t>一次已发生的学习行动，由 Quick Log 或 Timer 生成。</a:t>
+              <a:t>一次已发生的学习行动，由 Quick Log、Timer 或 Guided Routine Player 生成。</a:t>
             </a:r>
           </a:p>
         </p:txBody>
@@ -11052,7 +11611,7 @@
           <p:cNvPr id="12" name="">
             <a:extLst xmlns:a="http://schemas.openxmlformats.org/drawingml/2006/main">
               <a:ext uri="{FF2B5EF4-FFF2-40B4-BE49-F238E27FC236}">
-                <a16:creationId xmlns:a16="http://schemas.microsoft.com/office/drawing/2014/main" id="{3587998B-3BBA-40D1-9323-76DD650AFD09}"/>
+                <a16:creationId xmlns:a16="http://schemas.microsoft.com/office/drawing/2014/main" id="{ED5959BF-16C1-42E8-B5DD-C51F3DC02FE6}"/>
               </a:ext>
             </a:extLst>
           </p:cNvPr>
@@ -11102,7 +11661,7 @@
           <p:cNvPr id="13" name="">
             <a:extLst xmlns:a="http://schemas.openxmlformats.org/drawingml/2006/main">
               <a:ext uri="{FF2B5EF4-FFF2-40B4-BE49-F238E27FC236}">
-                <a16:creationId xmlns:a16="http://schemas.microsoft.com/office/drawing/2014/main" id="{6CD5B2AB-385C-4C84-865A-D7ECCFD5A952}"/>
+                <a16:creationId xmlns:a16="http://schemas.microsoft.com/office/drawing/2014/main" id="{427F7271-8DA8-4BC4-9D86-8BDA520335FD}"/>
               </a:ext>
             </a:extLst>
           </p:cNvPr>
@@ -11152,7 +11711,7 @@
           <p:cNvPr id="14" name="">
             <a:extLst xmlns:a="http://schemas.openxmlformats.org/drawingml/2006/main">
               <a:ext uri="{FF2B5EF4-FFF2-40B4-BE49-F238E27FC236}">
-                <a16:creationId xmlns:a16="http://schemas.microsoft.com/office/drawing/2014/main" id="{D405232F-430F-432B-AC24-0723AC326705}"/>
+                <a16:creationId xmlns:a16="http://schemas.microsoft.com/office/drawing/2014/main" id="{39E5A5E1-A450-4D09-A395-F79EAB0CFDD7}"/>
               </a:ext>
             </a:extLst>
           </p:cNvPr>
@@ -11192,7 +11751,7 @@
                   <a:srgbClr val="6F6C76"/>
                 </a:solidFill>
               </a:rPr>
-              <a:t>带有“这证明了什么”说明的图片、录音、文件或链接。</a:t>
+              <a:t>带有“这证明了什么”说明的图片、录音、文件或链接；必要时可成为 Qualifying Proof。</a:t>
             </a:r>
           </a:p>
         </p:txBody>
@@ -11202,7 +11761,7 @@
           <p:cNvPr id="15" name="">
             <a:extLst xmlns:a="http://schemas.openxmlformats.org/drawingml/2006/main">
               <a:ext uri="{FF2B5EF4-FFF2-40B4-BE49-F238E27FC236}">
-                <a16:creationId xmlns:a16="http://schemas.microsoft.com/office/drawing/2014/main" id="{48CCC82D-F9B7-4011-BC4B-73AC31DB5222}"/>
+                <a16:creationId xmlns:a16="http://schemas.microsoft.com/office/drawing/2014/main" id="{3E7AAA45-6426-4675-9A0F-D81C379B6659}"/>
               </a:ext>
             </a:extLst>
           </p:cNvPr>
@@ -11252,7 +11811,7 @@
           <p:cNvPr id="16" name="">
             <a:extLst xmlns:a="http://schemas.openxmlformats.org/drawingml/2006/main">
               <a:ext uri="{FF2B5EF4-FFF2-40B4-BE49-F238E27FC236}">
-                <a16:creationId xmlns:a16="http://schemas.microsoft.com/office/drawing/2014/main" id="{3AD1DA1B-EA4A-4693-9B08-ECB79FC01F65}"/>
+                <a16:creationId xmlns:a16="http://schemas.microsoft.com/office/drawing/2014/main" id="{72C93353-4C7F-4A75-9C51-F4E1291A9386}"/>
               </a:ext>
             </a:extLst>
           </p:cNvPr>
@@ -11302,7 +11861,7 @@
           <p:cNvPr id="17" name="">
             <a:extLst xmlns:a="http://schemas.openxmlformats.org/drawingml/2006/main">
               <a:ext uri="{FF2B5EF4-FFF2-40B4-BE49-F238E27FC236}">
-                <a16:creationId xmlns:a16="http://schemas.microsoft.com/office/drawing/2014/main" id="{DFCCAB83-5B97-4089-8105-25E850E05AE8}"/>
+                <a16:creationId xmlns:a16="http://schemas.microsoft.com/office/drawing/2014/main" id="{62CBE712-E2BC-4C99-B385-D0DF129E2A56}"/>
               </a:ext>
             </a:extLst>
           </p:cNvPr>
@@ -11342,7 +11901,7 @@
                   <a:srgbClr val="6F6C76"/>
                 </a:solidFill>
               </a:rPr>
-              <a:t>Session、Proof、Next Step、状态和 Review 组成的项目时间线。</a:t>
+              <a:t>Session、Proof、Next Step、阶段与 Review Decision 组成的项目时间线。</a:t>
             </a:r>
           </a:p>
         </p:txBody>
@@ -11352,7 +11911,7 @@
           <p:cNvPr id="18" name="">
             <a:extLst xmlns:a="http://schemas.openxmlformats.org/drawingml/2006/main">
               <a:ext uri="{FF2B5EF4-FFF2-40B4-BE49-F238E27FC236}">
-                <a16:creationId xmlns:a16="http://schemas.microsoft.com/office/drawing/2014/main" id="{7201B355-2798-42C2-A266-7EE1EE663891}"/>
+                <a16:creationId xmlns:a16="http://schemas.microsoft.com/office/drawing/2014/main" id="{3866AC95-48FA-41D6-A1E2-5D4540474A70}"/>
               </a:ext>
             </a:extLst>
           </p:cNvPr>
@@ -11402,7 +11961,7 @@
           <p:cNvPr id="19" name="">
             <a:extLst xmlns:a="http://schemas.openxmlformats.org/drawingml/2006/main">
               <a:ext uri="{FF2B5EF4-FFF2-40B4-BE49-F238E27FC236}">
-                <a16:creationId xmlns:a16="http://schemas.microsoft.com/office/drawing/2014/main" id="{A3D8FD8C-312F-43DE-91F5-004FAE6F8646}"/>
+                <a16:creationId xmlns:a16="http://schemas.microsoft.com/office/drawing/2014/main" id="{9A7D224E-EDB6-4BB0-A5B3-8AC57AD5EE6C}"/>
               </a:ext>
             </a:extLst>
           </p:cNvPr>
@@ -11452,7 +12011,7 @@
           <p:cNvPr id="20" name="">
             <a:extLst xmlns:a="http://schemas.openxmlformats.org/drawingml/2006/main">
               <a:ext uri="{FF2B5EF4-FFF2-40B4-BE49-F238E27FC236}">
-                <a16:creationId xmlns:a16="http://schemas.microsoft.com/office/drawing/2014/main" id="{0270A887-0ED0-420F-90BC-5B852824F6F5}"/>
+                <a16:creationId xmlns:a16="http://schemas.microsoft.com/office/drawing/2014/main" id="{E4971779-CAB1-43CE-8C4B-8691FF6F6C78}"/>
               </a:ext>
             </a:extLst>
           </p:cNvPr>
@@ -11492,7 +12051,7 @@
                   <a:srgbClr val="6F6C76"/>
                 </a:solidFill>
               </a:rPr>
-              <a:t>把近期证据整理为 Facts、Patterns、Decisions 与 Next Steps 的阶段判断。</a:t>
+              <a:t>把近期证据整理为 Facts、Patterns、Decisions 与 Next Steps 的 Weekly/Stage 判断。</a:t>
             </a:r>
           </a:p>
         </p:txBody>
@@ -11502,7 +12061,7 @@
           <p:cNvPr id="21" name="">
             <a:extLst xmlns:a="http://schemas.openxmlformats.org/drawingml/2006/main">
               <a:ext uri="{FF2B5EF4-FFF2-40B4-BE49-F238E27FC236}">
-                <a16:creationId xmlns:a16="http://schemas.microsoft.com/office/drawing/2014/main" id="{F7066944-C766-4684-8B8D-070FCCEE7CBB}"/>
+                <a16:creationId xmlns:a16="http://schemas.microsoft.com/office/drawing/2014/main" id="{55CA48CC-5419-4DF9-9946-9094AAF594F4}"/>
               </a:ext>
             </a:extLst>
           </p:cNvPr>
@@ -11533,7 +12092,7 @@
           <p:cNvPr id="22" name="">
             <a:extLst xmlns:a="http://schemas.openxmlformats.org/drawingml/2006/main">
               <a:ext uri="{FF2B5EF4-FFF2-40B4-BE49-F238E27FC236}">
-                <a16:creationId xmlns:a16="http://schemas.microsoft.com/office/drawing/2014/main" id="{89A371C0-6DEB-4BCA-A038-70BC3349A852}"/>
+                <a16:creationId xmlns:a16="http://schemas.microsoft.com/office/drawing/2014/main" id="{FFAE848C-E009-451C-91C0-4701DCBCFAB3}"/>
               </a:ext>
             </a:extLst>
           </p:cNvPr>
@@ -11581,7 +12140,7 @@
     </p:spTree>
     <p:extLst>
       <p:ext uri="{BB962C8B-B14F-4D97-AF65-F5344CB8AC3E}">
-        <p14:creationId xmlns:p14="http://schemas.microsoft.com/office/powerpoint/2010/main" val="2133113780"/>
+        <p14:creationId xmlns:p14="http://schemas.microsoft.com/office/powerpoint/2010/main" val="1008800093"/>
       </p:ext>
     </p:extLst>
   </p:cSld>
@@ -11609,10 +12168,10 @@
       </p:grpSpPr>
       <p:sp>
         <p:nvSpPr>
-          <p:cNvPr id="1" name="">
-            <a:extLst xmlns:a="http://schemas.openxmlformats.org/drawingml/2006/main">
-              <a:ext uri="{FF2B5EF4-FFF2-40B4-BE49-F238E27FC236}">
-                <a16:creationId xmlns:a16="http://schemas.microsoft.com/office/drawing/2014/main" id="{8960D446-AAD3-45F8-9F71-F793EC7FC93B}"/>
+          <p:cNvPr id="7" name="">
+            <a:extLst xmlns:a="http://schemas.openxmlformats.org/drawingml/2006/main">
+              <a:ext uri="{FF2B5EF4-FFF2-40B4-BE49-F238E27FC236}">
+                <a16:creationId xmlns:a16="http://schemas.microsoft.com/office/drawing/2014/main" id="{78A26E83-A65B-4875-BE8B-603F28C5B995}"/>
               </a:ext>
             </a:extLst>
           </p:cNvPr>
@@ -11662,7 +12221,7 @@
           <p:cNvPr id="2" name="wide-title-6">
             <a:extLst xmlns:a="http://schemas.openxmlformats.org/drawingml/2006/main">
               <a:ext uri="{FF2B5EF4-FFF2-40B4-BE49-F238E27FC236}">
-                <a16:creationId xmlns:a16="http://schemas.microsoft.com/office/drawing/2014/main" id="{DCB8D485-A11A-496A-B7C8-AF5ADD4CACB3}"/>
+                <a16:creationId xmlns:a16="http://schemas.microsoft.com/office/drawing/2014/main" id="{DB8A1145-18D9-4DFB-A575-2C483826D63C}"/>
               </a:ext>
             </a:extLst>
           </p:cNvPr>
@@ -11702,7 +12261,7 @@
                   <a:srgbClr val="25242B"/>
                 </a:solidFill>
               </a:rPr>
-              <a:t>三个主入口覆盖完整 v0.1 路径</a:t>
+              <a:t>iPhone 与 Web 覆盖完整 v0.1 路径</a:t>
             </a:r>
           </a:p>
         </p:txBody>
@@ -11712,7 +12271,7 @@
           <p:cNvPr id="3" name="">
             <a:extLst xmlns:a="http://schemas.openxmlformats.org/drawingml/2006/main">
               <a:ext uri="{FF2B5EF4-FFF2-40B4-BE49-F238E27FC236}">
-                <a16:creationId xmlns:a16="http://schemas.microsoft.com/office/drawing/2014/main" id="{476F1CEC-AF07-4708-A077-0431080FB9E2}"/>
+                <a16:creationId xmlns:a16="http://schemas.microsoft.com/office/drawing/2014/main" id="{F5420E48-5B1A-49F8-BB17-19DABD8734DB}"/>
               </a:ext>
             </a:extLst>
           </p:cNvPr>
@@ -11762,7 +12321,7 @@
           <p:cNvPr id="4" name="">
             <a:extLst xmlns:a="http://schemas.openxmlformats.org/drawingml/2006/main">
               <a:ext uri="{FF2B5EF4-FFF2-40B4-BE49-F238E27FC236}">
-                <a16:creationId xmlns:a16="http://schemas.microsoft.com/office/drawing/2014/main" id="{1C755E18-2612-481F-95B1-83E5E41B164D}"/>
+                <a16:creationId xmlns:a16="http://schemas.microsoft.com/office/drawing/2014/main" id="{B0133FAB-23A0-4144-B1D2-8E7B1281FF78}"/>
               </a:ext>
             </a:extLst>
           </p:cNvPr>
@@ -11801,13 +12360,13 @@
           <p:nvPr/>
         </p:nvPicPr>
         <p:blipFill>
-          <a:blip xmlns:r="http://schemas.openxmlformats.org/officeDocument/2006/relationships" xmlns:a="http://schemas.openxmlformats.org/drawingml/2006/main" r:embed="R5f0e9d54433a47d1"/>
+          <a:blip xmlns:r="http://schemas.openxmlformats.org/officeDocument/2006/relationships" xmlns:a="http://schemas.openxmlformats.org/drawingml/2006/main" r:embed="R02a3b2c97878475d"/>
           <a:stretch xmlns:a="http://schemas.openxmlformats.org/drawingml/2006/main"/>
         </p:blipFill>
         <p:spPr>
           <a:xfrm xmlns:a="http://schemas.openxmlformats.org/drawingml/2006/main">
-            <a:off x="2596779" y="1695450"/>
-            <a:ext cx="6998442" cy="4000500"/>
+            <a:off x="933450" y="1982567"/>
+            <a:ext cx="10325100" cy="3426266"/>
           </a:xfrm>
           <a:prstGeom xmlns:a="http://schemas.openxmlformats.org/drawingml/2006/main" prst="rect">
             <a:avLst/>
@@ -11819,7 +12378,7 @@
           <p:cNvPr id="6" name="">
             <a:extLst xmlns:a="http://schemas.openxmlformats.org/drawingml/2006/main">
               <a:ext uri="{FF2B5EF4-FFF2-40B4-BE49-F238E27FC236}">
-                <a16:creationId xmlns:a16="http://schemas.microsoft.com/office/drawing/2014/main" id="{3D429AAD-01CD-4A71-A699-69200FCA2F9B}"/>
+                <a16:creationId xmlns:a16="http://schemas.microsoft.com/office/drawing/2014/main" id="{52DA00AB-56A0-496C-9346-C8A24AAD3F6C}"/>
               </a:ext>
             </a:extLst>
           </p:cNvPr>
@@ -11859,7 +12418,7 @@
                   <a:srgbClr val="6F6C76"/>
                 </a:solidFill>
               </a:rPr>
-              <a:t>AI Review Settings 是条件性入口；Calendar、Course Plan 和 Cloud Sync 不在当前导航。</a:t>
+              <a:t>iPhone 负责现场执行；Web Demo/Real Workspace 负责规划、审阅和受 guard 保护的写入。</a:t>
             </a:r>
           </a:p>
         </p:txBody>
@@ -11867,7 +12426,7 @@
     </p:spTree>
     <p:extLst>
       <p:ext uri="{BB962C8B-B14F-4D97-AF65-F5344CB8AC3E}">
-        <p14:creationId xmlns:p14="http://schemas.microsoft.com/office/powerpoint/2010/main" val="1668818732"/>
+        <p14:creationId xmlns:p14="http://schemas.microsoft.com/office/powerpoint/2010/main" val="144442088"/>
       </p:ext>
     </p:extLst>
   </p:cSld>
@@ -11895,10 +12454,10 @@
       </p:grpSpPr>
       <p:sp>
         <p:nvSpPr>
-          <p:cNvPr id="1" name="">
-            <a:extLst xmlns:a="http://schemas.openxmlformats.org/drawingml/2006/main">
-              <a:ext uri="{FF2B5EF4-FFF2-40B4-BE49-F238E27FC236}">
-                <a16:creationId xmlns:a16="http://schemas.microsoft.com/office/drawing/2014/main" id="{E63C86B2-D1E9-4879-955E-ABC801149933}"/>
+          <p:cNvPr id="7" name="">
+            <a:extLst xmlns:a="http://schemas.openxmlformats.org/drawingml/2006/main">
+              <a:ext uri="{FF2B5EF4-FFF2-40B4-BE49-F238E27FC236}">
+                <a16:creationId xmlns:a16="http://schemas.microsoft.com/office/drawing/2014/main" id="{3D4E4824-F7B1-45CE-AB3A-828C321DA6A8}"/>
               </a:ext>
             </a:extLst>
           </p:cNvPr>
@@ -11948,7 +12507,7 @@
           <p:cNvPr id="2" name="wide-title-7">
             <a:extLst xmlns:a="http://schemas.openxmlformats.org/drawingml/2006/main">
               <a:ext uri="{FF2B5EF4-FFF2-40B4-BE49-F238E27FC236}">
-                <a16:creationId xmlns:a16="http://schemas.microsoft.com/office/drawing/2014/main" id="{F23238D9-D13C-44C1-87BA-E498C9133114}"/>
+                <a16:creationId xmlns:a16="http://schemas.microsoft.com/office/drawing/2014/main" id="{D70606B9-7468-4962-AA5B-14197C73055D}"/>
               </a:ext>
             </a:extLst>
           </p:cNvPr>
@@ -11988,7 +12547,7 @@
                   <a:srgbClr val="25242B"/>
                 </a:solidFill>
               </a:rPr>
-              <a:t>本地优先不等于封闭：数据和 AI 都有边界</a:t>
+              <a:t>本地规则与跨端边界都保持可见</a:t>
             </a:r>
           </a:p>
         </p:txBody>
@@ -11998,7 +12557,7 @@
           <p:cNvPr id="3" name="">
             <a:extLst xmlns:a="http://schemas.openxmlformats.org/drawingml/2006/main">
               <a:ext uri="{FF2B5EF4-FFF2-40B4-BE49-F238E27FC236}">
-                <a16:creationId xmlns:a16="http://schemas.microsoft.com/office/drawing/2014/main" id="{5EA1A738-691C-49E0-8994-FB968E9C6962}"/>
+                <a16:creationId xmlns:a16="http://schemas.microsoft.com/office/drawing/2014/main" id="{F17F63BC-2307-4082-83DD-3BE2FCD140EC}"/>
               </a:ext>
             </a:extLst>
           </p:cNvPr>
@@ -12048,7 +12607,7 @@
           <p:cNvPr id="4" name="">
             <a:extLst xmlns:a="http://schemas.openxmlformats.org/drawingml/2006/main">
               <a:ext uri="{FF2B5EF4-FFF2-40B4-BE49-F238E27FC236}">
-                <a16:creationId xmlns:a16="http://schemas.microsoft.com/office/drawing/2014/main" id="{0CC159DA-49E9-40BA-9214-EDDF474274B0}"/>
+                <a16:creationId xmlns:a16="http://schemas.microsoft.com/office/drawing/2014/main" id="{59982558-E608-4592-90F6-8EDB500BF3A4}"/>
               </a:ext>
             </a:extLst>
           </p:cNvPr>
@@ -12087,13 +12646,13 @@
           <p:nvPr/>
         </p:nvPicPr>
         <p:blipFill>
-          <a:blip xmlns:r="http://schemas.openxmlformats.org/officeDocument/2006/relationships" xmlns:a="http://schemas.openxmlformats.org/drawingml/2006/main" r:embed="Rec9636e86d9a46c0"/>
+          <a:blip xmlns:r="http://schemas.openxmlformats.org/officeDocument/2006/relationships" xmlns:a="http://schemas.openxmlformats.org/drawingml/2006/main" r:embed="R5027a3d26f154fc0"/>
           <a:stretch xmlns:a="http://schemas.openxmlformats.org/drawingml/2006/main"/>
         </p:blipFill>
         <p:spPr>
           <a:xfrm xmlns:a="http://schemas.openxmlformats.org/drawingml/2006/main">
-            <a:off x="2861799" y="1695450"/>
-            <a:ext cx="6468401" cy="4000500"/>
+            <a:off x="933450" y="2017292"/>
+            <a:ext cx="10325100" cy="3356815"/>
           </a:xfrm>
           <a:prstGeom xmlns:a="http://schemas.openxmlformats.org/drawingml/2006/main" prst="rect">
             <a:avLst/>
@@ -12105,7 +12664,7 @@
           <p:cNvPr id="6" name="">
             <a:extLst xmlns:a="http://schemas.openxmlformats.org/drawingml/2006/main">
               <a:ext uri="{FF2B5EF4-FFF2-40B4-BE49-F238E27FC236}">
-                <a16:creationId xmlns:a16="http://schemas.microsoft.com/office/drawing/2014/main" id="{AEA6C48B-2491-4B64-9ACA-4B8DEF16DAF5}"/>
+                <a16:creationId xmlns:a16="http://schemas.microsoft.com/office/drawing/2014/main" id="{02E7F996-67DE-4A20-8372-D7FF4C5FC15F}"/>
               </a:ext>
             </a:extLst>
           </p:cNvPr>
@@ -12145,7 +12704,7 @@
                   <a:srgbClr val="6F6C76"/>
                 </a:solidFill>
               </a:rPr>
-              <a:t>SwiftData 失败时降级到 JSON Store；Export 读取内存 Snapshot，不直接访问数据库。</a:t>
+              <a:t>SwiftData/JSON Store、CloudKit private zone、Web draft storage 与 Support/AI 边界彼此分开。</a:t>
             </a:r>
           </a:p>
         </p:txBody>
@@ -12153,7 +12712,7 @@
     </p:spTree>
     <p:extLst>
       <p:ext uri="{BB962C8B-B14F-4D97-AF65-F5344CB8AC3E}">
-        <p14:creationId xmlns:p14="http://schemas.microsoft.com/office/powerpoint/2010/main" val="301335323"/>
+        <p14:creationId xmlns:p14="http://schemas.microsoft.com/office/powerpoint/2010/main" val="868626958"/>
       </p:ext>
     </p:extLst>
   </p:cSld>
@@ -12181,10 +12740,10 @@
       </p:grpSpPr>
       <p:sp>
         <p:nvSpPr>
-          <p:cNvPr id="1" name="">
-            <a:extLst xmlns:a="http://schemas.openxmlformats.org/drawingml/2006/main">
-              <a:ext uri="{FF2B5EF4-FFF2-40B4-BE49-F238E27FC236}">
-                <a16:creationId xmlns:a16="http://schemas.microsoft.com/office/drawing/2014/main" id="{0AF2F07E-18D5-452A-805E-76E79A8A6B04}"/>
+          <p:cNvPr id="7" name="">
+            <a:extLst xmlns:a="http://schemas.openxmlformats.org/drawingml/2006/main">
+              <a:ext uri="{FF2B5EF4-FFF2-40B4-BE49-F238E27FC236}">
+                <a16:creationId xmlns:a16="http://schemas.microsoft.com/office/drawing/2014/main" id="{BB4629A8-3D34-468C-BBFB-3A4F38CCA451}"/>
               </a:ext>
             </a:extLst>
           </p:cNvPr>
@@ -12234,7 +12793,7 @@
           <p:cNvPr id="2" name="wide-title-8">
             <a:extLst xmlns:a="http://schemas.openxmlformats.org/drawingml/2006/main">
               <a:ext uri="{FF2B5EF4-FFF2-40B4-BE49-F238E27FC236}">
-                <a16:creationId xmlns:a16="http://schemas.microsoft.com/office/drawing/2014/main" id="{026AE58B-6CBE-448B-A4FC-2C0E67932CE1}"/>
+                <a16:creationId xmlns:a16="http://schemas.microsoft.com/office/drawing/2014/main" id="{B7AA5EF7-5111-43F1-ADD5-8045618A7F0B}"/>
               </a:ext>
             </a:extLst>
           </p:cNvPr>
@@ -12284,7 +12843,7 @@
           <p:cNvPr id="3" name="">
             <a:extLst xmlns:a="http://schemas.openxmlformats.org/drawingml/2006/main">
               <a:ext uri="{FF2B5EF4-FFF2-40B4-BE49-F238E27FC236}">
-                <a16:creationId xmlns:a16="http://schemas.microsoft.com/office/drawing/2014/main" id="{9CC607F8-2E09-42B1-884B-082CF93031EE}"/>
+                <a16:creationId xmlns:a16="http://schemas.microsoft.com/office/drawing/2014/main" id="{26AD15A6-D640-4A02-AD13-CC9D0E99A881}"/>
               </a:ext>
             </a:extLst>
           </p:cNvPr>
@@ -12334,7 +12893,7 @@
           <p:cNvPr id="4" name="">
             <a:extLst xmlns:a="http://schemas.openxmlformats.org/drawingml/2006/main">
               <a:ext uri="{FF2B5EF4-FFF2-40B4-BE49-F238E27FC236}">
-                <a16:creationId xmlns:a16="http://schemas.microsoft.com/office/drawing/2014/main" id="{3C1268E2-731A-4E23-B056-ABDB22438A66}"/>
+                <a16:creationId xmlns:a16="http://schemas.microsoft.com/office/drawing/2014/main" id="{1A41AFC1-0F43-442B-8092-3539B2D0BD73}"/>
               </a:ext>
             </a:extLst>
           </p:cNvPr>
@@ -12373,13 +12932,13 @@
           <p:nvPr/>
         </p:nvPicPr>
         <p:blipFill>
-          <a:blip xmlns:r="http://schemas.openxmlformats.org/officeDocument/2006/relationships" xmlns:a="http://schemas.openxmlformats.org/drawingml/2006/main" r:embed="Rf56e45baf8b8404a"/>
+          <a:blip xmlns:r="http://schemas.openxmlformats.org/officeDocument/2006/relationships" xmlns:a="http://schemas.openxmlformats.org/drawingml/2006/main" r:embed="R19b7794006b34034"/>
           <a:stretch xmlns:a="http://schemas.openxmlformats.org/drawingml/2006/main"/>
         </p:blipFill>
         <p:spPr>
           <a:xfrm xmlns:a="http://schemas.openxmlformats.org/drawingml/2006/main">
-            <a:off x="5217841" y="1695450"/>
-            <a:ext cx="1756317" cy="4000500"/>
+            <a:off x="5298188" y="1695450"/>
+            <a:ext cx="1595625" cy="4000500"/>
           </a:xfrm>
           <a:prstGeom xmlns:a="http://schemas.openxmlformats.org/drawingml/2006/main" prst="rect">
             <a:avLst/>
@@ -12391,7 +12950,7 @@
           <p:cNvPr id="6" name="">
             <a:extLst xmlns:a="http://schemas.openxmlformats.org/drawingml/2006/main">
               <a:ext uri="{FF2B5EF4-FFF2-40B4-BE49-F238E27FC236}">
-                <a16:creationId xmlns:a16="http://schemas.microsoft.com/office/drawing/2014/main" id="{ABE131A7-8CD4-4A68-A192-399D8244985B}"/>
+                <a16:creationId xmlns:a16="http://schemas.microsoft.com/office/drawing/2014/main" id="{58306456-5E95-4EE1-B9B3-D4300E11A04D}"/>
               </a:ext>
             </a:extLst>
           </p:cNvPr>
@@ -12439,7 +12998,7 @@
     </p:spTree>
     <p:extLst>
       <p:ext uri="{BB962C8B-B14F-4D97-AF65-F5344CB8AC3E}">
-        <p14:creationId xmlns:p14="http://schemas.microsoft.com/office/powerpoint/2010/main" val="2052449552"/>
+        <p14:creationId xmlns:p14="http://schemas.microsoft.com/office/powerpoint/2010/main" val="718532386"/>
       </p:ext>
     </p:extLst>
   </p:cSld>
@@ -12467,10 +13026,10 @@
       </p:grpSpPr>
       <p:sp>
         <p:nvSpPr>
-          <p:cNvPr id="1" name="">
-            <a:extLst xmlns:a="http://schemas.openxmlformats.org/drawingml/2006/main">
-              <a:ext uri="{FF2B5EF4-FFF2-40B4-BE49-F238E27FC236}">
-                <a16:creationId xmlns:a16="http://schemas.microsoft.com/office/drawing/2014/main" id="{08F79C84-EAAA-4C90-A453-9AB238C19218}"/>
+          <p:cNvPr id="14" name="">
+            <a:extLst xmlns:a="http://schemas.openxmlformats.org/drawingml/2006/main">
+              <a:ext uri="{FF2B5EF4-FFF2-40B4-BE49-F238E27FC236}">
+                <a16:creationId xmlns:a16="http://schemas.microsoft.com/office/drawing/2014/main" id="{995E530A-0254-4D5F-891D-1023F133ED8D}"/>
               </a:ext>
             </a:extLst>
           </p:cNvPr>
@@ -12520,7 +13079,7 @@
           <p:cNvPr id="2" name="wide-title-9">
             <a:extLst xmlns:a="http://schemas.openxmlformats.org/drawingml/2006/main">
               <a:ext uri="{FF2B5EF4-FFF2-40B4-BE49-F238E27FC236}">
-                <a16:creationId xmlns:a16="http://schemas.microsoft.com/office/drawing/2014/main" id="{C7E6A8EC-7D65-4B25-B914-FE883902BD49}"/>
+                <a16:creationId xmlns:a16="http://schemas.microsoft.com/office/drawing/2014/main" id="{43692C3A-F1A6-4344-BA54-1AEED4D354F1}"/>
               </a:ext>
             </a:extLst>
           </p:cNvPr>
@@ -12570,7 +13129,7 @@
           <p:cNvPr id="3" name="">
             <a:extLst xmlns:a="http://schemas.openxmlformats.org/drawingml/2006/main">
               <a:ext uri="{FF2B5EF4-FFF2-40B4-BE49-F238E27FC236}">
-                <a16:creationId xmlns:a16="http://schemas.microsoft.com/office/drawing/2014/main" id="{AA47B3EE-0FB0-494A-B41A-F653C31159E6}"/>
+                <a16:creationId xmlns:a16="http://schemas.microsoft.com/office/drawing/2014/main" id="{6539A8CC-A93E-47C0-B2CA-20202DDE5116}"/>
               </a:ext>
             </a:extLst>
           </p:cNvPr>
@@ -12620,7 +13179,7 @@
           <p:cNvPr id="4" name="">
             <a:extLst xmlns:a="http://schemas.openxmlformats.org/drawingml/2006/main">
               <a:ext uri="{FF2B5EF4-FFF2-40B4-BE49-F238E27FC236}">
-                <a16:creationId xmlns:a16="http://schemas.microsoft.com/office/drawing/2014/main" id="{262EE279-BA77-4F47-8D59-562894510A4F}"/>
+                <a16:creationId xmlns:a16="http://schemas.microsoft.com/office/drawing/2014/main" id="{50D851C4-E090-442F-B395-469F6410B906}"/>
               </a:ext>
             </a:extLst>
           </p:cNvPr>
@@ -12659,7 +13218,7 @@
           <p:nvPr/>
         </p:nvPicPr>
         <p:blipFill>
-          <a:blip xmlns:r="http://schemas.openxmlformats.org/officeDocument/2006/relationships" xmlns:a="http://schemas.openxmlformats.org/drawingml/2006/main" r:embed="R0bbfff5a1bfc4aee"/>
+          <a:blip xmlns:r="http://schemas.openxmlformats.org/officeDocument/2006/relationships" xmlns:a="http://schemas.openxmlformats.org/drawingml/2006/main" r:embed="R13b17196a80a422a"/>
           <a:stretch xmlns:a="http://schemas.openxmlformats.org/drawingml/2006/main"/>
         </p:blipFill>
         <p:spPr>
@@ -12679,7 +13238,7 @@
           <p:cNvPr id="6" name="">
             <a:extLst xmlns:a="http://schemas.openxmlformats.org/drawingml/2006/main">
               <a:ext uri="{FF2B5EF4-FFF2-40B4-BE49-F238E27FC236}">
-                <a16:creationId xmlns:a16="http://schemas.microsoft.com/office/drawing/2014/main" id="{FC95F602-D149-4BC9-A1E8-AB8A1FDC2007}"/>
+                <a16:creationId xmlns:a16="http://schemas.microsoft.com/office/drawing/2014/main" id="{337177E0-C7FB-4D7D-902E-CE9FA16A7805}"/>
               </a:ext>
             </a:extLst>
           </p:cNvPr>
@@ -12710,7 +13269,7 @@
           <p:cNvPr id="7" name="">
             <a:extLst xmlns:a="http://schemas.openxmlformats.org/drawingml/2006/main">
               <a:ext uri="{FF2B5EF4-FFF2-40B4-BE49-F238E27FC236}">
-                <a16:creationId xmlns:a16="http://schemas.microsoft.com/office/drawing/2014/main" id="{569E2063-EA8E-4126-92AD-1D7263D027CE}"/>
+                <a16:creationId xmlns:a16="http://schemas.microsoft.com/office/drawing/2014/main" id="{C6F48A06-35BD-4474-85B8-52BBBCCEA97A}"/>
               </a:ext>
             </a:extLst>
           </p:cNvPr>
@@ -12760,7 +13319,7 @@
           <p:cNvPr id="8" name="">
             <a:extLst xmlns:a="http://schemas.openxmlformats.org/drawingml/2006/main">
               <a:ext uri="{FF2B5EF4-FFF2-40B4-BE49-F238E27FC236}">
-                <a16:creationId xmlns:a16="http://schemas.microsoft.com/office/drawing/2014/main" id="{209E79F5-8E36-4A81-9FC4-2087D8E5474E}"/>
+                <a16:creationId xmlns:a16="http://schemas.microsoft.com/office/drawing/2014/main" id="{39D2F916-5FF6-4769-A48D-377462EA4100}"/>
               </a:ext>
             </a:extLst>
           </p:cNvPr>
@@ -12793,7 +13352,7 @@
           <p:cNvPr id="9" name="">
             <a:extLst xmlns:a="http://schemas.openxmlformats.org/drawingml/2006/main">
               <a:ext uri="{FF2B5EF4-FFF2-40B4-BE49-F238E27FC236}">
-                <a16:creationId xmlns:a16="http://schemas.microsoft.com/office/drawing/2014/main" id="{72D8CD4C-D768-4CEE-9143-EB546D1F85BB}"/>
+                <a16:creationId xmlns:a16="http://schemas.microsoft.com/office/drawing/2014/main" id="{7DD83F65-1CE5-46D5-9433-92E0D0D1E594}"/>
               </a:ext>
             </a:extLst>
           </p:cNvPr>
@@ -12843,7 +13402,7 @@
           <p:cNvPr id="10" name="">
             <a:extLst xmlns:a="http://schemas.openxmlformats.org/drawingml/2006/main">
               <a:ext uri="{FF2B5EF4-FFF2-40B4-BE49-F238E27FC236}">
-                <a16:creationId xmlns:a16="http://schemas.microsoft.com/office/drawing/2014/main" id="{37F4B386-0209-42C5-9068-316288658A4C}"/>
+                <a16:creationId xmlns:a16="http://schemas.microsoft.com/office/drawing/2014/main" id="{0B0C852D-6CD4-4441-8427-E56CDF554046}"/>
               </a:ext>
             </a:extLst>
           </p:cNvPr>
@@ -12876,7 +13435,7 @@
           <p:cNvPr id="11" name="">
             <a:extLst xmlns:a="http://schemas.openxmlformats.org/drawingml/2006/main">
               <a:ext uri="{FF2B5EF4-FFF2-40B4-BE49-F238E27FC236}">
-                <a16:creationId xmlns:a16="http://schemas.microsoft.com/office/drawing/2014/main" id="{3F6240E1-9E88-49ED-8A3D-63D95B2E9E33}"/>
+                <a16:creationId xmlns:a16="http://schemas.microsoft.com/office/drawing/2014/main" id="{1CD4FA42-D0E8-4FAD-959E-566FB3D5105A}"/>
               </a:ext>
             </a:extLst>
           </p:cNvPr>
@@ -12926,7 +13485,7 @@
           <p:cNvPr id="12" name="">
             <a:extLst xmlns:a="http://schemas.openxmlformats.org/drawingml/2006/main">
               <a:ext uri="{FF2B5EF4-FFF2-40B4-BE49-F238E27FC236}">
-                <a16:creationId xmlns:a16="http://schemas.microsoft.com/office/drawing/2014/main" id="{9EFCBFA1-890C-46B3-9EA8-8D41CC1F68C9}"/>
+                <a16:creationId xmlns:a16="http://schemas.microsoft.com/office/drawing/2014/main" id="{74E04FEA-A759-4493-A2FA-51244A3DB062}"/>
               </a:ext>
             </a:extLst>
           </p:cNvPr>
@@ -12959,7 +13518,7 @@
           <p:cNvPr id="13" name="">
             <a:extLst xmlns:a="http://schemas.openxmlformats.org/drawingml/2006/main">
               <a:ext uri="{FF2B5EF4-FFF2-40B4-BE49-F238E27FC236}">
-                <a16:creationId xmlns:a16="http://schemas.microsoft.com/office/drawing/2014/main" id="{64B35EF4-FBFF-4F4C-AA69-DF0A21AB1B57}"/>
+                <a16:creationId xmlns:a16="http://schemas.microsoft.com/office/drawing/2014/main" id="{42D6BE52-1CA9-4518-85BD-35817788AA45}"/>
               </a:ext>
             </a:extLst>
           </p:cNvPr>
@@ -13007,7 +13566,7 @@
     </p:spTree>
     <p:extLst>
       <p:ext uri="{BB962C8B-B14F-4D97-AF65-F5344CB8AC3E}">
-        <p14:creationId xmlns:p14="http://schemas.microsoft.com/office/powerpoint/2010/main" val="57006033"/>
+        <p14:creationId xmlns:p14="http://schemas.microsoft.com/office/powerpoint/2010/main" val="1256496807"/>
       </p:ext>
     </p:extLst>
   </p:cSld>

</xml_diff>